<commit_message>
Final results: DistilBERT, Gemma-3-12B, false alarm rate, final paper and slides
- DistilBERT leave-one-corpus-out on CPU (128 tokens), resumable per fold
- Gemma-3-12B complete after retrying rate-limited calls (1 of 19,200 calls unanswered)
- False alarm rate added to the main table: Qwen-2.5-7B 3%, Gemma-3-12B 25%
- Paper, both decks, notebook and research log regenerated from the final CSVs

Co-Authored-By: Claude Opus 5 (1M context) <noreply@anthropic.com>
</commit_message>
<xml_diff>
--- a/final-slides/final_deck.pptx
+++ b/final-slides/final_deck.pptx
@@ -1904,7 +1904,7 @@
           <a:p>
             <a:r>
               <a:rPr lang="en-US" dirty="0"/>
-              <a:t>60 sec. Read only the top row, the TF-IDF row and the worst LLM. Point at the cost column.</a:t>
+              <a:t>60 sec. Read the highlighted Qwen row, then Gemma (best on AI phishing, but 25% false alarms), then DistilBERT (best in-corpus, worst on AI phishing). Point at the cost column.</a:t>
             </a:r>
             <a:endParaRPr lang="en-US" dirty="0"/>
           </a:p>
@@ -1992,7 +1992,7 @@
           <a:p>
             <a:r>
               <a:rPr lang="en-US" dirty="0"/>
-              <a:t>50 sec. Three takeaways, one sentence each. Point at the top left of the plot: high F1, low cost.</a:t>
+              <a:t>60 sec. Four points, one sentence each. Spend the time on 2 and 3. Mention Phi-4 only if asked: it ignored the one-word format in a third of emails.</a:t>
             </a:r>
             <a:endParaRPr lang="en-US" dirty="0"/>
           </a:p>
@@ -2932,7 +2932,7 @@
                 <a:ea typeface="Calibri" pitchFamily="34" charset="-122"/>
                 <a:cs typeface="Calibri" pitchFamily="34" charset="-120"/>
               </a:rPr>
-              <a:t>300 emails per test set keeps the cost low. The 95% intervals are about ±0.02 to ±0.03.</a:t>
+              <a:t>300 emails per test set keeps the cost low. The 95% intervals are about ±0.01 to ±0.03.</a:t>
             </a:r>
             <a:endParaRPr lang="en-US" sz="1500" dirty="0"/>
           </a:p>
@@ -3585,7 +3585,7 @@
                 <a:ea typeface="Calibri" pitchFamily="34" charset="-122"/>
                 <a:cs typeface="Calibri" pitchFamily="34" charset="-120"/>
               </a:rPr>
-              <a:t>Get a HuggingFace token, run it locally on the same 2,700 emails. It is the model that fell from 97.5% to 70%.</a:t>
+              <a:t>Get a HuggingFace token, run it locally on the same 2,400 emails. It is the model that fell from 97.5% to 70%.</a:t>
             </a:r>
             <a:endParaRPr lang="en-US" sz="1100" dirty="0"/>
           </a:p>
@@ -7081,7 +7081,7 @@
                           <a:ea typeface="Calibri" pitchFamily="34" charset="-122"/>
                           <a:cs typeface="Calibri" pitchFamily="34" charset="-120"/>
                         </a:rPr>
-                        <a:t>Real cost of every one of 16,200 LLM calls, from OpenRouter</a:t>
+                        <a:t>Real cost of every one of 19,200 LLM calls, from OpenRouter</a:t>
                       </a:r>
                       <a:endParaRPr lang="en-US" sz="1400" dirty="0">
                         <a:latin typeface="Calibri" charset="0"/>
@@ -12700,7 +12700,7 @@
                 <a:ea typeface="Calibri" pitchFamily="34" charset="-122"/>
                 <a:cs typeface="Calibri" pitchFamily="34" charset="-120"/>
               </a:rPr>
-              <a:t>1 epoch, 256 tokens, batch 16, lr 5e-5, 1,000 emails per corpus, Apple M1 GPU</a:t>
+              <a:t>1 epoch, 128 tokens, batch 16, lr 5e-5, 1,000 emails per corpus, laptop CPU</a:t>
             </a:r>
             <a:endParaRPr lang="en-US" sz="1500" dirty="0"/>
           </a:p>
@@ -12878,7 +12878,7 @@
                 <a:ea typeface="Calibri" pitchFamily="34" charset="-122"/>
                 <a:cs typeface="Calibri" pitchFamily="34" charset="-120"/>
               </a:rPr>
-              <a:t>Seed 42 everywhere. 8 GB MacBook. Total API spend $0.41</a:t>
+              <a:t>Seed 42 everywhere. 8 GB MacBook. Total API spend $0.52</a:t>
             </a:r>
             <a:endParaRPr lang="en-US" sz="1500" dirty="0"/>
           </a:p>
@@ -13566,7 +13566,7 @@
                 <a:ea typeface="Calibri" pitchFamily="34" charset="-122"/>
                 <a:cs typeface="Calibri" pitchFamily="34" charset="-120"/>
               </a:rPr>
-              <a:t>Why exact matching fails: Kaggle deletes line breaks and glues words ("cream?Isn't"). We verified 400 matches by brute force.</a:t>
+              <a:t>Why exact matching fails: Kaggle deletes line breaks and glues words ("cream?Isn't"). We checked 400 of them by brute force: the matches are real.</a:t>
             </a:r>
             <a:endParaRPr lang="en-US" sz="1250" dirty="0"/>
           </a:p>
@@ -16617,14 +16617,15 @@
             <a:tbl>
               <a:tblPr/>
               <a:tblGrid>
-                <a:gridCol w="2651760"/>
-                <a:gridCol w="2560320"/>
+                <a:gridCol w="2377440"/>
+                <a:gridCol w="2377440"/>
+                <a:gridCol w="1188720"/>
+                <a:gridCol w="1188720"/>
                 <a:gridCol w="1371600"/>
-                <a:gridCol w="1554480"/>
-                <a:gridCol w="1554480"/>
                 <a:gridCol w="1371600"/>
+                <a:gridCol w="1188720"/>
               </a:tblGrid>
-              <a:tr h="384048">
+              <a:tr h="338328">
                 <a:tc>
                   <a:txBody>
                     <a:bodyPr/>
@@ -16634,7 +16635,7 @@
                         <a:buNone/>
                       </a:pPr>
                       <a:r>
-                        <a:rPr lang="en-US" sz="1300" b="1" dirty="0">
+                        <a:rPr lang="en-US" sz="1250" b="1" dirty="0">
                           <a:solidFill>
                             <a:srgbClr val="60A5FA"/>
                           </a:solidFill>
@@ -16644,7 +16645,7 @@
                         </a:rPr>
                         <a:t>Model</a:t>
                       </a:r>
-                      <a:endParaRPr lang="en-US" sz="1300" dirty="0">
+                      <a:endParaRPr lang="en-US" sz="1250" dirty="0">
                         <a:latin typeface="Calibri" charset="0"/>
                         <a:ea typeface="Calibri" charset="0"/>
                         <a:cs typeface="Calibri" charset="0"/>
@@ -16702,7 +16703,7 @@
                         <a:buNone/>
                       </a:pPr>
                       <a:r>
-                        <a:rPr lang="en-US" sz="1300" b="1" dirty="0">
+                        <a:rPr lang="en-US" sz="1250" b="1" dirty="0">
                           <a:solidFill>
                             <a:srgbClr val="60A5FA"/>
                           </a:solidFill>
@@ -16712,7 +16713,7 @@
                         </a:rPr>
                         <a:t>Unseen-corpus F1 (95% CI)</a:t>
                       </a:r>
-                      <a:endParaRPr lang="en-US" sz="1300" dirty="0">
+                      <a:endParaRPr lang="en-US" sz="1250" dirty="0">
                         <a:latin typeface="Calibri" charset="0"/>
                         <a:ea typeface="Calibri" charset="0"/>
                         <a:cs typeface="Calibri" charset="0"/>
@@ -16770,7 +16771,7 @@
                         <a:buNone/>
                       </a:pPr>
                       <a:r>
-                        <a:rPr lang="en-US" sz="1300" b="1" dirty="0">
+                        <a:rPr lang="en-US" sz="1250" b="1" dirty="0">
                           <a:solidFill>
                             <a:srgbClr val="60A5FA"/>
                           </a:solidFill>
@@ -16780,7 +16781,7 @@
                         </a:rPr>
                         <a:t>Worst corpus</a:t>
                       </a:r>
-                      <a:endParaRPr lang="en-US" sz="1300" dirty="0">
+                      <a:endParaRPr lang="en-US" sz="1250" dirty="0">
                         <a:latin typeface="Calibri" charset="0"/>
                         <a:ea typeface="Calibri" charset="0"/>
                         <a:cs typeface="Calibri" charset="0"/>
@@ -16838,7 +16839,7 @@
                         <a:buNone/>
                       </a:pPr>
                       <a:r>
-                        <a:rPr lang="en-US" sz="1300" b="1" dirty="0">
+                        <a:rPr lang="en-US" sz="1250" b="1" dirty="0">
                           <a:solidFill>
                             <a:srgbClr val="60A5FA"/>
                           </a:solidFill>
@@ -16846,9 +16847,9 @@
                           <a:ea typeface="Calibri" pitchFamily="34" charset="-122"/>
                           <a:cs typeface="Calibri" pitchFamily="34" charset="-120"/>
                         </a:rPr>
-                        <a:t>AI phishing F1</a:t>
+                        <a:t>False alarms</a:t>
                       </a:r>
-                      <a:endParaRPr lang="en-US" sz="1300" dirty="0">
+                      <a:endParaRPr lang="en-US" sz="1250" dirty="0">
                         <a:latin typeface="Calibri" charset="0"/>
                         <a:ea typeface="Calibri" charset="0"/>
                         <a:cs typeface="Calibri" charset="0"/>
@@ -16906,7 +16907,7 @@
                         <a:buNone/>
                       </a:pPr>
                       <a:r>
-                        <a:rPr lang="en-US" sz="1300" b="1" dirty="0">
+                        <a:rPr lang="en-US" sz="1250" b="1" dirty="0">
                           <a:solidFill>
                             <a:srgbClr val="60A5FA"/>
                           </a:solidFill>
@@ -16914,9 +16915,9 @@
                           <a:ea typeface="Calibri" pitchFamily="34" charset="-122"/>
                           <a:cs typeface="Calibri" pitchFamily="34" charset="-120"/>
                         </a:rPr>
-                        <a:t>Nazario recall</a:t>
+                        <a:t>AI phishing F1</a:t>
                       </a:r>
-                      <a:endParaRPr lang="en-US" sz="1300" dirty="0">
+                      <a:endParaRPr lang="en-US" sz="1250" dirty="0">
                         <a:latin typeface="Calibri" charset="0"/>
                         <a:ea typeface="Calibri" charset="0"/>
                         <a:cs typeface="Calibri" charset="0"/>
@@ -16974,7 +16975,7 @@
                         <a:buNone/>
                       </a:pPr>
                       <a:r>
-                        <a:rPr lang="en-US" sz="1300" b="1" dirty="0">
+                        <a:rPr lang="en-US" sz="1250" b="1" dirty="0">
                           <a:solidFill>
                             <a:srgbClr val="60A5FA"/>
                           </a:solidFill>
@@ -16982,79 +16983,9 @@
                           <a:ea typeface="Calibri" pitchFamily="34" charset="-122"/>
                           <a:cs typeface="Calibri" pitchFamily="34" charset="-120"/>
                         </a:rPr>
-                        <a:t>$ / 1,000</a:t>
+                        <a:t>Nazario recall</a:t>
                       </a:r>
-                      <a:endParaRPr lang="en-US" sz="1300" dirty="0">
-                        <a:latin typeface="Calibri" charset="0"/>
-                        <a:ea typeface="Calibri" charset="0"/>
-                        <a:cs typeface="Calibri" charset="0"/>
-                      </a:endParaRPr>
-                    </a:p>
-                  </a:txBody>
-                  <a:tcPr marL="91440" marR="91440" marT="45720" marB="45720" anchor="ctr">
-                    <a:lnL w="9525" cap="flat" cmpd="sng" algn="ctr">
-                      <a:solidFill>
-                        <a:srgbClr val="2A3448"/>
-                      </a:solidFill>
-                      <a:prstDash val="solid"/>
-                      <a:round/>
-                      <a:headEnd type="none" w="med" len="med"/>
-                      <a:tailEnd type="none" w="med" len="med"/>
-                    </a:lnL>
-                    <a:lnR w="9525" cap="flat" cmpd="sng" algn="ctr">
-                      <a:solidFill>
-                        <a:srgbClr val="2A3448"/>
-                      </a:solidFill>
-                      <a:prstDash val="solid"/>
-                      <a:round/>
-                      <a:headEnd type="none" w="med" len="med"/>
-                      <a:tailEnd type="none" w="med" len="med"/>
-                    </a:lnR>
-                    <a:lnT w="9525" cap="flat" cmpd="sng" algn="ctr">
-                      <a:solidFill>
-                        <a:srgbClr val="2A3448"/>
-                      </a:solidFill>
-                      <a:prstDash val="solid"/>
-                      <a:round/>
-                      <a:headEnd type="none" w="med" len="med"/>
-                      <a:tailEnd type="none" w="med" len="med"/>
-                    </a:lnT>
-                    <a:lnB w="9525" cap="flat" cmpd="sng" algn="ctr">
-                      <a:solidFill>
-                        <a:srgbClr val="2A3448"/>
-                      </a:solidFill>
-                      <a:prstDash val="solid"/>
-                      <a:round/>
-                      <a:headEnd type="none" w="med" len="med"/>
-                      <a:tailEnd type="none" w="med" len="med"/>
-                    </a:lnB>
-                    <a:solidFill>
-                      <a:srgbClr val="0F1420"/>
-                    </a:solidFill>
-                  </a:tcPr>
-                </a:tc>
-              </a:tr>
-              <a:tr h="384048">
-                <a:tc>
-                  <a:txBody>
-                    <a:bodyPr/>
-                    <a:lstStyle/>
-                    <a:p>
-                      <a:pPr algn="ctr" indent="0" marL="0">
-                        <a:buNone/>
-                      </a:pPr>
-                      <a:r>
-                        <a:rPr lang="en-US" sz="1300" b="1" dirty="0">
-                          <a:solidFill>
-                            <a:srgbClr val="FF6B4A"/>
-                          </a:solidFill>
-                          <a:latin typeface="Calibri" pitchFamily="34" charset="0"/>
-                          <a:ea typeface="Calibri" pitchFamily="34" charset="-122"/>
-                          <a:cs typeface="Calibri" pitchFamily="34" charset="-120"/>
-                        </a:rPr>
-                        <a:t>Qwen-2.5-7B</a:t>
-                      </a:r>
-                      <a:endParaRPr lang="en-US" sz="1300" dirty="0">
+                      <a:endParaRPr lang="en-US" sz="1250" dirty="0">
                         <a:latin typeface="Calibri" charset="0"/>
                         <a:ea typeface="Calibri" charset="0"/>
                         <a:cs typeface="Calibri" charset="0"/>
@@ -17112,17 +17043,87 @@
                         <a:buNone/>
                       </a:pPr>
                       <a:r>
-                        <a:rPr lang="en-US" sz="1300" b="1" dirty="0">
+                        <a:rPr lang="en-US" sz="1250" b="1" dirty="0">
                           <a:solidFill>
-                            <a:srgbClr val="FF6B4A"/>
+                            <a:srgbClr val="60A5FA"/>
                           </a:solidFill>
                           <a:latin typeface="Calibri" pitchFamily="34" charset="0"/>
                           <a:ea typeface="Calibri" pitchFamily="34" charset="-122"/>
                           <a:cs typeface="Calibri" pitchFamily="34" charset="-120"/>
                         </a:rPr>
-                        <a:t>0.928 (0.914-0.940)</a:t>
+                        <a:t>$ / 1,000</a:t>
                       </a:r>
-                      <a:endParaRPr lang="en-US" sz="1300" dirty="0">
+                      <a:endParaRPr lang="en-US" sz="1250" dirty="0">
+                        <a:latin typeface="Calibri" charset="0"/>
+                        <a:ea typeface="Calibri" charset="0"/>
+                        <a:cs typeface="Calibri" charset="0"/>
+                      </a:endParaRPr>
+                    </a:p>
+                  </a:txBody>
+                  <a:tcPr marL="91440" marR="91440" marT="45720" marB="45720" anchor="ctr">
+                    <a:lnL w="9525" cap="flat" cmpd="sng" algn="ctr">
+                      <a:solidFill>
+                        <a:srgbClr val="2A3448"/>
+                      </a:solidFill>
+                      <a:prstDash val="solid"/>
+                      <a:round/>
+                      <a:headEnd type="none" w="med" len="med"/>
+                      <a:tailEnd type="none" w="med" len="med"/>
+                    </a:lnL>
+                    <a:lnR w="9525" cap="flat" cmpd="sng" algn="ctr">
+                      <a:solidFill>
+                        <a:srgbClr val="2A3448"/>
+                      </a:solidFill>
+                      <a:prstDash val="solid"/>
+                      <a:round/>
+                      <a:headEnd type="none" w="med" len="med"/>
+                      <a:tailEnd type="none" w="med" len="med"/>
+                    </a:lnR>
+                    <a:lnT w="9525" cap="flat" cmpd="sng" algn="ctr">
+                      <a:solidFill>
+                        <a:srgbClr val="2A3448"/>
+                      </a:solidFill>
+                      <a:prstDash val="solid"/>
+                      <a:round/>
+                      <a:headEnd type="none" w="med" len="med"/>
+                      <a:tailEnd type="none" w="med" len="med"/>
+                    </a:lnT>
+                    <a:lnB w="9525" cap="flat" cmpd="sng" algn="ctr">
+                      <a:solidFill>
+                        <a:srgbClr val="2A3448"/>
+                      </a:solidFill>
+                      <a:prstDash val="solid"/>
+                      <a:round/>
+                      <a:headEnd type="none" w="med" len="med"/>
+                      <a:tailEnd type="none" w="med" len="med"/>
+                    </a:lnB>
+                    <a:solidFill>
+                      <a:srgbClr val="0F1420"/>
+                    </a:solidFill>
+                  </a:tcPr>
+                </a:tc>
+              </a:tr>
+              <a:tr h="338328">
+                <a:tc>
+                  <a:txBody>
+                    <a:bodyPr/>
+                    <a:lstStyle/>
+                    <a:p>
+                      <a:pPr algn="ctr" indent="0" marL="0">
+                        <a:buNone/>
+                      </a:pPr>
+                      <a:r>
+                        <a:rPr lang="en-US" sz="1250" dirty="0">
+                          <a:solidFill>
+                            <a:srgbClr val="F5F7FA"/>
+                          </a:solidFill>
+                          <a:latin typeface="Calibri" pitchFamily="34" charset="0"/>
+                          <a:ea typeface="Calibri" pitchFamily="34" charset="-122"/>
+                          <a:cs typeface="Calibri" pitchFamily="34" charset="-120"/>
+                        </a:rPr>
+                        <a:t>Qwen-2.5-7B few-shot</a:t>
+                      </a:r>
+                      <a:endParaRPr lang="en-US" sz="1250" dirty="0">
                         <a:latin typeface="Calibri" charset="0"/>
                         <a:ea typeface="Calibri" charset="0"/>
                         <a:cs typeface="Calibri" charset="0"/>
@@ -17180,17 +17181,17 @@
                         <a:buNone/>
                       </a:pPr>
                       <a:r>
-                        <a:rPr lang="en-US" sz="1300" b="1" dirty="0">
+                        <a:rPr lang="en-US" sz="1250" dirty="0">
                           <a:solidFill>
-                            <a:srgbClr val="FF6B4A"/>
+                            <a:srgbClr val="F5F7FA"/>
                           </a:solidFill>
                           <a:latin typeface="Calibri" pitchFamily="34" charset="0"/>
                           <a:ea typeface="Calibri" pitchFamily="34" charset="-122"/>
                           <a:cs typeface="Calibri" pitchFamily="34" charset="-120"/>
                         </a:rPr>
-                        <a:t>0.850</a:t>
+                        <a:t>0.937 (0.925-0.948)</a:t>
                       </a:r>
-                      <a:endParaRPr lang="en-US" sz="1300" dirty="0">
+                      <a:endParaRPr lang="en-US" sz="1250" dirty="0">
                         <a:latin typeface="Calibri" charset="0"/>
                         <a:ea typeface="Calibri" charset="0"/>
                         <a:cs typeface="Calibri" charset="0"/>
@@ -17248,17 +17249,17 @@
                         <a:buNone/>
                       </a:pPr>
                       <a:r>
-                        <a:rPr lang="en-US" sz="1300" b="1" dirty="0">
+                        <a:rPr lang="en-US" sz="1250" dirty="0">
                           <a:solidFill>
-                            <a:srgbClr val="FF6B4A"/>
+                            <a:srgbClr val="F5F7FA"/>
                           </a:solidFill>
                           <a:latin typeface="Calibri" pitchFamily="34" charset="0"/>
                           <a:ea typeface="Calibri" pitchFamily="34" charset="-122"/>
                           <a:cs typeface="Calibri" pitchFamily="34" charset="-120"/>
                         </a:rPr>
-                        <a:t>0.819</a:t>
+                        <a:t>0.844</a:t>
                       </a:r>
-                      <a:endParaRPr lang="en-US" sz="1300" dirty="0">
+                      <a:endParaRPr lang="en-US" sz="1250" dirty="0">
                         <a:latin typeface="Calibri" charset="0"/>
                         <a:ea typeface="Calibri" charset="0"/>
                         <a:cs typeface="Calibri" charset="0"/>
@@ -17316,17 +17317,17 @@
                         <a:buNone/>
                       </a:pPr>
                       <a:r>
-                        <a:rPr lang="en-US" sz="1300" b="1" dirty="0">
+                        <a:rPr lang="en-US" sz="1250" dirty="0">
                           <a:solidFill>
-                            <a:srgbClr val="FF6B4A"/>
+                            <a:srgbClr val="F5F7FA"/>
                           </a:solidFill>
                           <a:latin typeface="Calibri" pitchFamily="34" charset="0"/>
                           <a:ea typeface="Calibri" pitchFamily="34" charset="-122"/>
                           <a:cs typeface="Calibri" pitchFamily="34" charset="-120"/>
                         </a:rPr>
-                        <a:t>0.940</a:t>
+                        <a:t>5%</a:t>
                       </a:r>
-                      <a:endParaRPr lang="en-US" sz="1300" dirty="0">
+                      <a:endParaRPr lang="en-US" sz="1250" dirty="0">
                         <a:latin typeface="Calibri" charset="0"/>
                         <a:ea typeface="Calibri" charset="0"/>
                         <a:cs typeface="Calibri" charset="0"/>
@@ -17384,77 +17385,7 @@
                         <a:buNone/>
                       </a:pPr>
                       <a:r>
-                        <a:rPr lang="en-US" sz="1300" b="1" dirty="0">
-                          <a:solidFill>
-                            <a:srgbClr val="FF6B4A"/>
-                          </a:solidFill>
-                          <a:latin typeface="Calibri" pitchFamily="34" charset="0"/>
-                          <a:ea typeface="Calibri" pitchFamily="34" charset="-122"/>
-                          <a:cs typeface="Calibri" pitchFamily="34" charset="-120"/>
-                        </a:rPr>
-                        <a:t>$0.031</a:t>
-                      </a:r>
-                      <a:endParaRPr lang="en-US" sz="1300" dirty="0">
-                        <a:latin typeface="Calibri" charset="0"/>
-                        <a:ea typeface="Calibri" charset="0"/>
-                        <a:cs typeface="Calibri" charset="0"/>
-                      </a:endParaRPr>
-                    </a:p>
-                  </a:txBody>
-                  <a:tcPr marL="91440" marR="91440" marT="45720" marB="45720" anchor="ctr">
-                    <a:lnL w="9525" cap="flat" cmpd="sng" algn="ctr">
-                      <a:solidFill>
-                        <a:srgbClr val="2A3448"/>
-                      </a:solidFill>
-                      <a:prstDash val="solid"/>
-                      <a:round/>
-                      <a:headEnd type="none" w="med" len="med"/>
-                      <a:tailEnd type="none" w="med" len="med"/>
-                    </a:lnL>
-                    <a:lnR w="9525" cap="flat" cmpd="sng" algn="ctr">
-                      <a:solidFill>
-                        <a:srgbClr val="2A3448"/>
-                      </a:solidFill>
-                      <a:prstDash val="solid"/>
-                      <a:round/>
-                      <a:headEnd type="none" w="med" len="med"/>
-                      <a:tailEnd type="none" w="med" len="med"/>
-                    </a:lnR>
-                    <a:lnT w="9525" cap="flat" cmpd="sng" algn="ctr">
-                      <a:solidFill>
-                        <a:srgbClr val="2A3448"/>
-                      </a:solidFill>
-                      <a:prstDash val="solid"/>
-                      <a:round/>
-                      <a:headEnd type="none" w="med" len="med"/>
-                      <a:tailEnd type="none" w="med" len="med"/>
-                    </a:lnT>
-                    <a:lnB w="9525" cap="flat" cmpd="sng" algn="ctr">
-                      <a:solidFill>
-                        <a:srgbClr val="2A3448"/>
-                      </a:solidFill>
-                      <a:prstDash val="solid"/>
-                      <a:round/>
-                      <a:headEnd type="none" w="med" len="med"/>
-                      <a:tailEnd type="none" w="med" len="med"/>
-                    </a:lnB>
-                    <a:solidFill>
-                      <a:srgbClr val="0F1420"/>
-                    </a:solidFill>
-                  </a:tcPr>
-                </a:tc>
-              </a:tr>
-              <a:tr h="384048">
-                <a:tc>
-                  <a:txBody>
-                    <a:bodyPr/>
-                    <a:lstStyle/>
-                    <a:p>
-                      <a:pPr algn="ctr" indent="0" marL="0">
-                        <a:buNone/>
-                      </a:pPr>
-                      <a:r>
-                        <a:rPr lang="en-US" sz="1300" dirty="0">
+                        <a:rPr lang="en-US" sz="1250" dirty="0">
                           <a:solidFill>
                             <a:srgbClr val="F5F7FA"/>
                           </a:solidFill>
@@ -17462,9 +17393,9 @@
                           <a:ea typeface="Calibri" pitchFamily="34" charset="-122"/>
                           <a:cs typeface="Calibri" pitchFamily="34" charset="-120"/>
                         </a:rPr>
-                        <a:t>TF-IDF + LogReg</a:t>
+                        <a:t>0.598</a:t>
                       </a:r>
-                      <a:endParaRPr lang="en-US" sz="1300" dirty="0">
+                      <a:endParaRPr lang="en-US" sz="1250" dirty="0">
                         <a:latin typeface="Calibri" charset="0"/>
                         <a:ea typeface="Calibri" charset="0"/>
                         <a:cs typeface="Calibri" charset="0"/>
@@ -17522,7 +17453,7 @@
                         <a:buNone/>
                       </a:pPr>
                       <a:r>
-                        <a:rPr lang="en-US" sz="1300" dirty="0">
+                        <a:rPr lang="en-US" sz="1250" dirty="0">
                           <a:solidFill>
                             <a:srgbClr val="F5F7FA"/>
                           </a:solidFill>
@@ -17530,9 +17461,9 @@
                           <a:ea typeface="Calibri" pitchFamily="34" charset="-122"/>
                           <a:cs typeface="Calibri" pitchFamily="34" charset="-120"/>
                         </a:rPr>
-                        <a:t>0.901 (0.886-0.916)</a:t>
+                        <a:t>0.847</a:t>
                       </a:r>
-                      <a:endParaRPr lang="en-US" sz="1300" dirty="0">
+                      <a:endParaRPr lang="en-US" sz="1250" dirty="0">
                         <a:latin typeface="Calibri" charset="0"/>
                         <a:ea typeface="Calibri" charset="0"/>
                         <a:cs typeface="Calibri" charset="0"/>
@@ -17590,7 +17521,7 @@
                         <a:buNone/>
                       </a:pPr>
                       <a:r>
-                        <a:rPr lang="en-US" sz="1300" dirty="0">
+                        <a:rPr lang="en-US" sz="1250" dirty="0">
                           <a:solidFill>
                             <a:srgbClr val="F5F7FA"/>
                           </a:solidFill>
@@ -17598,9 +17529,79 @@
                           <a:ea typeface="Calibri" pitchFamily="34" charset="-122"/>
                           <a:cs typeface="Calibri" pitchFamily="34" charset="-120"/>
                         </a:rPr>
-                        <a:t>0.807</a:t>
+                        <a:t>$0.074</a:t>
                       </a:r>
-                      <a:endParaRPr lang="en-US" sz="1300" dirty="0">
+                      <a:endParaRPr lang="en-US" sz="1250" dirty="0">
+                        <a:latin typeface="Calibri" charset="0"/>
+                        <a:ea typeface="Calibri" charset="0"/>
+                        <a:cs typeface="Calibri" charset="0"/>
+                      </a:endParaRPr>
+                    </a:p>
+                  </a:txBody>
+                  <a:tcPr marL="91440" marR="91440" marT="45720" marB="45720" anchor="ctr">
+                    <a:lnL w="9525" cap="flat" cmpd="sng" algn="ctr">
+                      <a:solidFill>
+                        <a:srgbClr val="2A3448"/>
+                      </a:solidFill>
+                      <a:prstDash val="solid"/>
+                      <a:round/>
+                      <a:headEnd type="none" w="med" len="med"/>
+                      <a:tailEnd type="none" w="med" len="med"/>
+                    </a:lnL>
+                    <a:lnR w="9525" cap="flat" cmpd="sng" algn="ctr">
+                      <a:solidFill>
+                        <a:srgbClr val="2A3448"/>
+                      </a:solidFill>
+                      <a:prstDash val="solid"/>
+                      <a:round/>
+                      <a:headEnd type="none" w="med" len="med"/>
+                      <a:tailEnd type="none" w="med" len="med"/>
+                    </a:lnR>
+                    <a:lnT w="9525" cap="flat" cmpd="sng" algn="ctr">
+                      <a:solidFill>
+                        <a:srgbClr val="2A3448"/>
+                      </a:solidFill>
+                      <a:prstDash val="solid"/>
+                      <a:round/>
+                      <a:headEnd type="none" w="med" len="med"/>
+                      <a:tailEnd type="none" w="med" len="med"/>
+                    </a:lnT>
+                    <a:lnB w="9525" cap="flat" cmpd="sng" algn="ctr">
+                      <a:solidFill>
+                        <a:srgbClr val="2A3448"/>
+                      </a:solidFill>
+                      <a:prstDash val="solid"/>
+                      <a:round/>
+                      <a:headEnd type="none" w="med" len="med"/>
+                      <a:tailEnd type="none" w="med" len="med"/>
+                    </a:lnB>
+                    <a:solidFill>
+                      <a:srgbClr val="0F1420"/>
+                    </a:solidFill>
+                  </a:tcPr>
+                </a:tc>
+              </a:tr>
+              <a:tr h="338328">
+                <a:tc>
+                  <a:txBody>
+                    <a:bodyPr/>
+                    <a:lstStyle/>
+                    <a:p>
+                      <a:pPr algn="ctr" indent="0" marL="0">
+                        <a:buNone/>
+                      </a:pPr>
+                      <a:r>
+                        <a:rPr lang="en-US" sz="1250" b="1" dirty="0">
+                          <a:solidFill>
+                            <a:srgbClr val="FF6B4A"/>
+                          </a:solidFill>
+                          <a:latin typeface="Calibri" pitchFamily="34" charset="0"/>
+                          <a:ea typeface="Calibri" pitchFamily="34" charset="-122"/>
+                          <a:cs typeface="Calibri" pitchFamily="34" charset="-120"/>
+                        </a:rPr>
+                        <a:t>Qwen-2.5-7B</a:t>
+                      </a:r>
+                      <a:endParaRPr lang="en-US" sz="1250" dirty="0">
                         <a:latin typeface="Calibri" charset="0"/>
                         <a:ea typeface="Calibri" charset="0"/>
                         <a:cs typeface="Calibri" charset="0"/>
@@ -17658,17 +17659,17 @@
                         <a:buNone/>
                       </a:pPr>
                       <a:r>
-                        <a:rPr lang="en-US" sz="1300" dirty="0">
+                        <a:rPr lang="en-US" sz="1250" b="1" dirty="0">
                           <a:solidFill>
-                            <a:srgbClr val="F5F7FA"/>
+                            <a:srgbClr val="FF6B4A"/>
                           </a:solidFill>
                           <a:latin typeface="Calibri" pitchFamily="34" charset="0"/>
                           <a:ea typeface="Calibri" pitchFamily="34" charset="-122"/>
                           <a:cs typeface="Calibri" pitchFamily="34" charset="-120"/>
                         </a:rPr>
-                        <a:t>0.640</a:t>
+                        <a:t>0.928 (0.915-0.940)</a:t>
                       </a:r>
-                      <a:endParaRPr lang="en-US" sz="1300" dirty="0">
+                      <a:endParaRPr lang="en-US" sz="1250" dirty="0">
                         <a:latin typeface="Calibri" charset="0"/>
                         <a:ea typeface="Calibri" charset="0"/>
                         <a:cs typeface="Calibri" charset="0"/>
@@ -17726,17 +17727,17 @@
                         <a:buNone/>
                       </a:pPr>
                       <a:r>
-                        <a:rPr lang="en-US" sz="1300" dirty="0">
+                        <a:rPr lang="en-US" sz="1250" b="1" dirty="0">
                           <a:solidFill>
-                            <a:srgbClr val="F5F7FA"/>
+                            <a:srgbClr val="FF6B4A"/>
                           </a:solidFill>
                           <a:latin typeface="Calibri" pitchFamily="34" charset="0"/>
                           <a:ea typeface="Calibri" pitchFamily="34" charset="-122"/>
                           <a:cs typeface="Calibri" pitchFamily="34" charset="-120"/>
                         </a:rPr>
-                        <a:t>0.713</a:t>
+                        <a:t>0.850</a:t>
                       </a:r>
-                      <a:endParaRPr lang="en-US" sz="1300" dirty="0">
+                      <a:endParaRPr lang="en-US" sz="1250" dirty="0">
                         <a:latin typeface="Calibri" charset="0"/>
                         <a:ea typeface="Calibri" charset="0"/>
                         <a:cs typeface="Calibri" charset="0"/>
@@ -17794,87 +17795,17 @@
                         <a:buNone/>
                       </a:pPr>
                       <a:r>
-                        <a:rPr lang="en-US" sz="1300" dirty="0">
+                        <a:rPr lang="en-US" sz="1250" b="1" dirty="0">
                           <a:solidFill>
-                            <a:srgbClr val="F5F7FA"/>
+                            <a:srgbClr val="FF6B4A"/>
                           </a:solidFill>
                           <a:latin typeface="Calibri" pitchFamily="34" charset="0"/>
                           <a:ea typeface="Calibri" pitchFamily="34" charset="-122"/>
                           <a:cs typeface="Calibri" pitchFamily="34" charset="-120"/>
                         </a:rPr>
-                        <a:t>local</a:t>
+                        <a:t>3%</a:t>
                       </a:r>
-                      <a:endParaRPr lang="en-US" sz="1300" dirty="0">
-                        <a:latin typeface="Calibri" charset="0"/>
-                        <a:ea typeface="Calibri" charset="0"/>
-                        <a:cs typeface="Calibri" charset="0"/>
-                      </a:endParaRPr>
-                    </a:p>
-                  </a:txBody>
-                  <a:tcPr marL="91440" marR="91440" marT="45720" marB="45720" anchor="ctr">
-                    <a:lnL w="9525" cap="flat" cmpd="sng" algn="ctr">
-                      <a:solidFill>
-                        <a:srgbClr val="2A3448"/>
-                      </a:solidFill>
-                      <a:prstDash val="solid"/>
-                      <a:round/>
-                      <a:headEnd type="none" w="med" len="med"/>
-                      <a:tailEnd type="none" w="med" len="med"/>
-                    </a:lnL>
-                    <a:lnR w="9525" cap="flat" cmpd="sng" algn="ctr">
-                      <a:solidFill>
-                        <a:srgbClr val="2A3448"/>
-                      </a:solidFill>
-                      <a:prstDash val="solid"/>
-                      <a:round/>
-                      <a:headEnd type="none" w="med" len="med"/>
-                      <a:tailEnd type="none" w="med" len="med"/>
-                    </a:lnR>
-                    <a:lnT w="9525" cap="flat" cmpd="sng" algn="ctr">
-                      <a:solidFill>
-                        <a:srgbClr val="2A3448"/>
-                      </a:solidFill>
-                      <a:prstDash val="solid"/>
-                      <a:round/>
-                      <a:headEnd type="none" w="med" len="med"/>
-                      <a:tailEnd type="none" w="med" len="med"/>
-                    </a:lnT>
-                    <a:lnB w="9525" cap="flat" cmpd="sng" algn="ctr">
-                      <a:solidFill>
-                        <a:srgbClr val="2A3448"/>
-                      </a:solidFill>
-                      <a:prstDash val="solid"/>
-                      <a:round/>
-                      <a:headEnd type="none" w="med" len="med"/>
-                      <a:tailEnd type="none" w="med" len="med"/>
-                    </a:lnB>
-                    <a:solidFill>
-                      <a:srgbClr val="0F1420"/>
-                    </a:solidFill>
-                  </a:tcPr>
-                </a:tc>
-              </a:tr>
-              <a:tr h="384048">
-                <a:tc>
-                  <a:txBody>
-                    <a:bodyPr/>
-                    <a:lstStyle/>
-                    <a:p>
-                      <a:pPr algn="ctr" indent="0" marL="0">
-                        <a:buNone/>
-                      </a:pPr>
-                      <a:r>
-                        <a:rPr lang="en-US" sz="1300" dirty="0">
-                          <a:solidFill>
-                            <a:srgbClr val="F5F7FA"/>
-                          </a:solidFill>
-                          <a:latin typeface="Calibri" pitchFamily="34" charset="0"/>
-                          <a:ea typeface="Calibri" pitchFamily="34" charset="-122"/>
-                          <a:cs typeface="Calibri" pitchFamily="34" charset="-120"/>
-                        </a:rPr>
-                        <a:t>Llama-3.2-3B few-shot</a:t>
-                      </a:r>
-                      <a:endParaRPr lang="en-US" sz="1300" dirty="0">
+                      <a:endParaRPr lang="en-US" sz="1250" dirty="0">
                         <a:latin typeface="Calibri" charset="0"/>
                         <a:ea typeface="Calibri" charset="0"/>
                         <a:cs typeface="Calibri" charset="0"/>
@@ -17932,17 +17863,17 @@
                         <a:buNone/>
                       </a:pPr>
                       <a:r>
-                        <a:rPr lang="en-US" sz="1300" dirty="0">
+                        <a:rPr lang="en-US" sz="1250" b="1" dirty="0">
                           <a:solidFill>
-                            <a:srgbClr val="F5F7FA"/>
+                            <a:srgbClr val="FF6B4A"/>
                           </a:solidFill>
                           <a:latin typeface="Calibri" pitchFamily="34" charset="0"/>
                           <a:ea typeface="Calibri" pitchFamily="34" charset="-122"/>
                           <a:cs typeface="Calibri" pitchFamily="34" charset="-120"/>
                         </a:rPr>
-                        <a:t>0.901 (0.885-0.915)</a:t>
+                        <a:t>0.819</a:t>
                       </a:r>
-                      <a:endParaRPr lang="en-US" sz="1300" dirty="0">
+                      <a:endParaRPr lang="en-US" sz="1250" dirty="0">
                         <a:latin typeface="Calibri" charset="0"/>
                         <a:ea typeface="Calibri" charset="0"/>
                         <a:cs typeface="Calibri" charset="0"/>
@@ -18000,17 +17931,17 @@
                         <a:buNone/>
                       </a:pPr>
                       <a:r>
-                        <a:rPr lang="en-US" sz="1300" dirty="0">
+                        <a:rPr lang="en-US" sz="1250" b="1" dirty="0">
                           <a:solidFill>
-                            <a:srgbClr val="F5F7FA"/>
+                            <a:srgbClr val="FF6B4A"/>
                           </a:solidFill>
                           <a:latin typeface="Calibri" pitchFamily="34" charset="0"/>
                           <a:ea typeface="Calibri" pitchFamily="34" charset="-122"/>
                           <a:cs typeface="Calibri" pitchFamily="34" charset="-120"/>
                         </a:rPr>
-                        <a:t>0.848</a:t>
+                        <a:t>0.940</a:t>
                       </a:r>
-                      <a:endParaRPr lang="en-US" sz="1300" dirty="0">
+                      <a:endParaRPr lang="en-US" sz="1250" dirty="0">
                         <a:latin typeface="Calibri" charset="0"/>
                         <a:ea typeface="Calibri" charset="0"/>
                         <a:cs typeface="Calibri" charset="0"/>
@@ -18068,7 +17999,77 @@
                         <a:buNone/>
                       </a:pPr>
                       <a:r>
-                        <a:rPr lang="en-US" sz="1300" dirty="0">
+                        <a:rPr lang="en-US" sz="1250" b="1" dirty="0">
+                          <a:solidFill>
+                            <a:srgbClr val="FF6B4A"/>
+                          </a:solidFill>
+                          <a:latin typeface="Calibri" pitchFamily="34" charset="0"/>
+                          <a:ea typeface="Calibri" pitchFamily="34" charset="-122"/>
+                          <a:cs typeface="Calibri" pitchFamily="34" charset="-120"/>
+                        </a:rPr>
+                        <a:t>$0.031</a:t>
+                      </a:r>
+                      <a:endParaRPr lang="en-US" sz="1250" dirty="0">
+                        <a:latin typeface="Calibri" charset="0"/>
+                        <a:ea typeface="Calibri" charset="0"/>
+                        <a:cs typeface="Calibri" charset="0"/>
+                      </a:endParaRPr>
+                    </a:p>
+                  </a:txBody>
+                  <a:tcPr marL="91440" marR="91440" marT="45720" marB="45720" anchor="ctr">
+                    <a:lnL w="9525" cap="flat" cmpd="sng" algn="ctr">
+                      <a:solidFill>
+                        <a:srgbClr val="2A3448"/>
+                      </a:solidFill>
+                      <a:prstDash val="solid"/>
+                      <a:round/>
+                      <a:headEnd type="none" w="med" len="med"/>
+                      <a:tailEnd type="none" w="med" len="med"/>
+                    </a:lnL>
+                    <a:lnR w="9525" cap="flat" cmpd="sng" algn="ctr">
+                      <a:solidFill>
+                        <a:srgbClr val="2A3448"/>
+                      </a:solidFill>
+                      <a:prstDash val="solid"/>
+                      <a:round/>
+                      <a:headEnd type="none" w="med" len="med"/>
+                      <a:tailEnd type="none" w="med" len="med"/>
+                    </a:lnR>
+                    <a:lnT w="9525" cap="flat" cmpd="sng" algn="ctr">
+                      <a:solidFill>
+                        <a:srgbClr val="2A3448"/>
+                      </a:solidFill>
+                      <a:prstDash val="solid"/>
+                      <a:round/>
+                      <a:headEnd type="none" w="med" len="med"/>
+                      <a:tailEnd type="none" w="med" len="med"/>
+                    </a:lnT>
+                    <a:lnB w="9525" cap="flat" cmpd="sng" algn="ctr">
+                      <a:solidFill>
+                        <a:srgbClr val="2A3448"/>
+                      </a:solidFill>
+                      <a:prstDash val="solid"/>
+                      <a:round/>
+                      <a:headEnd type="none" w="med" len="med"/>
+                      <a:tailEnd type="none" w="med" len="med"/>
+                    </a:lnB>
+                    <a:solidFill>
+                      <a:srgbClr val="0F1420"/>
+                    </a:solidFill>
+                  </a:tcPr>
+                </a:tc>
+              </a:tr>
+              <a:tr h="338328">
+                <a:tc>
+                  <a:txBody>
+                    <a:bodyPr/>
+                    <a:lstStyle/>
+                    <a:p>
+                      <a:pPr algn="ctr" indent="0" marL="0">
+                        <a:buNone/>
+                      </a:pPr>
+                      <a:r>
+                        <a:rPr lang="en-US" sz="1250" dirty="0">
                           <a:solidFill>
                             <a:srgbClr val="F5F7FA"/>
                           </a:solidFill>
@@ -18076,9 +18077,9 @@
                           <a:ea typeface="Calibri" pitchFamily="34" charset="-122"/>
                           <a:cs typeface="Calibri" pitchFamily="34" charset="-120"/>
                         </a:rPr>
-                        <a:t>0.438</a:t>
+                        <a:t>TF-IDF + LogReg</a:t>
                       </a:r>
-                      <a:endParaRPr lang="en-US" sz="1300" dirty="0">
+                      <a:endParaRPr lang="en-US" sz="1250" dirty="0">
                         <a:latin typeface="Calibri" charset="0"/>
                         <a:ea typeface="Calibri" charset="0"/>
                         <a:cs typeface="Calibri" charset="0"/>
@@ -18136,7 +18137,7 @@
                         <a:buNone/>
                       </a:pPr>
                       <a:r>
-                        <a:rPr lang="en-US" sz="1300" dirty="0">
+                        <a:rPr lang="en-US" sz="1250" dirty="0">
                           <a:solidFill>
                             <a:srgbClr val="F5F7FA"/>
                           </a:solidFill>
@@ -18144,9 +18145,9 @@
                           <a:ea typeface="Calibri" pitchFamily="34" charset="-122"/>
                           <a:cs typeface="Calibri" pitchFamily="34" charset="-120"/>
                         </a:rPr>
-                        <a:t>0.680</a:t>
+                        <a:t>0.901 (0.886-0.916)</a:t>
                       </a:r>
-                      <a:endParaRPr lang="en-US" sz="1300" dirty="0">
+                      <a:endParaRPr lang="en-US" sz="1250" dirty="0">
                         <a:latin typeface="Calibri" charset="0"/>
                         <a:ea typeface="Calibri" charset="0"/>
                         <a:cs typeface="Calibri" charset="0"/>
@@ -18204,7 +18205,7 @@
                         <a:buNone/>
                       </a:pPr>
                       <a:r>
-                        <a:rPr lang="en-US" sz="1300" dirty="0">
+                        <a:rPr lang="en-US" sz="1250" dirty="0">
                           <a:solidFill>
                             <a:srgbClr val="F5F7FA"/>
                           </a:solidFill>
@@ -18212,79 +18213,9 @@
                           <a:ea typeface="Calibri" pitchFamily="34" charset="-122"/>
                           <a:cs typeface="Calibri" pitchFamily="34" charset="-120"/>
                         </a:rPr>
-                        <a:t>$0.037</a:t>
+                        <a:t>0.807</a:t>
                       </a:r>
-                      <a:endParaRPr lang="en-US" sz="1300" dirty="0">
-                        <a:latin typeface="Calibri" charset="0"/>
-                        <a:ea typeface="Calibri" charset="0"/>
-                        <a:cs typeface="Calibri" charset="0"/>
-                      </a:endParaRPr>
-                    </a:p>
-                  </a:txBody>
-                  <a:tcPr marL="91440" marR="91440" marT="45720" marB="45720" anchor="ctr">
-                    <a:lnL w="9525" cap="flat" cmpd="sng" algn="ctr">
-                      <a:solidFill>
-                        <a:srgbClr val="2A3448"/>
-                      </a:solidFill>
-                      <a:prstDash val="solid"/>
-                      <a:round/>
-                      <a:headEnd type="none" w="med" len="med"/>
-                      <a:tailEnd type="none" w="med" len="med"/>
-                    </a:lnL>
-                    <a:lnR w="9525" cap="flat" cmpd="sng" algn="ctr">
-                      <a:solidFill>
-                        <a:srgbClr val="2A3448"/>
-                      </a:solidFill>
-                      <a:prstDash val="solid"/>
-                      <a:round/>
-                      <a:headEnd type="none" w="med" len="med"/>
-                      <a:tailEnd type="none" w="med" len="med"/>
-                    </a:lnR>
-                    <a:lnT w="9525" cap="flat" cmpd="sng" algn="ctr">
-                      <a:solidFill>
-                        <a:srgbClr val="2A3448"/>
-                      </a:solidFill>
-                      <a:prstDash val="solid"/>
-                      <a:round/>
-                      <a:headEnd type="none" w="med" len="med"/>
-                      <a:tailEnd type="none" w="med" len="med"/>
-                    </a:lnT>
-                    <a:lnB w="9525" cap="flat" cmpd="sng" algn="ctr">
-                      <a:solidFill>
-                        <a:srgbClr val="2A3448"/>
-                      </a:solidFill>
-                      <a:prstDash val="solid"/>
-                      <a:round/>
-                      <a:headEnd type="none" w="med" len="med"/>
-                      <a:tailEnd type="none" w="med" len="med"/>
-                    </a:lnB>
-                    <a:solidFill>
-                      <a:srgbClr val="0F1420"/>
-                    </a:solidFill>
-                  </a:tcPr>
-                </a:tc>
-              </a:tr>
-              <a:tr h="384048">
-                <a:tc>
-                  <a:txBody>
-                    <a:bodyPr/>
-                    <a:lstStyle/>
-                    <a:p>
-                      <a:pPr algn="ctr" indent="0" marL="0">
-                        <a:buNone/>
-                      </a:pPr>
-                      <a:r>
-                        <a:rPr lang="en-US" sz="1300" dirty="0">
-                          <a:solidFill>
-                            <a:srgbClr val="F5F7FA"/>
-                          </a:solidFill>
-                          <a:latin typeface="Calibri" pitchFamily="34" charset="0"/>
-                          <a:ea typeface="Calibri" pitchFamily="34" charset="-122"/>
-                          <a:cs typeface="Calibri" pitchFamily="34" charset="-120"/>
-                        </a:rPr>
-                        <a:t>TF-IDF + NB</a:t>
-                      </a:r>
-                      <a:endParaRPr lang="en-US" sz="1300" dirty="0">
+                      <a:endParaRPr lang="en-US" sz="1250" dirty="0">
                         <a:latin typeface="Calibri" charset="0"/>
                         <a:ea typeface="Calibri" charset="0"/>
                         <a:cs typeface="Calibri" charset="0"/>
@@ -18342,7 +18273,7 @@
                         <a:buNone/>
                       </a:pPr>
                       <a:r>
-                        <a:rPr lang="en-US" sz="1300" dirty="0">
+                        <a:rPr lang="en-US" sz="1250" dirty="0">
                           <a:solidFill>
                             <a:srgbClr val="F5F7FA"/>
                           </a:solidFill>
@@ -18350,9 +18281,9 @@
                           <a:ea typeface="Calibri" pitchFamily="34" charset="-122"/>
                           <a:cs typeface="Calibri" pitchFamily="34" charset="-120"/>
                         </a:rPr>
-                        <a:t>0.895 (0.879-0.909)</a:t>
+                        <a:t>9%</a:t>
                       </a:r>
-                      <a:endParaRPr lang="en-US" sz="1300" dirty="0">
+                      <a:endParaRPr lang="en-US" sz="1250" dirty="0">
                         <a:latin typeface="Calibri" charset="0"/>
                         <a:ea typeface="Calibri" charset="0"/>
                         <a:cs typeface="Calibri" charset="0"/>
@@ -18410,7 +18341,7 @@
                         <a:buNone/>
                       </a:pPr>
                       <a:r>
-                        <a:rPr lang="en-US" sz="1300" dirty="0">
+                        <a:rPr lang="en-US" sz="1250" dirty="0">
                           <a:solidFill>
                             <a:srgbClr val="F5F7FA"/>
                           </a:solidFill>
@@ -18418,9 +18349,9 @@
                           <a:ea typeface="Calibri" pitchFamily="34" charset="-122"/>
                           <a:cs typeface="Calibri" pitchFamily="34" charset="-120"/>
                         </a:rPr>
-                        <a:t>0.773</a:t>
+                        <a:t>0.640</a:t>
                       </a:r>
-                      <a:endParaRPr lang="en-US" sz="1300" dirty="0">
+                      <a:endParaRPr lang="en-US" sz="1250" dirty="0">
                         <a:latin typeface="Calibri" charset="0"/>
                         <a:ea typeface="Calibri" charset="0"/>
                         <a:cs typeface="Calibri" charset="0"/>
@@ -18478,7 +18409,7 @@
                         <a:buNone/>
                       </a:pPr>
                       <a:r>
-                        <a:rPr lang="en-US" sz="1300" dirty="0">
+                        <a:rPr lang="en-US" sz="1250" dirty="0">
                           <a:solidFill>
                             <a:srgbClr val="F5F7FA"/>
                           </a:solidFill>
@@ -18486,9 +18417,9 @@
                           <a:ea typeface="Calibri" pitchFamily="34" charset="-122"/>
                           <a:cs typeface="Calibri" pitchFamily="34" charset="-120"/>
                         </a:rPr>
-                        <a:t>0.631</a:t>
+                        <a:t>0.713</a:t>
                       </a:r>
-                      <a:endParaRPr lang="en-US" sz="1300" dirty="0">
+                      <a:endParaRPr lang="en-US" sz="1250" dirty="0">
                         <a:latin typeface="Calibri" charset="0"/>
                         <a:ea typeface="Calibri" charset="0"/>
                         <a:cs typeface="Calibri" charset="0"/>
@@ -18546,7 +18477,7 @@
                         <a:buNone/>
                       </a:pPr>
                       <a:r>
-                        <a:rPr lang="en-US" sz="1300" dirty="0">
+                        <a:rPr lang="en-US" sz="1250" dirty="0">
                           <a:solidFill>
                             <a:srgbClr val="F5F7FA"/>
                           </a:solidFill>
@@ -18554,9 +18485,79 @@
                           <a:ea typeface="Calibri" pitchFamily="34" charset="-122"/>
                           <a:cs typeface="Calibri" pitchFamily="34" charset="-120"/>
                         </a:rPr>
-                        <a:t>0.600</a:t>
+                        <a:t>local</a:t>
                       </a:r>
-                      <a:endParaRPr lang="en-US" sz="1300" dirty="0">
+                      <a:endParaRPr lang="en-US" sz="1250" dirty="0">
+                        <a:latin typeface="Calibri" charset="0"/>
+                        <a:ea typeface="Calibri" charset="0"/>
+                        <a:cs typeface="Calibri" charset="0"/>
+                      </a:endParaRPr>
+                    </a:p>
+                  </a:txBody>
+                  <a:tcPr marL="91440" marR="91440" marT="45720" marB="45720" anchor="ctr">
+                    <a:lnL w="9525" cap="flat" cmpd="sng" algn="ctr">
+                      <a:solidFill>
+                        <a:srgbClr val="2A3448"/>
+                      </a:solidFill>
+                      <a:prstDash val="solid"/>
+                      <a:round/>
+                      <a:headEnd type="none" w="med" len="med"/>
+                      <a:tailEnd type="none" w="med" len="med"/>
+                    </a:lnL>
+                    <a:lnR w="9525" cap="flat" cmpd="sng" algn="ctr">
+                      <a:solidFill>
+                        <a:srgbClr val="2A3448"/>
+                      </a:solidFill>
+                      <a:prstDash val="solid"/>
+                      <a:round/>
+                      <a:headEnd type="none" w="med" len="med"/>
+                      <a:tailEnd type="none" w="med" len="med"/>
+                    </a:lnR>
+                    <a:lnT w="9525" cap="flat" cmpd="sng" algn="ctr">
+                      <a:solidFill>
+                        <a:srgbClr val="2A3448"/>
+                      </a:solidFill>
+                      <a:prstDash val="solid"/>
+                      <a:round/>
+                      <a:headEnd type="none" w="med" len="med"/>
+                      <a:tailEnd type="none" w="med" len="med"/>
+                    </a:lnT>
+                    <a:lnB w="9525" cap="flat" cmpd="sng" algn="ctr">
+                      <a:solidFill>
+                        <a:srgbClr val="2A3448"/>
+                      </a:solidFill>
+                      <a:prstDash val="solid"/>
+                      <a:round/>
+                      <a:headEnd type="none" w="med" len="med"/>
+                      <a:tailEnd type="none" w="med" len="med"/>
+                    </a:lnB>
+                    <a:solidFill>
+                      <a:srgbClr val="0F1420"/>
+                    </a:solidFill>
+                  </a:tcPr>
+                </a:tc>
+              </a:tr>
+              <a:tr h="338328">
+                <a:tc>
+                  <a:txBody>
+                    <a:bodyPr/>
+                    <a:lstStyle/>
+                    <a:p>
+                      <a:pPr algn="ctr" indent="0" marL="0">
+                        <a:buNone/>
+                      </a:pPr>
+                      <a:r>
+                        <a:rPr lang="en-US" sz="1250" dirty="0">
+                          <a:solidFill>
+                            <a:srgbClr val="F5F7FA"/>
+                          </a:solidFill>
+                          <a:latin typeface="Calibri" pitchFamily="34" charset="0"/>
+                          <a:ea typeface="Calibri" pitchFamily="34" charset="-122"/>
+                          <a:cs typeface="Calibri" pitchFamily="34" charset="-120"/>
+                        </a:rPr>
+                        <a:t>Llama-3.2-3B few-shot</a:t>
+                      </a:r>
+                      <a:endParaRPr lang="en-US" sz="1250" dirty="0">
                         <a:latin typeface="Calibri" charset="0"/>
                         <a:ea typeface="Calibri" charset="0"/>
                         <a:cs typeface="Calibri" charset="0"/>
@@ -18614,7 +18615,7 @@
                         <a:buNone/>
                       </a:pPr>
                       <a:r>
-                        <a:rPr lang="en-US" sz="1300" dirty="0">
+                        <a:rPr lang="en-US" sz="1250" dirty="0">
                           <a:solidFill>
                             <a:srgbClr val="F5F7FA"/>
                           </a:solidFill>
@@ -18622,79 +18623,9 @@
                           <a:ea typeface="Calibri" pitchFamily="34" charset="-122"/>
                           <a:cs typeface="Calibri" pitchFamily="34" charset="-120"/>
                         </a:rPr>
-                        <a:t>local</a:t>
+                        <a:t>0.901 (0.885-0.915)</a:t>
                       </a:r>
-                      <a:endParaRPr lang="en-US" sz="1300" dirty="0">
-                        <a:latin typeface="Calibri" charset="0"/>
-                        <a:ea typeface="Calibri" charset="0"/>
-                        <a:cs typeface="Calibri" charset="0"/>
-                      </a:endParaRPr>
-                    </a:p>
-                  </a:txBody>
-                  <a:tcPr marL="91440" marR="91440" marT="45720" marB="45720" anchor="ctr">
-                    <a:lnL w="9525" cap="flat" cmpd="sng" algn="ctr">
-                      <a:solidFill>
-                        <a:srgbClr val="2A3448"/>
-                      </a:solidFill>
-                      <a:prstDash val="solid"/>
-                      <a:round/>
-                      <a:headEnd type="none" w="med" len="med"/>
-                      <a:tailEnd type="none" w="med" len="med"/>
-                    </a:lnL>
-                    <a:lnR w="9525" cap="flat" cmpd="sng" algn="ctr">
-                      <a:solidFill>
-                        <a:srgbClr val="2A3448"/>
-                      </a:solidFill>
-                      <a:prstDash val="solid"/>
-                      <a:round/>
-                      <a:headEnd type="none" w="med" len="med"/>
-                      <a:tailEnd type="none" w="med" len="med"/>
-                    </a:lnR>
-                    <a:lnT w="9525" cap="flat" cmpd="sng" algn="ctr">
-                      <a:solidFill>
-                        <a:srgbClr val="2A3448"/>
-                      </a:solidFill>
-                      <a:prstDash val="solid"/>
-                      <a:round/>
-                      <a:headEnd type="none" w="med" len="med"/>
-                      <a:tailEnd type="none" w="med" len="med"/>
-                    </a:lnT>
-                    <a:lnB w="9525" cap="flat" cmpd="sng" algn="ctr">
-                      <a:solidFill>
-                        <a:srgbClr val="2A3448"/>
-                      </a:solidFill>
-                      <a:prstDash val="solid"/>
-                      <a:round/>
-                      <a:headEnd type="none" w="med" len="med"/>
-                      <a:tailEnd type="none" w="med" len="med"/>
-                    </a:lnB>
-                    <a:solidFill>
-                      <a:srgbClr val="0F1420"/>
-                    </a:solidFill>
-                  </a:tcPr>
-                </a:tc>
-              </a:tr>
-              <a:tr h="384048">
-                <a:tc>
-                  <a:txBody>
-                    <a:bodyPr/>
-                    <a:lstStyle/>
-                    <a:p>
-                      <a:pPr algn="ctr" indent="0" marL="0">
-                        <a:buNone/>
-                      </a:pPr>
-                      <a:r>
-                        <a:rPr lang="en-US" sz="1300" dirty="0">
-                          <a:solidFill>
-                            <a:srgbClr val="F5F7FA"/>
-                          </a:solidFill>
-                          <a:latin typeface="Calibri" pitchFamily="34" charset="0"/>
-                          <a:ea typeface="Calibri" pitchFamily="34" charset="-122"/>
-                          <a:cs typeface="Calibri" pitchFamily="34" charset="-120"/>
-                        </a:rPr>
-                        <a:t>Llama-3.1-8B</a:t>
-                      </a:r>
-                      <a:endParaRPr lang="en-US" sz="1300" dirty="0">
+                      <a:endParaRPr lang="en-US" sz="1250" dirty="0">
                         <a:latin typeface="Calibri" charset="0"/>
                         <a:ea typeface="Calibri" charset="0"/>
                         <a:cs typeface="Calibri" charset="0"/>
@@ -18752,7 +18683,7 @@
                         <a:buNone/>
                       </a:pPr>
                       <a:r>
-                        <a:rPr lang="en-US" sz="1300" dirty="0">
+                        <a:rPr lang="en-US" sz="1250" dirty="0">
                           <a:solidFill>
                             <a:srgbClr val="F5F7FA"/>
                           </a:solidFill>
@@ -18760,9 +18691,9 @@
                           <a:ea typeface="Calibri" pitchFamily="34" charset="-122"/>
                           <a:cs typeface="Calibri" pitchFamily="34" charset="-120"/>
                         </a:rPr>
-                        <a:t>0.881 (0.866-0.896)</a:t>
+                        <a:t>0.848</a:t>
                       </a:r>
-                      <a:endParaRPr lang="en-US" sz="1300" dirty="0">
+                      <a:endParaRPr lang="en-US" sz="1250" dirty="0">
                         <a:latin typeface="Calibri" charset="0"/>
                         <a:ea typeface="Calibri" charset="0"/>
                         <a:cs typeface="Calibri" charset="0"/>
@@ -18820,7 +18751,7 @@
                         <a:buNone/>
                       </a:pPr>
                       <a:r>
-                        <a:rPr lang="en-US" sz="1300" dirty="0">
+                        <a:rPr lang="en-US" sz="1250" dirty="0">
                           <a:solidFill>
                             <a:srgbClr val="F5F7FA"/>
                           </a:solidFill>
@@ -18828,9 +18759,9 @@
                           <a:ea typeface="Calibri" pitchFamily="34" charset="-122"/>
                           <a:cs typeface="Calibri" pitchFamily="34" charset="-120"/>
                         </a:rPr>
-                        <a:t>0.779</a:t>
+                        <a:t>3%</a:t>
                       </a:r>
-                      <a:endParaRPr lang="en-US" sz="1300" dirty="0">
+                      <a:endParaRPr lang="en-US" sz="1250" dirty="0">
                         <a:latin typeface="Calibri" charset="0"/>
                         <a:ea typeface="Calibri" charset="0"/>
                         <a:cs typeface="Calibri" charset="0"/>
@@ -18888,7 +18819,7 @@
                         <a:buNone/>
                       </a:pPr>
                       <a:r>
-                        <a:rPr lang="en-US" sz="1300" dirty="0">
+                        <a:rPr lang="en-US" sz="1250" dirty="0">
                           <a:solidFill>
                             <a:srgbClr val="F5F7FA"/>
                           </a:solidFill>
@@ -18896,9 +18827,9 @@
                           <a:ea typeface="Calibri" pitchFamily="34" charset="-122"/>
                           <a:cs typeface="Calibri" pitchFamily="34" charset="-120"/>
                         </a:rPr>
-                        <a:t>0.817</a:t>
+                        <a:t>0.438</a:t>
                       </a:r>
-                      <a:endParaRPr lang="en-US" sz="1300" dirty="0">
+                      <a:endParaRPr lang="en-US" sz="1250" dirty="0">
                         <a:latin typeface="Calibri" charset="0"/>
                         <a:ea typeface="Calibri" charset="0"/>
                         <a:cs typeface="Calibri" charset="0"/>
@@ -18956,7 +18887,7 @@
                         <a:buNone/>
                       </a:pPr>
                       <a:r>
-                        <a:rPr lang="en-US" sz="1300" dirty="0">
+                        <a:rPr lang="en-US" sz="1250" dirty="0">
                           <a:solidFill>
                             <a:srgbClr val="F5F7FA"/>
                           </a:solidFill>
@@ -18964,9 +18895,9 @@
                           <a:ea typeface="Calibri" pitchFamily="34" charset="-122"/>
                           <a:cs typeface="Calibri" pitchFamily="34" charset="-120"/>
                         </a:rPr>
-                        <a:t>0.973</a:t>
+                        <a:t>0.680</a:t>
                       </a:r>
-                      <a:endParaRPr lang="en-US" sz="1300" dirty="0">
+                      <a:endParaRPr lang="en-US" sz="1250" dirty="0">
                         <a:latin typeface="Calibri" charset="0"/>
                         <a:ea typeface="Calibri" charset="0"/>
                         <a:cs typeface="Calibri" charset="0"/>
@@ -19024,7 +18955,7 @@
                         <a:buNone/>
                       </a:pPr>
                       <a:r>
-                        <a:rPr lang="en-US" sz="1300" dirty="0">
+                        <a:rPr lang="en-US" sz="1250" dirty="0">
                           <a:solidFill>
                             <a:srgbClr val="F5F7FA"/>
                           </a:solidFill>
@@ -19032,9 +18963,9 @@
                           <a:ea typeface="Calibri" pitchFamily="34" charset="-122"/>
                           <a:cs typeface="Calibri" pitchFamily="34" charset="-120"/>
                         </a:rPr>
-                        <a:t>$0.011</a:t>
+                        <a:t>$0.037</a:t>
                       </a:r>
-                      <a:endParaRPr lang="en-US" sz="1300" dirty="0">
+                      <a:endParaRPr lang="en-US" sz="1250" dirty="0">
                         <a:latin typeface="Calibri" charset="0"/>
                         <a:ea typeface="Calibri" charset="0"/>
                         <a:cs typeface="Calibri" charset="0"/>
@@ -19084,7 +19015,7 @@
                   </a:tcPr>
                 </a:tc>
               </a:tr>
-              <a:tr h="384048">
+              <a:tr h="338328">
                 <a:tc>
                   <a:txBody>
                     <a:bodyPr/>
@@ -19094,7 +19025,7 @@
                         <a:buNone/>
                       </a:pPr>
                       <a:r>
-                        <a:rPr lang="en-US" sz="1300" dirty="0">
+                        <a:rPr lang="en-US" sz="1250" dirty="0">
                           <a:solidFill>
                             <a:srgbClr val="F5F7FA"/>
                           </a:solidFill>
@@ -19102,9 +19033,9 @@
                           <a:ea typeface="Calibri" pitchFamily="34" charset="-122"/>
                           <a:cs typeface="Calibri" pitchFamily="34" charset="-120"/>
                         </a:rPr>
-                        <a:t>Llama-3.2-3B</a:t>
+                        <a:t>TF-IDF + NB</a:t>
                       </a:r>
-                      <a:endParaRPr lang="en-US" sz="1300" dirty="0">
+                      <a:endParaRPr lang="en-US" sz="1250" dirty="0">
                         <a:latin typeface="Calibri" charset="0"/>
                         <a:ea typeface="Calibri" charset="0"/>
                         <a:cs typeface="Calibri" charset="0"/>
@@ -19162,7 +19093,7 @@
                         <a:buNone/>
                       </a:pPr>
                       <a:r>
-                        <a:rPr lang="en-US" sz="1300" dirty="0">
+                        <a:rPr lang="en-US" sz="1250" dirty="0">
                           <a:solidFill>
                             <a:srgbClr val="F5F7FA"/>
                           </a:solidFill>
@@ -19170,9 +19101,9 @@
                           <a:ea typeface="Calibri" pitchFamily="34" charset="-122"/>
                           <a:cs typeface="Calibri" pitchFamily="34" charset="-120"/>
                         </a:rPr>
-                        <a:t>0.850 (0.832-0.868)</a:t>
+                        <a:t>0.895 (0.879-0.909)</a:t>
                       </a:r>
-                      <a:endParaRPr lang="en-US" sz="1300" dirty="0">
+                      <a:endParaRPr lang="en-US" sz="1250" dirty="0">
                         <a:latin typeface="Calibri" charset="0"/>
                         <a:ea typeface="Calibri" charset="0"/>
                         <a:cs typeface="Calibri" charset="0"/>
@@ -19230,7 +19161,7 @@
                         <a:buNone/>
                       </a:pPr>
                       <a:r>
-                        <a:rPr lang="en-US" sz="1300" dirty="0">
+                        <a:rPr lang="en-US" sz="1250" dirty="0">
                           <a:solidFill>
                             <a:srgbClr val="F5F7FA"/>
                           </a:solidFill>
@@ -19238,9 +19169,9 @@
                           <a:ea typeface="Calibri" pitchFamily="34" charset="-122"/>
                           <a:cs typeface="Calibri" pitchFamily="34" charset="-120"/>
                         </a:rPr>
-                        <a:t>0.799</a:t>
+                        <a:t>0.773</a:t>
                       </a:r>
-                      <a:endParaRPr lang="en-US" sz="1300" dirty="0">
+                      <a:endParaRPr lang="en-US" sz="1250" dirty="0">
                         <a:latin typeface="Calibri" charset="0"/>
                         <a:ea typeface="Calibri" charset="0"/>
                         <a:cs typeface="Calibri" charset="0"/>
@@ -19298,7 +19229,7 @@
                         <a:buNone/>
                       </a:pPr>
                       <a:r>
-                        <a:rPr lang="en-US" sz="1300" dirty="0">
+                        <a:rPr lang="en-US" sz="1250" dirty="0">
                           <a:solidFill>
                             <a:srgbClr val="F5F7FA"/>
                           </a:solidFill>
@@ -19306,9 +19237,9 @@
                           <a:ea typeface="Calibri" pitchFamily="34" charset="-122"/>
                           <a:cs typeface="Calibri" pitchFamily="34" charset="-120"/>
                         </a:rPr>
-                        <a:t>0.507</a:t>
+                        <a:t>7%</a:t>
                       </a:r>
-                      <a:endParaRPr lang="en-US" sz="1300" dirty="0">
+                      <a:endParaRPr lang="en-US" sz="1250" dirty="0">
                         <a:latin typeface="Calibri" charset="0"/>
                         <a:ea typeface="Calibri" charset="0"/>
                         <a:cs typeface="Calibri" charset="0"/>
@@ -19366,7 +19297,7 @@
                         <a:buNone/>
                       </a:pPr>
                       <a:r>
-                        <a:rPr lang="en-US" sz="1300" dirty="0">
+                        <a:rPr lang="en-US" sz="1250" dirty="0">
                           <a:solidFill>
                             <a:srgbClr val="F5F7FA"/>
                           </a:solidFill>
@@ -19374,9 +19305,9 @@
                           <a:ea typeface="Calibri" pitchFamily="34" charset="-122"/>
                           <a:cs typeface="Calibri" pitchFamily="34" charset="-120"/>
                         </a:rPr>
-                        <a:t>0.827</a:t>
+                        <a:t>0.631</a:t>
                       </a:r>
-                      <a:endParaRPr lang="en-US" sz="1300" dirty="0">
+                      <a:endParaRPr lang="en-US" sz="1250" dirty="0">
                         <a:latin typeface="Calibri" charset="0"/>
                         <a:ea typeface="Calibri" charset="0"/>
                         <a:cs typeface="Calibri" charset="0"/>
@@ -19434,7 +19365,7 @@
                         <a:buNone/>
                       </a:pPr>
                       <a:r>
-                        <a:rPr lang="en-US" sz="1300" dirty="0">
+                        <a:rPr lang="en-US" sz="1250" dirty="0">
                           <a:solidFill>
                             <a:srgbClr val="F5F7FA"/>
                           </a:solidFill>
@@ -19442,79 +19373,9 @@
                           <a:ea typeface="Calibri" pitchFamily="34" charset="-122"/>
                           <a:cs typeface="Calibri" pitchFamily="34" charset="-120"/>
                         </a:rPr>
-                        <a:t>$0.016</a:t>
+                        <a:t>0.600</a:t>
                       </a:r>
-                      <a:endParaRPr lang="en-US" sz="1300" dirty="0">
-                        <a:latin typeface="Calibri" charset="0"/>
-                        <a:ea typeface="Calibri" charset="0"/>
-                        <a:cs typeface="Calibri" charset="0"/>
-                      </a:endParaRPr>
-                    </a:p>
-                  </a:txBody>
-                  <a:tcPr marL="91440" marR="91440" marT="45720" marB="45720" anchor="ctr">
-                    <a:lnL w="9525" cap="flat" cmpd="sng" algn="ctr">
-                      <a:solidFill>
-                        <a:srgbClr val="2A3448"/>
-                      </a:solidFill>
-                      <a:prstDash val="solid"/>
-                      <a:round/>
-                      <a:headEnd type="none" w="med" len="med"/>
-                      <a:tailEnd type="none" w="med" len="med"/>
-                    </a:lnL>
-                    <a:lnR w="9525" cap="flat" cmpd="sng" algn="ctr">
-                      <a:solidFill>
-                        <a:srgbClr val="2A3448"/>
-                      </a:solidFill>
-                      <a:prstDash val="solid"/>
-                      <a:round/>
-                      <a:headEnd type="none" w="med" len="med"/>
-                      <a:tailEnd type="none" w="med" len="med"/>
-                    </a:lnR>
-                    <a:lnT w="9525" cap="flat" cmpd="sng" algn="ctr">
-                      <a:solidFill>
-                        <a:srgbClr val="2A3448"/>
-                      </a:solidFill>
-                      <a:prstDash val="solid"/>
-                      <a:round/>
-                      <a:headEnd type="none" w="med" len="med"/>
-                      <a:tailEnd type="none" w="med" len="med"/>
-                    </a:lnT>
-                    <a:lnB w="9525" cap="flat" cmpd="sng" algn="ctr">
-                      <a:solidFill>
-                        <a:srgbClr val="2A3448"/>
-                      </a:solidFill>
-                      <a:prstDash val="solid"/>
-                      <a:round/>
-                      <a:headEnd type="none" w="med" len="med"/>
-                      <a:tailEnd type="none" w="med" len="med"/>
-                    </a:lnB>
-                    <a:solidFill>
-                      <a:srgbClr val="0F1420"/>
-                    </a:solidFill>
-                  </a:tcPr>
-                </a:tc>
-              </a:tr>
-              <a:tr h="384048">
-                <a:tc>
-                  <a:txBody>
-                    <a:bodyPr/>
-                    <a:lstStyle/>
-                    <a:p>
-                      <a:pPr algn="ctr" indent="0" marL="0">
-                        <a:buNone/>
-                      </a:pPr>
-                      <a:r>
-                        <a:rPr lang="en-US" sz="1300" dirty="0">
-                          <a:solidFill>
-                            <a:srgbClr val="F5F7FA"/>
-                          </a:solidFill>
-                          <a:latin typeface="Calibri" pitchFamily="34" charset="0"/>
-                          <a:ea typeface="Calibri" pitchFamily="34" charset="-122"/>
-                          <a:cs typeface="Calibri" pitchFamily="34" charset="-120"/>
-                        </a:rPr>
-                        <a:t>Phi-4-14B</a:t>
-                      </a:r>
-                      <a:endParaRPr lang="en-US" sz="1300" dirty="0">
+                      <a:endParaRPr lang="en-US" sz="1250" dirty="0">
                         <a:latin typeface="Calibri" charset="0"/>
                         <a:ea typeface="Calibri" charset="0"/>
                         <a:cs typeface="Calibri" charset="0"/>
@@ -19572,7 +19433,7 @@
                         <a:buNone/>
                       </a:pPr>
                       <a:r>
-                        <a:rPr lang="en-US" sz="1300" dirty="0">
+                        <a:rPr lang="en-US" sz="1250" dirty="0">
                           <a:solidFill>
                             <a:srgbClr val="F5F7FA"/>
                           </a:solidFill>
@@ -19580,9 +19441,79 @@
                           <a:ea typeface="Calibri" pitchFamily="34" charset="-122"/>
                           <a:cs typeface="Calibri" pitchFamily="34" charset="-120"/>
                         </a:rPr>
-                        <a:t>0.727 (0.703-0.749)</a:t>
+                        <a:t>local</a:t>
                       </a:r>
-                      <a:endParaRPr lang="en-US" sz="1300" dirty="0">
+                      <a:endParaRPr lang="en-US" sz="1250" dirty="0">
+                        <a:latin typeface="Calibri" charset="0"/>
+                        <a:ea typeface="Calibri" charset="0"/>
+                        <a:cs typeface="Calibri" charset="0"/>
+                      </a:endParaRPr>
+                    </a:p>
+                  </a:txBody>
+                  <a:tcPr marL="91440" marR="91440" marT="45720" marB="45720" anchor="ctr">
+                    <a:lnL w="9525" cap="flat" cmpd="sng" algn="ctr">
+                      <a:solidFill>
+                        <a:srgbClr val="2A3448"/>
+                      </a:solidFill>
+                      <a:prstDash val="solid"/>
+                      <a:round/>
+                      <a:headEnd type="none" w="med" len="med"/>
+                      <a:tailEnd type="none" w="med" len="med"/>
+                    </a:lnL>
+                    <a:lnR w="9525" cap="flat" cmpd="sng" algn="ctr">
+                      <a:solidFill>
+                        <a:srgbClr val="2A3448"/>
+                      </a:solidFill>
+                      <a:prstDash val="solid"/>
+                      <a:round/>
+                      <a:headEnd type="none" w="med" len="med"/>
+                      <a:tailEnd type="none" w="med" len="med"/>
+                    </a:lnR>
+                    <a:lnT w="9525" cap="flat" cmpd="sng" algn="ctr">
+                      <a:solidFill>
+                        <a:srgbClr val="2A3448"/>
+                      </a:solidFill>
+                      <a:prstDash val="solid"/>
+                      <a:round/>
+                      <a:headEnd type="none" w="med" len="med"/>
+                      <a:tailEnd type="none" w="med" len="med"/>
+                    </a:lnT>
+                    <a:lnB w="9525" cap="flat" cmpd="sng" algn="ctr">
+                      <a:solidFill>
+                        <a:srgbClr val="2A3448"/>
+                      </a:solidFill>
+                      <a:prstDash val="solid"/>
+                      <a:round/>
+                      <a:headEnd type="none" w="med" len="med"/>
+                      <a:tailEnd type="none" w="med" len="med"/>
+                    </a:lnB>
+                    <a:solidFill>
+                      <a:srgbClr val="0F1420"/>
+                    </a:solidFill>
+                  </a:tcPr>
+                </a:tc>
+              </a:tr>
+              <a:tr h="338328">
+                <a:tc>
+                  <a:txBody>
+                    <a:bodyPr/>
+                    <a:lstStyle/>
+                    <a:p>
+                      <a:pPr algn="ctr" indent="0" marL="0">
+                        <a:buNone/>
+                      </a:pPr>
+                      <a:r>
+                        <a:rPr lang="en-US" sz="1250" dirty="0">
+                          <a:solidFill>
+                            <a:srgbClr val="F5F7FA"/>
+                          </a:solidFill>
+                          <a:latin typeface="Calibri" pitchFamily="34" charset="0"/>
+                          <a:ea typeface="Calibri" pitchFamily="34" charset="-122"/>
+                          <a:cs typeface="Calibri" pitchFamily="34" charset="-120"/>
+                        </a:rPr>
+                        <a:t>DistilBERT</a:t>
+                      </a:r>
+                      <a:endParaRPr lang="en-US" sz="1250" dirty="0">
                         <a:latin typeface="Calibri" charset="0"/>
                         <a:ea typeface="Calibri" charset="0"/>
                         <a:cs typeface="Calibri" charset="0"/>
@@ -19640,7 +19571,7 @@
                         <a:buNone/>
                       </a:pPr>
                       <a:r>
-                        <a:rPr lang="en-US" sz="1300" dirty="0">
+                        <a:rPr lang="en-US" sz="1250" dirty="0">
                           <a:solidFill>
                             <a:srgbClr val="F5F7FA"/>
                           </a:solidFill>
@@ -19648,9 +19579,9 @@
                           <a:ea typeface="Calibri" pitchFamily="34" charset="-122"/>
                           <a:cs typeface="Calibri" pitchFamily="34" charset="-120"/>
                         </a:rPr>
-                        <a:t>0.621</a:t>
+                        <a:t>0.891 (0.875-0.906)</a:t>
                       </a:r>
-                      <a:endParaRPr lang="en-US" sz="1300" dirty="0">
+                      <a:endParaRPr lang="en-US" sz="1250" dirty="0">
                         <a:latin typeface="Calibri" charset="0"/>
                         <a:ea typeface="Calibri" charset="0"/>
                         <a:cs typeface="Calibri" charset="0"/>
@@ -19708,7 +19639,7 @@
                         <a:buNone/>
                       </a:pPr>
                       <a:r>
-                        <a:rPr lang="en-US" sz="1300" dirty="0">
+                        <a:rPr lang="en-US" sz="1250" dirty="0">
                           <a:solidFill>
                             <a:srgbClr val="F5F7FA"/>
                           </a:solidFill>
@@ -19716,9 +19647,9 @@
                           <a:ea typeface="Calibri" pitchFamily="34" charset="-122"/>
                           <a:cs typeface="Calibri" pitchFamily="34" charset="-120"/>
                         </a:rPr>
-                        <a:t>0.759</a:t>
+                        <a:t>0.838</a:t>
                       </a:r>
-                      <a:endParaRPr lang="en-US" sz="1300" dirty="0">
+                      <a:endParaRPr lang="en-US" sz="1250" dirty="0">
                         <a:latin typeface="Calibri" charset="0"/>
                         <a:ea typeface="Calibri" charset="0"/>
                         <a:cs typeface="Calibri" charset="0"/>
@@ -19776,7 +19707,7 @@
                         <a:buNone/>
                       </a:pPr>
                       <a:r>
-                        <a:rPr lang="en-US" sz="1300" dirty="0">
+                        <a:rPr lang="en-US" sz="1250" dirty="0">
                           <a:solidFill>
                             <a:srgbClr val="F5F7FA"/>
                           </a:solidFill>
@@ -19784,9 +19715,9 @@
                           <a:ea typeface="Calibri" pitchFamily="34" charset="-122"/>
                           <a:cs typeface="Calibri" pitchFamily="34" charset="-120"/>
                         </a:rPr>
-                        <a:t>0.660</a:t>
+                        <a:t>6%</a:t>
                       </a:r>
-                      <a:endParaRPr lang="en-US" sz="1300" dirty="0">
+                      <a:endParaRPr lang="en-US" sz="1250" dirty="0">
                         <a:latin typeface="Calibri" charset="0"/>
                         <a:ea typeface="Calibri" charset="0"/>
                         <a:cs typeface="Calibri" charset="0"/>
@@ -19844,7 +19775,7 @@
                         <a:buNone/>
                       </a:pPr>
                       <a:r>
-                        <a:rPr lang="en-US" sz="1300" dirty="0">
+                        <a:rPr lang="en-US" sz="1250" dirty="0">
                           <a:solidFill>
                             <a:srgbClr val="F5F7FA"/>
                           </a:solidFill>
@@ -19852,79 +19783,9 @@
                           <a:ea typeface="Calibri" pitchFamily="34" charset="-122"/>
                           <a:cs typeface="Calibri" pitchFamily="34" charset="-120"/>
                         </a:rPr>
-                        <a:t>$0.021</a:t>
+                        <a:t>0.493</a:t>
                       </a:r>
-                      <a:endParaRPr lang="en-US" sz="1300" dirty="0">
-                        <a:latin typeface="Calibri" charset="0"/>
-                        <a:ea typeface="Calibri" charset="0"/>
-                        <a:cs typeface="Calibri" charset="0"/>
-                      </a:endParaRPr>
-                    </a:p>
-                  </a:txBody>
-                  <a:tcPr marL="91440" marR="91440" marT="45720" marB="45720" anchor="ctr">
-                    <a:lnL w="9525" cap="flat" cmpd="sng" algn="ctr">
-                      <a:solidFill>
-                        <a:srgbClr val="2A3448"/>
-                      </a:solidFill>
-                      <a:prstDash val="solid"/>
-                      <a:round/>
-                      <a:headEnd type="none" w="med" len="med"/>
-                      <a:tailEnd type="none" w="med" len="med"/>
-                    </a:lnL>
-                    <a:lnR w="9525" cap="flat" cmpd="sng" algn="ctr">
-                      <a:solidFill>
-                        <a:srgbClr val="2A3448"/>
-                      </a:solidFill>
-                      <a:prstDash val="solid"/>
-                      <a:round/>
-                      <a:headEnd type="none" w="med" len="med"/>
-                      <a:tailEnd type="none" w="med" len="med"/>
-                    </a:lnR>
-                    <a:lnT w="9525" cap="flat" cmpd="sng" algn="ctr">
-                      <a:solidFill>
-                        <a:srgbClr val="2A3448"/>
-                      </a:solidFill>
-                      <a:prstDash val="solid"/>
-                      <a:round/>
-                      <a:headEnd type="none" w="med" len="med"/>
-                      <a:tailEnd type="none" w="med" len="med"/>
-                    </a:lnT>
-                    <a:lnB w="9525" cap="flat" cmpd="sng" algn="ctr">
-                      <a:solidFill>
-                        <a:srgbClr val="2A3448"/>
-                      </a:solidFill>
-                      <a:prstDash val="solid"/>
-                      <a:round/>
-                      <a:headEnd type="none" w="med" len="med"/>
-                      <a:tailEnd type="none" w="med" len="med"/>
-                    </a:lnB>
-                    <a:solidFill>
-                      <a:srgbClr val="0F1420"/>
-                    </a:solidFill>
-                  </a:tcPr>
-                </a:tc>
-              </a:tr>
-              <a:tr h="384048">
-                <a:tc>
-                  <a:txBody>
-                    <a:bodyPr/>
-                    <a:lstStyle/>
-                    <a:p>
-                      <a:pPr algn="ctr" indent="0" marL="0">
-                        <a:buNone/>
-                      </a:pPr>
-                      <a:r>
-                        <a:rPr lang="en-US" sz="1300" dirty="0">
-                          <a:solidFill>
-                            <a:srgbClr val="F5F7FA"/>
-                          </a:solidFill>
-                          <a:latin typeface="Calibri" pitchFamily="34" charset="0"/>
-                          <a:ea typeface="Calibri" pitchFamily="34" charset="-122"/>
-                          <a:cs typeface="Calibri" pitchFamily="34" charset="-120"/>
-                        </a:rPr>
-                        <a:t>Llama-3.2-1B</a:t>
-                      </a:r>
-                      <a:endParaRPr lang="en-US" sz="1300" dirty="0">
+                      <a:endParaRPr lang="en-US" sz="1250" dirty="0">
                         <a:latin typeface="Calibri" charset="0"/>
                         <a:ea typeface="Calibri" charset="0"/>
                         <a:cs typeface="Calibri" charset="0"/>
@@ -19982,7 +19843,7 @@
                         <a:buNone/>
                       </a:pPr>
                       <a:r>
-                        <a:rPr lang="en-US" sz="1300" dirty="0">
+                        <a:rPr lang="en-US" sz="1250" dirty="0">
                           <a:solidFill>
                             <a:srgbClr val="F5F7FA"/>
                           </a:solidFill>
@@ -19990,9 +19851,9 @@
                           <a:ea typeface="Calibri" pitchFamily="34" charset="-122"/>
                           <a:cs typeface="Calibri" pitchFamily="34" charset="-120"/>
                         </a:rPr>
-                        <a:t>0.623 (0.599-0.645)</a:t>
+                        <a:t>0.760</a:t>
                       </a:r>
-                      <a:endParaRPr lang="en-US" sz="1300" dirty="0">
+                      <a:endParaRPr lang="en-US" sz="1250" dirty="0">
                         <a:latin typeface="Calibri" charset="0"/>
                         <a:ea typeface="Calibri" charset="0"/>
                         <a:cs typeface="Calibri" charset="0"/>
@@ -20050,7 +19911,7 @@
                         <a:buNone/>
                       </a:pPr>
                       <a:r>
-                        <a:rPr lang="en-US" sz="1300" dirty="0">
+                        <a:rPr lang="en-US" sz="1250" dirty="0">
                           <a:solidFill>
                             <a:srgbClr val="F5F7FA"/>
                           </a:solidFill>
@@ -20058,9 +19919,79 @@
                           <a:ea typeface="Calibri" pitchFamily="34" charset="-122"/>
                           <a:cs typeface="Calibri" pitchFamily="34" charset="-120"/>
                         </a:rPr>
-                        <a:t>0.359</a:t>
+                        <a:t>local</a:t>
                       </a:r>
-                      <a:endParaRPr lang="en-US" sz="1300" dirty="0">
+                      <a:endParaRPr lang="en-US" sz="1250" dirty="0">
+                        <a:latin typeface="Calibri" charset="0"/>
+                        <a:ea typeface="Calibri" charset="0"/>
+                        <a:cs typeface="Calibri" charset="0"/>
+                      </a:endParaRPr>
+                    </a:p>
+                  </a:txBody>
+                  <a:tcPr marL="91440" marR="91440" marT="45720" marB="45720" anchor="ctr">
+                    <a:lnL w="9525" cap="flat" cmpd="sng" algn="ctr">
+                      <a:solidFill>
+                        <a:srgbClr val="2A3448"/>
+                      </a:solidFill>
+                      <a:prstDash val="solid"/>
+                      <a:round/>
+                      <a:headEnd type="none" w="med" len="med"/>
+                      <a:tailEnd type="none" w="med" len="med"/>
+                    </a:lnL>
+                    <a:lnR w="9525" cap="flat" cmpd="sng" algn="ctr">
+                      <a:solidFill>
+                        <a:srgbClr val="2A3448"/>
+                      </a:solidFill>
+                      <a:prstDash val="solid"/>
+                      <a:round/>
+                      <a:headEnd type="none" w="med" len="med"/>
+                      <a:tailEnd type="none" w="med" len="med"/>
+                    </a:lnR>
+                    <a:lnT w="9525" cap="flat" cmpd="sng" algn="ctr">
+                      <a:solidFill>
+                        <a:srgbClr val="2A3448"/>
+                      </a:solidFill>
+                      <a:prstDash val="solid"/>
+                      <a:round/>
+                      <a:headEnd type="none" w="med" len="med"/>
+                      <a:tailEnd type="none" w="med" len="med"/>
+                    </a:lnT>
+                    <a:lnB w="9525" cap="flat" cmpd="sng" algn="ctr">
+                      <a:solidFill>
+                        <a:srgbClr val="2A3448"/>
+                      </a:solidFill>
+                      <a:prstDash val="solid"/>
+                      <a:round/>
+                      <a:headEnd type="none" w="med" len="med"/>
+                      <a:tailEnd type="none" w="med" len="med"/>
+                    </a:lnB>
+                    <a:solidFill>
+                      <a:srgbClr val="0F1420"/>
+                    </a:solidFill>
+                  </a:tcPr>
+                </a:tc>
+              </a:tr>
+              <a:tr h="338328">
+                <a:tc>
+                  <a:txBody>
+                    <a:bodyPr/>
+                    <a:lstStyle/>
+                    <a:p>
+                      <a:pPr algn="ctr" indent="0" marL="0">
+                        <a:buNone/>
+                      </a:pPr>
+                      <a:r>
+                        <a:rPr lang="en-US" sz="1250" dirty="0">
+                          <a:solidFill>
+                            <a:srgbClr val="F5F7FA"/>
+                          </a:solidFill>
+                          <a:latin typeface="Calibri" pitchFamily="34" charset="0"/>
+                          <a:ea typeface="Calibri" pitchFamily="34" charset="-122"/>
+                          <a:cs typeface="Calibri" pitchFamily="34" charset="-120"/>
+                        </a:rPr>
+                        <a:t>Gemma-3-12B</a:t>
+                      </a:r>
+                      <a:endParaRPr lang="en-US" sz="1250" dirty="0">
                         <a:latin typeface="Calibri" charset="0"/>
                         <a:ea typeface="Calibri" charset="0"/>
                         <a:cs typeface="Calibri" charset="0"/>
@@ -20118,7 +20049,7 @@
                         <a:buNone/>
                       </a:pPr>
                       <a:r>
-                        <a:rPr lang="en-US" sz="1300" dirty="0">
+                        <a:rPr lang="en-US" sz="1250" dirty="0">
                           <a:solidFill>
                             <a:srgbClr val="F5F7FA"/>
                           </a:solidFill>
@@ -20126,9 +20057,9 @@
                           <a:ea typeface="Calibri" pitchFamily="34" charset="-122"/>
                           <a:cs typeface="Calibri" pitchFamily="34" charset="-120"/>
                         </a:rPr>
-                        <a:t>0.474</a:t>
+                        <a:t>0.882 (0.866-0.896)</a:t>
                       </a:r>
-                      <a:endParaRPr lang="en-US" sz="1300" dirty="0">
+                      <a:endParaRPr lang="en-US" sz="1250" dirty="0">
                         <a:latin typeface="Calibri" charset="0"/>
                         <a:ea typeface="Calibri" charset="0"/>
                         <a:cs typeface="Calibri" charset="0"/>
@@ -20186,7 +20117,7 @@
                         <a:buNone/>
                       </a:pPr>
                       <a:r>
-                        <a:rPr lang="en-US" sz="1300" dirty="0">
+                        <a:rPr lang="en-US" sz="1250" dirty="0">
                           <a:solidFill>
                             <a:srgbClr val="F5F7FA"/>
                           </a:solidFill>
@@ -20194,9 +20125,9 @@
                           <a:ea typeface="Calibri" pitchFamily="34" charset="-122"/>
                           <a:cs typeface="Calibri" pitchFamily="34" charset="-120"/>
                         </a:rPr>
-                        <a:t>0.760</a:t>
+                        <a:t>0.768</a:t>
                       </a:r>
-                      <a:endParaRPr lang="en-US" sz="1300" dirty="0">
+                      <a:endParaRPr lang="en-US" sz="1250" dirty="0">
                         <a:latin typeface="Calibri" charset="0"/>
                         <a:ea typeface="Calibri" charset="0"/>
                         <a:cs typeface="Calibri" charset="0"/>
@@ -20254,7 +20185,2123 @@
                         <a:buNone/>
                       </a:pPr>
                       <a:r>
-                        <a:rPr lang="en-US" sz="1300" dirty="0">
+                        <a:rPr lang="en-US" sz="1250" dirty="0">
+                          <a:solidFill>
+                            <a:srgbClr val="F5F7FA"/>
+                          </a:solidFill>
+                          <a:latin typeface="Calibri" pitchFamily="34" charset="0"/>
+                          <a:ea typeface="Calibri" pitchFamily="34" charset="-122"/>
+                          <a:cs typeface="Calibri" pitchFamily="34" charset="-120"/>
+                        </a:rPr>
+                        <a:t>25%</a:t>
+                      </a:r>
+                      <a:endParaRPr lang="en-US" sz="1250" dirty="0">
+                        <a:latin typeface="Calibri" charset="0"/>
+                        <a:ea typeface="Calibri" charset="0"/>
+                        <a:cs typeface="Calibri" charset="0"/>
+                      </a:endParaRPr>
+                    </a:p>
+                  </a:txBody>
+                  <a:tcPr marL="91440" marR="91440" marT="45720" marB="45720" anchor="ctr">
+                    <a:lnL w="9525" cap="flat" cmpd="sng" algn="ctr">
+                      <a:solidFill>
+                        <a:srgbClr val="2A3448"/>
+                      </a:solidFill>
+                      <a:prstDash val="solid"/>
+                      <a:round/>
+                      <a:headEnd type="none" w="med" len="med"/>
+                      <a:tailEnd type="none" w="med" len="med"/>
+                    </a:lnL>
+                    <a:lnR w="9525" cap="flat" cmpd="sng" algn="ctr">
+                      <a:solidFill>
+                        <a:srgbClr val="2A3448"/>
+                      </a:solidFill>
+                      <a:prstDash val="solid"/>
+                      <a:round/>
+                      <a:headEnd type="none" w="med" len="med"/>
+                      <a:tailEnd type="none" w="med" len="med"/>
+                    </a:lnR>
+                    <a:lnT w="9525" cap="flat" cmpd="sng" algn="ctr">
+                      <a:solidFill>
+                        <a:srgbClr val="2A3448"/>
+                      </a:solidFill>
+                      <a:prstDash val="solid"/>
+                      <a:round/>
+                      <a:headEnd type="none" w="med" len="med"/>
+                      <a:tailEnd type="none" w="med" len="med"/>
+                    </a:lnT>
+                    <a:lnB w="9525" cap="flat" cmpd="sng" algn="ctr">
+                      <a:solidFill>
+                        <a:srgbClr val="2A3448"/>
+                      </a:solidFill>
+                      <a:prstDash val="solid"/>
+                      <a:round/>
+                      <a:headEnd type="none" w="med" len="med"/>
+                      <a:tailEnd type="none" w="med" len="med"/>
+                    </a:lnB>
+                    <a:solidFill>
+                      <a:srgbClr val="0F1420"/>
+                    </a:solidFill>
+                  </a:tcPr>
+                </a:tc>
+                <a:tc>
+                  <a:txBody>
+                    <a:bodyPr/>
+                    <a:lstStyle/>
+                    <a:p>
+                      <a:pPr algn="ctr" indent="0" marL="0">
+                        <a:buNone/>
+                      </a:pPr>
+                      <a:r>
+                        <a:rPr lang="en-US" sz="1250" dirty="0">
+                          <a:solidFill>
+                            <a:srgbClr val="F5F7FA"/>
+                          </a:solidFill>
+                          <a:latin typeface="Calibri" pitchFamily="34" charset="0"/>
+                          <a:ea typeface="Calibri" pitchFamily="34" charset="-122"/>
+                          <a:cs typeface="Calibri" pitchFamily="34" charset="-120"/>
+                        </a:rPr>
+                        <a:t>0.955</a:t>
+                      </a:r>
+                      <a:endParaRPr lang="en-US" sz="1250" dirty="0">
+                        <a:latin typeface="Calibri" charset="0"/>
+                        <a:ea typeface="Calibri" charset="0"/>
+                        <a:cs typeface="Calibri" charset="0"/>
+                      </a:endParaRPr>
+                    </a:p>
+                  </a:txBody>
+                  <a:tcPr marL="91440" marR="91440" marT="45720" marB="45720" anchor="ctr">
+                    <a:lnL w="9525" cap="flat" cmpd="sng" algn="ctr">
+                      <a:solidFill>
+                        <a:srgbClr val="2A3448"/>
+                      </a:solidFill>
+                      <a:prstDash val="solid"/>
+                      <a:round/>
+                      <a:headEnd type="none" w="med" len="med"/>
+                      <a:tailEnd type="none" w="med" len="med"/>
+                    </a:lnL>
+                    <a:lnR w="9525" cap="flat" cmpd="sng" algn="ctr">
+                      <a:solidFill>
+                        <a:srgbClr val="2A3448"/>
+                      </a:solidFill>
+                      <a:prstDash val="solid"/>
+                      <a:round/>
+                      <a:headEnd type="none" w="med" len="med"/>
+                      <a:tailEnd type="none" w="med" len="med"/>
+                    </a:lnR>
+                    <a:lnT w="9525" cap="flat" cmpd="sng" algn="ctr">
+                      <a:solidFill>
+                        <a:srgbClr val="2A3448"/>
+                      </a:solidFill>
+                      <a:prstDash val="solid"/>
+                      <a:round/>
+                      <a:headEnd type="none" w="med" len="med"/>
+                      <a:tailEnd type="none" w="med" len="med"/>
+                    </a:lnT>
+                    <a:lnB w="9525" cap="flat" cmpd="sng" algn="ctr">
+                      <a:solidFill>
+                        <a:srgbClr val="2A3448"/>
+                      </a:solidFill>
+                      <a:prstDash val="solid"/>
+                      <a:round/>
+                      <a:headEnd type="none" w="med" len="med"/>
+                      <a:tailEnd type="none" w="med" len="med"/>
+                    </a:lnB>
+                    <a:solidFill>
+                      <a:srgbClr val="0F1420"/>
+                    </a:solidFill>
+                  </a:tcPr>
+                </a:tc>
+                <a:tc>
+                  <a:txBody>
+                    <a:bodyPr/>
+                    <a:lstStyle/>
+                    <a:p>
+                      <a:pPr algn="ctr" indent="0" marL="0">
+                        <a:buNone/>
+                      </a:pPr>
+                      <a:r>
+                        <a:rPr lang="en-US" sz="1250" dirty="0">
+                          <a:solidFill>
+                            <a:srgbClr val="F5F7FA"/>
+                          </a:solidFill>
+                          <a:latin typeface="Calibri" pitchFamily="34" charset="0"/>
+                          <a:ea typeface="Calibri" pitchFamily="34" charset="-122"/>
+                          <a:cs typeface="Calibri" pitchFamily="34" charset="-120"/>
+                        </a:rPr>
+                        <a:t>0.980</a:t>
+                      </a:r>
+                      <a:endParaRPr lang="en-US" sz="1250" dirty="0">
+                        <a:latin typeface="Calibri" charset="0"/>
+                        <a:ea typeface="Calibri" charset="0"/>
+                        <a:cs typeface="Calibri" charset="0"/>
+                      </a:endParaRPr>
+                    </a:p>
+                  </a:txBody>
+                  <a:tcPr marL="91440" marR="91440" marT="45720" marB="45720" anchor="ctr">
+                    <a:lnL w="9525" cap="flat" cmpd="sng" algn="ctr">
+                      <a:solidFill>
+                        <a:srgbClr val="2A3448"/>
+                      </a:solidFill>
+                      <a:prstDash val="solid"/>
+                      <a:round/>
+                      <a:headEnd type="none" w="med" len="med"/>
+                      <a:tailEnd type="none" w="med" len="med"/>
+                    </a:lnL>
+                    <a:lnR w="9525" cap="flat" cmpd="sng" algn="ctr">
+                      <a:solidFill>
+                        <a:srgbClr val="2A3448"/>
+                      </a:solidFill>
+                      <a:prstDash val="solid"/>
+                      <a:round/>
+                      <a:headEnd type="none" w="med" len="med"/>
+                      <a:tailEnd type="none" w="med" len="med"/>
+                    </a:lnR>
+                    <a:lnT w="9525" cap="flat" cmpd="sng" algn="ctr">
+                      <a:solidFill>
+                        <a:srgbClr val="2A3448"/>
+                      </a:solidFill>
+                      <a:prstDash val="solid"/>
+                      <a:round/>
+                      <a:headEnd type="none" w="med" len="med"/>
+                      <a:tailEnd type="none" w="med" len="med"/>
+                    </a:lnT>
+                    <a:lnB w="9525" cap="flat" cmpd="sng" algn="ctr">
+                      <a:solidFill>
+                        <a:srgbClr val="2A3448"/>
+                      </a:solidFill>
+                      <a:prstDash val="solid"/>
+                      <a:round/>
+                      <a:headEnd type="none" w="med" len="med"/>
+                      <a:tailEnd type="none" w="med" len="med"/>
+                    </a:lnB>
+                    <a:solidFill>
+                      <a:srgbClr val="0F1420"/>
+                    </a:solidFill>
+                  </a:tcPr>
+                </a:tc>
+                <a:tc>
+                  <a:txBody>
+                    <a:bodyPr/>
+                    <a:lstStyle/>
+                    <a:p>
+                      <a:pPr algn="ctr" indent="0" marL="0">
+                        <a:buNone/>
+                      </a:pPr>
+                      <a:r>
+                        <a:rPr lang="en-US" sz="1250" dirty="0">
+                          <a:solidFill>
+                            <a:srgbClr val="F5F7FA"/>
+                          </a:solidFill>
+                          <a:latin typeface="Calibri" pitchFamily="34" charset="0"/>
+                          <a:ea typeface="Calibri" pitchFamily="34" charset="-122"/>
+                          <a:cs typeface="Calibri" pitchFamily="34" charset="-120"/>
+                        </a:rPr>
+                        <a:t>$0.016</a:t>
+                      </a:r>
+                      <a:endParaRPr lang="en-US" sz="1250" dirty="0">
+                        <a:latin typeface="Calibri" charset="0"/>
+                        <a:ea typeface="Calibri" charset="0"/>
+                        <a:cs typeface="Calibri" charset="0"/>
+                      </a:endParaRPr>
+                    </a:p>
+                  </a:txBody>
+                  <a:tcPr marL="91440" marR="91440" marT="45720" marB="45720" anchor="ctr">
+                    <a:lnL w="9525" cap="flat" cmpd="sng" algn="ctr">
+                      <a:solidFill>
+                        <a:srgbClr val="2A3448"/>
+                      </a:solidFill>
+                      <a:prstDash val="solid"/>
+                      <a:round/>
+                      <a:headEnd type="none" w="med" len="med"/>
+                      <a:tailEnd type="none" w="med" len="med"/>
+                    </a:lnL>
+                    <a:lnR w="9525" cap="flat" cmpd="sng" algn="ctr">
+                      <a:solidFill>
+                        <a:srgbClr val="2A3448"/>
+                      </a:solidFill>
+                      <a:prstDash val="solid"/>
+                      <a:round/>
+                      <a:headEnd type="none" w="med" len="med"/>
+                      <a:tailEnd type="none" w="med" len="med"/>
+                    </a:lnR>
+                    <a:lnT w="9525" cap="flat" cmpd="sng" algn="ctr">
+                      <a:solidFill>
+                        <a:srgbClr val="2A3448"/>
+                      </a:solidFill>
+                      <a:prstDash val="solid"/>
+                      <a:round/>
+                      <a:headEnd type="none" w="med" len="med"/>
+                      <a:tailEnd type="none" w="med" len="med"/>
+                    </a:lnT>
+                    <a:lnB w="9525" cap="flat" cmpd="sng" algn="ctr">
+                      <a:solidFill>
+                        <a:srgbClr val="2A3448"/>
+                      </a:solidFill>
+                      <a:prstDash val="solid"/>
+                      <a:round/>
+                      <a:headEnd type="none" w="med" len="med"/>
+                      <a:tailEnd type="none" w="med" len="med"/>
+                    </a:lnB>
+                    <a:solidFill>
+                      <a:srgbClr val="0F1420"/>
+                    </a:solidFill>
+                  </a:tcPr>
+                </a:tc>
+              </a:tr>
+              <a:tr h="338328">
+                <a:tc>
+                  <a:txBody>
+                    <a:bodyPr/>
+                    <a:lstStyle/>
+                    <a:p>
+                      <a:pPr algn="ctr" indent="0" marL="0">
+                        <a:buNone/>
+                      </a:pPr>
+                      <a:r>
+                        <a:rPr lang="en-US" sz="1250" dirty="0">
+                          <a:solidFill>
+                            <a:srgbClr val="F5F7FA"/>
+                          </a:solidFill>
+                          <a:latin typeface="Calibri" pitchFamily="34" charset="0"/>
+                          <a:ea typeface="Calibri" pitchFamily="34" charset="-122"/>
+                          <a:cs typeface="Calibri" pitchFamily="34" charset="-120"/>
+                        </a:rPr>
+                        <a:t>Llama-3.1-8B</a:t>
+                      </a:r>
+                      <a:endParaRPr lang="en-US" sz="1250" dirty="0">
+                        <a:latin typeface="Calibri" charset="0"/>
+                        <a:ea typeface="Calibri" charset="0"/>
+                        <a:cs typeface="Calibri" charset="0"/>
+                      </a:endParaRPr>
+                    </a:p>
+                  </a:txBody>
+                  <a:tcPr marL="91440" marR="91440" marT="45720" marB="45720" anchor="ctr">
+                    <a:lnL w="9525" cap="flat" cmpd="sng" algn="ctr">
+                      <a:solidFill>
+                        <a:srgbClr val="2A3448"/>
+                      </a:solidFill>
+                      <a:prstDash val="solid"/>
+                      <a:round/>
+                      <a:headEnd type="none" w="med" len="med"/>
+                      <a:tailEnd type="none" w="med" len="med"/>
+                    </a:lnL>
+                    <a:lnR w="9525" cap="flat" cmpd="sng" algn="ctr">
+                      <a:solidFill>
+                        <a:srgbClr val="2A3448"/>
+                      </a:solidFill>
+                      <a:prstDash val="solid"/>
+                      <a:round/>
+                      <a:headEnd type="none" w="med" len="med"/>
+                      <a:tailEnd type="none" w="med" len="med"/>
+                    </a:lnR>
+                    <a:lnT w="9525" cap="flat" cmpd="sng" algn="ctr">
+                      <a:solidFill>
+                        <a:srgbClr val="2A3448"/>
+                      </a:solidFill>
+                      <a:prstDash val="solid"/>
+                      <a:round/>
+                      <a:headEnd type="none" w="med" len="med"/>
+                      <a:tailEnd type="none" w="med" len="med"/>
+                    </a:lnT>
+                    <a:lnB w="9525" cap="flat" cmpd="sng" algn="ctr">
+                      <a:solidFill>
+                        <a:srgbClr val="2A3448"/>
+                      </a:solidFill>
+                      <a:prstDash val="solid"/>
+                      <a:round/>
+                      <a:headEnd type="none" w="med" len="med"/>
+                      <a:tailEnd type="none" w="med" len="med"/>
+                    </a:lnB>
+                    <a:solidFill>
+                      <a:srgbClr val="0F1420"/>
+                    </a:solidFill>
+                  </a:tcPr>
+                </a:tc>
+                <a:tc>
+                  <a:txBody>
+                    <a:bodyPr/>
+                    <a:lstStyle/>
+                    <a:p>
+                      <a:pPr algn="ctr" indent="0" marL="0">
+                        <a:buNone/>
+                      </a:pPr>
+                      <a:r>
+                        <a:rPr lang="en-US" sz="1250" dirty="0">
+                          <a:solidFill>
+                            <a:srgbClr val="F5F7FA"/>
+                          </a:solidFill>
+                          <a:latin typeface="Calibri" pitchFamily="34" charset="0"/>
+                          <a:ea typeface="Calibri" pitchFamily="34" charset="-122"/>
+                          <a:cs typeface="Calibri" pitchFamily="34" charset="-120"/>
+                        </a:rPr>
+                        <a:t>0.881 (0.865-0.896)</a:t>
+                      </a:r>
+                      <a:endParaRPr lang="en-US" sz="1250" dirty="0">
+                        <a:latin typeface="Calibri" charset="0"/>
+                        <a:ea typeface="Calibri" charset="0"/>
+                        <a:cs typeface="Calibri" charset="0"/>
+                      </a:endParaRPr>
+                    </a:p>
+                  </a:txBody>
+                  <a:tcPr marL="91440" marR="91440" marT="45720" marB="45720" anchor="ctr">
+                    <a:lnL w="9525" cap="flat" cmpd="sng" algn="ctr">
+                      <a:solidFill>
+                        <a:srgbClr val="2A3448"/>
+                      </a:solidFill>
+                      <a:prstDash val="solid"/>
+                      <a:round/>
+                      <a:headEnd type="none" w="med" len="med"/>
+                      <a:tailEnd type="none" w="med" len="med"/>
+                    </a:lnL>
+                    <a:lnR w="9525" cap="flat" cmpd="sng" algn="ctr">
+                      <a:solidFill>
+                        <a:srgbClr val="2A3448"/>
+                      </a:solidFill>
+                      <a:prstDash val="solid"/>
+                      <a:round/>
+                      <a:headEnd type="none" w="med" len="med"/>
+                      <a:tailEnd type="none" w="med" len="med"/>
+                    </a:lnR>
+                    <a:lnT w="9525" cap="flat" cmpd="sng" algn="ctr">
+                      <a:solidFill>
+                        <a:srgbClr val="2A3448"/>
+                      </a:solidFill>
+                      <a:prstDash val="solid"/>
+                      <a:round/>
+                      <a:headEnd type="none" w="med" len="med"/>
+                      <a:tailEnd type="none" w="med" len="med"/>
+                    </a:lnT>
+                    <a:lnB w="9525" cap="flat" cmpd="sng" algn="ctr">
+                      <a:solidFill>
+                        <a:srgbClr val="2A3448"/>
+                      </a:solidFill>
+                      <a:prstDash val="solid"/>
+                      <a:round/>
+                      <a:headEnd type="none" w="med" len="med"/>
+                      <a:tailEnd type="none" w="med" len="med"/>
+                    </a:lnB>
+                    <a:solidFill>
+                      <a:srgbClr val="0F1420"/>
+                    </a:solidFill>
+                  </a:tcPr>
+                </a:tc>
+                <a:tc>
+                  <a:txBody>
+                    <a:bodyPr/>
+                    <a:lstStyle/>
+                    <a:p>
+                      <a:pPr algn="ctr" indent="0" marL="0">
+                        <a:buNone/>
+                      </a:pPr>
+                      <a:r>
+                        <a:rPr lang="en-US" sz="1250" dirty="0">
+                          <a:solidFill>
+                            <a:srgbClr val="F5F7FA"/>
+                          </a:solidFill>
+                          <a:latin typeface="Calibri" pitchFamily="34" charset="0"/>
+                          <a:ea typeface="Calibri" pitchFamily="34" charset="-122"/>
+                          <a:cs typeface="Calibri" pitchFamily="34" charset="-120"/>
+                        </a:rPr>
+                        <a:t>0.779</a:t>
+                      </a:r>
+                      <a:endParaRPr lang="en-US" sz="1250" dirty="0">
+                        <a:latin typeface="Calibri" charset="0"/>
+                        <a:ea typeface="Calibri" charset="0"/>
+                        <a:cs typeface="Calibri" charset="0"/>
+                      </a:endParaRPr>
+                    </a:p>
+                  </a:txBody>
+                  <a:tcPr marL="91440" marR="91440" marT="45720" marB="45720" anchor="ctr">
+                    <a:lnL w="9525" cap="flat" cmpd="sng" algn="ctr">
+                      <a:solidFill>
+                        <a:srgbClr val="2A3448"/>
+                      </a:solidFill>
+                      <a:prstDash val="solid"/>
+                      <a:round/>
+                      <a:headEnd type="none" w="med" len="med"/>
+                      <a:tailEnd type="none" w="med" len="med"/>
+                    </a:lnL>
+                    <a:lnR w="9525" cap="flat" cmpd="sng" algn="ctr">
+                      <a:solidFill>
+                        <a:srgbClr val="2A3448"/>
+                      </a:solidFill>
+                      <a:prstDash val="solid"/>
+                      <a:round/>
+                      <a:headEnd type="none" w="med" len="med"/>
+                      <a:tailEnd type="none" w="med" len="med"/>
+                    </a:lnR>
+                    <a:lnT w="9525" cap="flat" cmpd="sng" algn="ctr">
+                      <a:solidFill>
+                        <a:srgbClr val="2A3448"/>
+                      </a:solidFill>
+                      <a:prstDash val="solid"/>
+                      <a:round/>
+                      <a:headEnd type="none" w="med" len="med"/>
+                      <a:tailEnd type="none" w="med" len="med"/>
+                    </a:lnT>
+                    <a:lnB w="9525" cap="flat" cmpd="sng" algn="ctr">
+                      <a:solidFill>
+                        <a:srgbClr val="2A3448"/>
+                      </a:solidFill>
+                      <a:prstDash val="solid"/>
+                      <a:round/>
+                      <a:headEnd type="none" w="med" len="med"/>
+                      <a:tailEnd type="none" w="med" len="med"/>
+                    </a:lnB>
+                    <a:solidFill>
+                      <a:srgbClr val="0F1420"/>
+                    </a:solidFill>
+                  </a:tcPr>
+                </a:tc>
+                <a:tc>
+                  <a:txBody>
+                    <a:bodyPr/>
+                    <a:lstStyle/>
+                    <a:p>
+                      <a:pPr algn="ctr" indent="0" marL="0">
+                        <a:buNone/>
+                      </a:pPr>
+                      <a:r>
+                        <a:rPr lang="en-US" sz="1250" dirty="0">
+                          <a:solidFill>
+                            <a:srgbClr val="F5F7FA"/>
+                          </a:solidFill>
+                          <a:latin typeface="Calibri" pitchFamily="34" charset="0"/>
+                          <a:ea typeface="Calibri" pitchFamily="34" charset="-122"/>
+                          <a:cs typeface="Calibri" pitchFamily="34" charset="-120"/>
+                        </a:rPr>
+                        <a:t>21%</a:t>
+                      </a:r>
+                      <a:endParaRPr lang="en-US" sz="1250" dirty="0">
+                        <a:latin typeface="Calibri" charset="0"/>
+                        <a:ea typeface="Calibri" charset="0"/>
+                        <a:cs typeface="Calibri" charset="0"/>
+                      </a:endParaRPr>
+                    </a:p>
+                  </a:txBody>
+                  <a:tcPr marL="91440" marR="91440" marT="45720" marB="45720" anchor="ctr">
+                    <a:lnL w="9525" cap="flat" cmpd="sng" algn="ctr">
+                      <a:solidFill>
+                        <a:srgbClr val="2A3448"/>
+                      </a:solidFill>
+                      <a:prstDash val="solid"/>
+                      <a:round/>
+                      <a:headEnd type="none" w="med" len="med"/>
+                      <a:tailEnd type="none" w="med" len="med"/>
+                    </a:lnL>
+                    <a:lnR w="9525" cap="flat" cmpd="sng" algn="ctr">
+                      <a:solidFill>
+                        <a:srgbClr val="2A3448"/>
+                      </a:solidFill>
+                      <a:prstDash val="solid"/>
+                      <a:round/>
+                      <a:headEnd type="none" w="med" len="med"/>
+                      <a:tailEnd type="none" w="med" len="med"/>
+                    </a:lnR>
+                    <a:lnT w="9525" cap="flat" cmpd="sng" algn="ctr">
+                      <a:solidFill>
+                        <a:srgbClr val="2A3448"/>
+                      </a:solidFill>
+                      <a:prstDash val="solid"/>
+                      <a:round/>
+                      <a:headEnd type="none" w="med" len="med"/>
+                      <a:tailEnd type="none" w="med" len="med"/>
+                    </a:lnT>
+                    <a:lnB w="9525" cap="flat" cmpd="sng" algn="ctr">
+                      <a:solidFill>
+                        <a:srgbClr val="2A3448"/>
+                      </a:solidFill>
+                      <a:prstDash val="solid"/>
+                      <a:round/>
+                      <a:headEnd type="none" w="med" len="med"/>
+                      <a:tailEnd type="none" w="med" len="med"/>
+                    </a:lnB>
+                    <a:solidFill>
+                      <a:srgbClr val="0F1420"/>
+                    </a:solidFill>
+                  </a:tcPr>
+                </a:tc>
+                <a:tc>
+                  <a:txBody>
+                    <a:bodyPr/>
+                    <a:lstStyle/>
+                    <a:p>
+                      <a:pPr algn="ctr" indent="0" marL="0">
+                        <a:buNone/>
+                      </a:pPr>
+                      <a:r>
+                        <a:rPr lang="en-US" sz="1250" dirty="0">
+                          <a:solidFill>
+                            <a:srgbClr val="F5F7FA"/>
+                          </a:solidFill>
+                          <a:latin typeface="Calibri" pitchFamily="34" charset="0"/>
+                          <a:ea typeface="Calibri" pitchFamily="34" charset="-122"/>
+                          <a:cs typeface="Calibri" pitchFamily="34" charset="-120"/>
+                        </a:rPr>
+                        <a:t>0.817</a:t>
+                      </a:r>
+                      <a:endParaRPr lang="en-US" sz="1250" dirty="0">
+                        <a:latin typeface="Calibri" charset="0"/>
+                        <a:ea typeface="Calibri" charset="0"/>
+                        <a:cs typeface="Calibri" charset="0"/>
+                      </a:endParaRPr>
+                    </a:p>
+                  </a:txBody>
+                  <a:tcPr marL="91440" marR="91440" marT="45720" marB="45720" anchor="ctr">
+                    <a:lnL w="9525" cap="flat" cmpd="sng" algn="ctr">
+                      <a:solidFill>
+                        <a:srgbClr val="2A3448"/>
+                      </a:solidFill>
+                      <a:prstDash val="solid"/>
+                      <a:round/>
+                      <a:headEnd type="none" w="med" len="med"/>
+                      <a:tailEnd type="none" w="med" len="med"/>
+                    </a:lnL>
+                    <a:lnR w="9525" cap="flat" cmpd="sng" algn="ctr">
+                      <a:solidFill>
+                        <a:srgbClr val="2A3448"/>
+                      </a:solidFill>
+                      <a:prstDash val="solid"/>
+                      <a:round/>
+                      <a:headEnd type="none" w="med" len="med"/>
+                      <a:tailEnd type="none" w="med" len="med"/>
+                    </a:lnR>
+                    <a:lnT w="9525" cap="flat" cmpd="sng" algn="ctr">
+                      <a:solidFill>
+                        <a:srgbClr val="2A3448"/>
+                      </a:solidFill>
+                      <a:prstDash val="solid"/>
+                      <a:round/>
+                      <a:headEnd type="none" w="med" len="med"/>
+                      <a:tailEnd type="none" w="med" len="med"/>
+                    </a:lnT>
+                    <a:lnB w="9525" cap="flat" cmpd="sng" algn="ctr">
+                      <a:solidFill>
+                        <a:srgbClr val="2A3448"/>
+                      </a:solidFill>
+                      <a:prstDash val="solid"/>
+                      <a:round/>
+                      <a:headEnd type="none" w="med" len="med"/>
+                      <a:tailEnd type="none" w="med" len="med"/>
+                    </a:lnB>
+                    <a:solidFill>
+                      <a:srgbClr val="0F1420"/>
+                    </a:solidFill>
+                  </a:tcPr>
+                </a:tc>
+                <a:tc>
+                  <a:txBody>
+                    <a:bodyPr/>
+                    <a:lstStyle/>
+                    <a:p>
+                      <a:pPr algn="ctr" indent="0" marL="0">
+                        <a:buNone/>
+                      </a:pPr>
+                      <a:r>
+                        <a:rPr lang="en-US" sz="1250" dirty="0">
+                          <a:solidFill>
+                            <a:srgbClr val="F5F7FA"/>
+                          </a:solidFill>
+                          <a:latin typeface="Calibri" pitchFamily="34" charset="0"/>
+                          <a:ea typeface="Calibri" pitchFamily="34" charset="-122"/>
+                          <a:cs typeface="Calibri" pitchFamily="34" charset="-120"/>
+                        </a:rPr>
+                        <a:t>0.973</a:t>
+                      </a:r>
+                      <a:endParaRPr lang="en-US" sz="1250" dirty="0">
+                        <a:latin typeface="Calibri" charset="0"/>
+                        <a:ea typeface="Calibri" charset="0"/>
+                        <a:cs typeface="Calibri" charset="0"/>
+                      </a:endParaRPr>
+                    </a:p>
+                  </a:txBody>
+                  <a:tcPr marL="91440" marR="91440" marT="45720" marB="45720" anchor="ctr">
+                    <a:lnL w="9525" cap="flat" cmpd="sng" algn="ctr">
+                      <a:solidFill>
+                        <a:srgbClr val="2A3448"/>
+                      </a:solidFill>
+                      <a:prstDash val="solid"/>
+                      <a:round/>
+                      <a:headEnd type="none" w="med" len="med"/>
+                      <a:tailEnd type="none" w="med" len="med"/>
+                    </a:lnL>
+                    <a:lnR w="9525" cap="flat" cmpd="sng" algn="ctr">
+                      <a:solidFill>
+                        <a:srgbClr val="2A3448"/>
+                      </a:solidFill>
+                      <a:prstDash val="solid"/>
+                      <a:round/>
+                      <a:headEnd type="none" w="med" len="med"/>
+                      <a:tailEnd type="none" w="med" len="med"/>
+                    </a:lnR>
+                    <a:lnT w="9525" cap="flat" cmpd="sng" algn="ctr">
+                      <a:solidFill>
+                        <a:srgbClr val="2A3448"/>
+                      </a:solidFill>
+                      <a:prstDash val="solid"/>
+                      <a:round/>
+                      <a:headEnd type="none" w="med" len="med"/>
+                      <a:tailEnd type="none" w="med" len="med"/>
+                    </a:lnT>
+                    <a:lnB w="9525" cap="flat" cmpd="sng" algn="ctr">
+                      <a:solidFill>
+                        <a:srgbClr val="2A3448"/>
+                      </a:solidFill>
+                      <a:prstDash val="solid"/>
+                      <a:round/>
+                      <a:headEnd type="none" w="med" len="med"/>
+                      <a:tailEnd type="none" w="med" len="med"/>
+                    </a:lnB>
+                    <a:solidFill>
+                      <a:srgbClr val="0F1420"/>
+                    </a:solidFill>
+                  </a:tcPr>
+                </a:tc>
+                <a:tc>
+                  <a:txBody>
+                    <a:bodyPr/>
+                    <a:lstStyle/>
+                    <a:p>
+                      <a:pPr algn="ctr" indent="0" marL="0">
+                        <a:buNone/>
+                      </a:pPr>
+                      <a:r>
+                        <a:rPr lang="en-US" sz="1250" dirty="0">
+                          <a:solidFill>
+                            <a:srgbClr val="F5F7FA"/>
+                          </a:solidFill>
+                          <a:latin typeface="Calibri" pitchFamily="34" charset="0"/>
+                          <a:ea typeface="Calibri" pitchFamily="34" charset="-122"/>
+                          <a:cs typeface="Calibri" pitchFamily="34" charset="-120"/>
+                        </a:rPr>
+                        <a:t>$0.011</a:t>
+                      </a:r>
+                      <a:endParaRPr lang="en-US" sz="1250" dirty="0">
+                        <a:latin typeface="Calibri" charset="0"/>
+                        <a:ea typeface="Calibri" charset="0"/>
+                        <a:cs typeface="Calibri" charset="0"/>
+                      </a:endParaRPr>
+                    </a:p>
+                  </a:txBody>
+                  <a:tcPr marL="91440" marR="91440" marT="45720" marB="45720" anchor="ctr">
+                    <a:lnL w="9525" cap="flat" cmpd="sng" algn="ctr">
+                      <a:solidFill>
+                        <a:srgbClr val="2A3448"/>
+                      </a:solidFill>
+                      <a:prstDash val="solid"/>
+                      <a:round/>
+                      <a:headEnd type="none" w="med" len="med"/>
+                      <a:tailEnd type="none" w="med" len="med"/>
+                    </a:lnL>
+                    <a:lnR w="9525" cap="flat" cmpd="sng" algn="ctr">
+                      <a:solidFill>
+                        <a:srgbClr val="2A3448"/>
+                      </a:solidFill>
+                      <a:prstDash val="solid"/>
+                      <a:round/>
+                      <a:headEnd type="none" w="med" len="med"/>
+                      <a:tailEnd type="none" w="med" len="med"/>
+                    </a:lnR>
+                    <a:lnT w="9525" cap="flat" cmpd="sng" algn="ctr">
+                      <a:solidFill>
+                        <a:srgbClr val="2A3448"/>
+                      </a:solidFill>
+                      <a:prstDash val="solid"/>
+                      <a:round/>
+                      <a:headEnd type="none" w="med" len="med"/>
+                      <a:tailEnd type="none" w="med" len="med"/>
+                    </a:lnT>
+                    <a:lnB w="9525" cap="flat" cmpd="sng" algn="ctr">
+                      <a:solidFill>
+                        <a:srgbClr val="2A3448"/>
+                      </a:solidFill>
+                      <a:prstDash val="solid"/>
+                      <a:round/>
+                      <a:headEnd type="none" w="med" len="med"/>
+                      <a:tailEnd type="none" w="med" len="med"/>
+                    </a:lnB>
+                    <a:solidFill>
+                      <a:srgbClr val="0F1420"/>
+                    </a:solidFill>
+                  </a:tcPr>
+                </a:tc>
+              </a:tr>
+              <a:tr h="338328">
+                <a:tc>
+                  <a:txBody>
+                    <a:bodyPr/>
+                    <a:lstStyle/>
+                    <a:p>
+                      <a:pPr algn="ctr" indent="0" marL="0">
+                        <a:buNone/>
+                      </a:pPr>
+                      <a:r>
+                        <a:rPr lang="en-US" sz="1250" dirty="0">
+                          <a:solidFill>
+                            <a:srgbClr val="F5F7FA"/>
+                          </a:solidFill>
+                          <a:latin typeface="Calibri" pitchFamily="34" charset="0"/>
+                          <a:ea typeface="Calibri" pitchFamily="34" charset="-122"/>
+                          <a:cs typeface="Calibri" pitchFamily="34" charset="-120"/>
+                        </a:rPr>
+                        <a:t>Llama-3.2-3B</a:t>
+                      </a:r>
+                      <a:endParaRPr lang="en-US" sz="1250" dirty="0">
+                        <a:latin typeface="Calibri" charset="0"/>
+                        <a:ea typeface="Calibri" charset="0"/>
+                        <a:cs typeface="Calibri" charset="0"/>
+                      </a:endParaRPr>
+                    </a:p>
+                  </a:txBody>
+                  <a:tcPr marL="91440" marR="91440" marT="45720" marB="45720" anchor="ctr">
+                    <a:lnL w="9525" cap="flat" cmpd="sng" algn="ctr">
+                      <a:solidFill>
+                        <a:srgbClr val="2A3448"/>
+                      </a:solidFill>
+                      <a:prstDash val="solid"/>
+                      <a:round/>
+                      <a:headEnd type="none" w="med" len="med"/>
+                      <a:tailEnd type="none" w="med" len="med"/>
+                    </a:lnL>
+                    <a:lnR w="9525" cap="flat" cmpd="sng" algn="ctr">
+                      <a:solidFill>
+                        <a:srgbClr val="2A3448"/>
+                      </a:solidFill>
+                      <a:prstDash val="solid"/>
+                      <a:round/>
+                      <a:headEnd type="none" w="med" len="med"/>
+                      <a:tailEnd type="none" w="med" len="med"/>
+                    </a:lnR>
+                    <a:lnT w="9525" cap="flat" cmpd="sng" algn="ctr">
+                      <a:solidFill>
+                        <a:srgbClr val="2A3448"/>
+                      </a:solidFill>
+                      <a:prstDash val="solid"/>
+                      <a:round/>
+                      <a:headEnd type="none" w="med" len="med"/>
+                      <a:tailEnd type="none" w="med" len="med"/>
+                    </a:lnT>
+                    <a:lnB w="9525" cap="flat" cmpd="sng" algn="ctr">
+                      <a:solidFill>
+                        <a:srgbClr val="2A3448"/>
+                      </a:solidFill>
+                      <a:prstDash val="solid"/>
+                      <a:round/>
+                      <a:headEnd type="none" w="med" len="med"/>
+                      <a:tailEnd type="none" w="med" len="med"/>
+                    </a:lnB>
+                    <a:solidFill>
+                      <a:srgbClr val="0F1420"/>
+                    </a:solidFill>
+                  </a:tcPr>
+                </a:tc>
+                <a:tc>
+                  <a:txBody>
+                    <a:bodyPr/>
+                    <a:lstStyle/>
+                    <a:p>
+                      <a:pPr algn="ctr" indent="0" marL="0">
+                        <a:buNone/>
+                      </a:pPr>
+                      <a:r>
+                        <a:rPr lang="en-US" sz="1250" dirty="0">
+                          <a:solidFill>
+                            <a:srgbClr val="F5F7FA"/>
+                          </a:solidFill>
+                          <a:latin typeface="Calibri" pitchFamily="34" charset="0"/>
+                          <a:ea typeface="Calibri" pitchFamily="34" charset="-122"/>
+                          <a:cs typeface="Calibri" pitchFamily="34" charset="-120"/>
+                        </a:rPr>
+                        <a:t>0.850 (0.832-0.868)</a:t>
+                      </a:r>
+                      <a:endParaRPr lang="en-US" sz="1250" dirty="0">
+                        <a:latin typeface="Calibri" charset="0"/>
+                        <a:ea typeface="Calibri" charset="0"/>
+                        <a:cs typeface="Calibri" charset="0"/>
+                      </a:endParaRPr>
+                    </a:p>
+                  </a:txBody>
+                  <a:tcPr marL="91440" marR="91440" marT="45720" marB="45720" anchor="ctr">
+                    <a:lnL w="9525" cap="flat" cmpd="sng" algn="ctr">
+                      <a:solidFill>
+                        <a:srgbClr val="2A3448"/>
+                      </a:solidFill>
+                      <a:prstDash val="solid"/>
+                      <a:round/>
+                      <a:headEnd type="none" w="med" len="med"/>
+                      <a:tailEnd type="none" w="med" len="med"/>
+                    </a:lnL>
+                    <a:lnR w="9525" cap="flat" cmpd="sng" algn="ctr">
+                      <a:solidFill>
+                        <a:srgbClr val="2A3448"/>
+                      </a:solidFill>
+                      <a:prstDash val="solid"/>
+                      <a:round/>
+                      <a:headEnd type="none" w="med" len="med"/>
+                      <a:tailEnd type="none" w="med" len="med"/>
+                    </a:lnR>
+                    <a:lnT w="9525" cap="flat" cmpd="sng" algn="ctr">
+                      <a:solidFill>
+                        <a:srgbClr val="2A3448"/>
+                      </a:solidFill>
+                      <a:prstDash val="solid"/>
+                      <a:round/>
+                      <a:headEnd type="none" w="med" len="med"/>
+                      <a:tailEnd type="none" w="med" len="med"/>
+                    </a:lnT>
+                    <a:lnB w="9525" cap="flat" cmpd="sng" algn="ctr">
+                      <a:solidFill>
+                        <a:srgbClr val="2A3448"/>
+                      </a:solidFill>
+                      <a:prstDash val="solid"/>
+                      <a:round/>
+                      <a:headEnd type="none" w="med" len="med"/>
+                      <a:tailEnd type="none" w="med" len="med"/>
+                    </a:lnB>
+                    <a:solidFill>
+                      <a:srgbClr val="0F1420"/>
+                    </a:solidFill>
+                  </a:tcPr>
+                </a:tc>
+                <a:tc>
+                  <a:txBody>
+                    <a:bodyPr/>
+                    <a:lstStyle/>
+                    <a:p>
+                      <a:pPr algn="ctr" indent="0" marL="0">
+                        <a:buNone/>
+                      </a:pPr>
+                      <a:r>
+                        <a:rPr lang="en-US" sz="1250" dirty="0">
+                          <a:solidFill>
+                            <a:srgbClr val="F5F7FA"/>
+                          </a:solidFill>
+                          <a:latin typeface="Calibri" pitchFamily="34" charset="0"/>
+                          <a:ea typeface="Calibri" pitchFamily="34" charset="-122"/>
+                          <a:cs typeface="Calibri" pitchFamily="34" charset="-120"/>
+                        </a:rPr>
+                        <a:t>0.799</a:t>
+                      </a:r>
+                      <a:endParaRPr lang="en-US" sz="1250" dirty="0">
+                        <a:latin typeface="Calibri" charset="0"/>
+                        <a:ea typeface="Calibri" charset="0"/>
+                        <a:cs typeface="Calibri" charset="0"/>
+                      </a:endParaRPr>
+                    </a:p>
+                  </a:txBody>
+                  <a:tcPr marL="91440" marR="91440" marT="45720" marB="45720" anchor="ctr">
+                    <a:lnL w="9525" cap="flat" cmpd="sng" algn="ctr">
+                      <a:solidFill>
+                        <a:srgbClr val="2A3448"/>
+                      </a:solidFill>
+                      <a:prstDash val="solid"/>
+                      <a:round/>
+                      <a:headEnd type="none" w="med" len="med"/>
+                      <a:tailEnd type="none" w="med" len="med"/>
+                    </a:lnL>
+                    <a:lnR w="9525" cap="flat" cmpd="sng" algn="ctr">
+                      <a:solidFill>
+                        <a:srgbClr val="2A3448"/>
+                      </a:solidFill>
+                      <a:prstDash val="solid"/>
+                      <a:round/>
+                      <a:headEnd type="none" w="med" len="med"/>
+                      <a:tailEnd type="none" w="med" len="med"/>
+                    </a:lnR>
+                    <a:lnT w="9525" cap="flat" cmpd="sng" algn="ctr">
+                      <a:solidFill>
+                        <a:srgbClr val="2A3448"/>
+                      </a:solidFill>
+                      <a:prstDash val="solid"/>
+                      <a:round/>
+                      <a:headEnd type="none" w="med" len="med"/>
+                      <a:tailEnd type="none" w="med" len="med"/>
+                    </a:lnT>
+                    <a:lnB w="9525" cap="flat" cmpd="sng" algn="ctr">
+                      <a:solidFill>
+                        <a:srgbClr val="2A3448"/>
+                      </a:solidFill>
+                      <a:prstDash val="solid"/>
+                      <a:round/>
+                      <a:headEnd type="none" w="med" len="med"/>
+                      <a:tailEnd type="none" w="med" len="med"/>
+                    </a:lnB>
+                    <a:solidFill>
+                      <a:srgbClr val="0F1420"/>
+                    </a:solidFill>
+                  </a:tcPr>
+                </a:tc>
+                <a:tc>
+                  <a:txBody>
+                    <a:bodyPr/>
+                    <a:lstStyle/>
+                    <a:p>
+                      <a:pPr algn="ctr" indent="0" marL="0">
+                        <a:buNone/>
+                      </a:pPr>
+                      <a:r>
+                        <a:rPr lang="en-US" sz="1250" dirty="0">
+                          <a:solidFill>
+                            <a:srgbClr val="F5F7FA"/>
+                          </a:solidFill>
+                          <a:latin typeface="Calibri" pitchFamily="34" charset="0"/>
+                          <a:ea typeface="Calibri" pitchFamily="34" charset="-122"/>
+                          <a:cs typeface="Calibri" pitchFamily="34" charset="-120"/>
+                        </a:rPr>
+                        <a:t>5%</a:t>
+                      </a:r>
+                      <a:endParaRPr lang="en-US" sz="1250" dirty="0">
+                        <a:latin typeface="Calibri" charset="0"/>
+                        <a:ea typeface="Calibri" charset="0"/>
+                        <a:cs typeface="Calibri" charset="0"/>
+                      </a:endParaRPr>
+                    </a:p>
+                  </a:txBody>
+                  <a:tcPr marL="91440" marR="91440" marT="45720" marB="45720" anchor="ctr">
+                    <a:lnL w="9525" cap="flat" cmpd="sng" algn="ctr">
+                      <a:solidFill>
+                        <a:srgbClr val="2A3448"/>
+                      </a:solidFill>
+                      <a:prstDash val="solid"/>
+                      <a:round/>
+                      <a:headEnd type="none" w="med" len="med"/>
+                      <a:tailEnd type="none" w="med" len="med"/>
+                    </a:lnL>
+                    <a:lnR w="9525" cap="flat" cmpd="sng" algn="ctr">
+                      <a:solidFill>
+                        <a:srgbClr val="2A3448"/>
+                      </a:solidFill>
+                      <a:prstDash val="solid"/>
+                      <a:round/>
+                      <a:headEnd type="none" w="med" len="med"/>
+                      <a:tailEnd type="none" w="med" len="med"/>
+                    </a:lnR>
+                    <a:lnT w="9525" cap="flat" cmpd="sng" algn="ctr">
+                      <a:solidFill>
+                        <a:srgbClr val="2A3448"/>
+                      </a:solidFill>
+                      <a:prstDash val="solid"/>
+                      <a:round/>
+                      <a:headEnd type="none" w="med" len="med"/>
+                      <a:tailEnd type="none" w="med" len="med"/>
+                    </a:lnT>
+                    <a:lnB w="9525" cap="flat" cmpd="sng" algn="ctr">
+                      <a:solidFill>
+                        <a:srgbClr val="2A3448"/>
+                      </a:solidFill>
+                      <a:prstDash val="solid"/>
+                      <a:round/>
+                      <a:headEnd type="none" w="med" len="med"/>
+                      <a:tailEnd type="none" w="med" len="med"/>
+                    </a:lnB>
+                    <a:solidFill>
+                      <a:srgbClr val="0F1420"/>
+                    </a:solidFill>
+                  </a:tcPr>
+                </a:tc>
+                <a:tc>
+                  <a:txBody>
+                    <a:bodyPr/>
+                    <a:lstStyle/>
+                    <a:p>
+                      <a:pPr algn="ctr" indent="0" marL="0">
+                        <a:buNone/>
+                      </a:pPr>
+                      <a:r>
+                        <a:rPr lang="en-US" sz="1250" dirty="0">
+                          <a:solidFill>
+                            <a:srgbClr val="F5F7FA"/>
+                          </a:solidFill>
+                          <a:latin typeface="Calibri" pitchFamily="34" charset="0"/>
+                          <a:ea typeface="Calibri" pitchFamily="34" charset="-122"/>
+                          <a:cs typeface="Calibri" pitchFamily="34" charset="-120"/>
+                        </a:rPr>
+                        <a:t>0.507</a:t>
+                      </a:r>
+                      <a:endParaRPr lang="en-US" sz="1250" dirty="0">
+                        <a:latin typeface="Calibri" charset="0"/>
+                        <a:ea typeface="Calibri" charset="0"/>
+                        <a:cs typeface="Calibri" charset="0"/>
+                      </a:endParaRPr>
+                    </a:p>
+                  </a:txBody>
+                  <a:tcPr marL="91440" marR="91440" marT="45720" marB="45720" anchor="ctr">
+                    <a:lnL w="9525" cap="flat" cmpd="sng" algn="ctr">
+                      <a:solidFill>
+                        <a:srgbClr val="2A3448"/>
+                      </a:solidFill>
+                      <a:prstDash val="solid"/>
+                      <a:round/>
+                      <a:headEnd type="none" w="med" len="med"/>
+                      <a:tailEnd type="none" w="med" len="med"/>
+                    </a:lnL>
+                    <a:lnR w="9525" cap="flat" cmpd="sng" algn="ctr">
+                      <a:solidFill>
+                        <a:srgbClr val="2A3448"/>
+                      </a:solidFill>
+                      <a:prstDash val="solid"/>
+                      <a:round/>
+                      <a:headEnd type="none" w="med" len="med"/>
+                      <a:tailEnd type="none" w="med" len="med"/>
+                    </a:lnR>
+                    <a:lnT w="9525" cap="flat" cmpd="sng" algn="ctr">
+                      <a:solidFill>
+                        <a:srgbClr val="2A3448"/>
+                      </a:solidFill>
+                      <a:prstDash val="solid"/>
+                      <a:round/>
+                      <a:headEnd type="none" w="med" len="med"/>
+                      <a:tailEnd type="none" w="med" len="med"/>
+                    </a:lnT>
+                    <a:lnB w="9525" cap="flat" cmpd="sng" algn="ctr">
+                      <a:solidFill>
+                        <a:srgbClr val="2A3448"/>
+                      </a:solidFill>
+                      <a:prstDash val="solid"/>
+                      <a:round/>
+                      <a:headEnd type="none" w="med" len="med"/>
+                      <a:tailEnd type="none" w="med" len="med"/>
+                    </a:lnB>
+                    <a:solidFill>
+                      <a:srgbClr val="0F1420"/>
+                    </a:solidFill>
+                  </a:tcPr>
+                </a:tc>
+                <a:tc>
+                  <a:txBody>
+                    <a:bodyPr/>
+                    <a:lstStyle/>
+                    <a:p>
+                      <a:pPr algn="ctr" indent="0" marL="0">
+                        <a:buNone/>
+                      </a:pPr>
+                      <a:r>
+                        <a:rPr lang="en-US" sz="1250" dirty="0">
+                          <a:solidFill>
+                            <a:srgbClr val="F5F7FA"/>
+                          </a:solidFill>
+                          <a:latin typeface="Calibri" pitchFamily="34" charset="0"/>
+                          <a:ea typeface="Calibri" pitchFamily="34" charset="-122"/>
+                          <a:cs typeface="Calibri" pitchFamily="34" charset="-120"/>
+                        </a:rPr>
+                        <a:t>0.827</a:t>
+                      </a:r>
+                      <a:endParaRPr lang="en-US" sz="1250" dirty="0">
+                        <a:latin typeface="Calibri" charset="0"/>
+                        <a:ea typeface="Calibri" charset="0"/>
+                        <a:cs typeface="Calibri" charset="0"/>
+                      </a:endParaRPr>
+                    </a:p>
+                  </a:txBody>
+                  <a:tcPr marL="91440" marR="91440" marT="45720" marB="45720" anchor="ctr">
+                    <a:lnL w="9525" cap="flat" cmpd="sng" algn="ctr">
+                      <a:solidFill>
+                        <a:srgbClr val="2A3448"/>
+                      </a:solidFill>
+                      <a:prstDash val="solid"/>
+                      <a:round/>
+                      <a:headEnd type="none" w="med" len="med"/>
+                      <a:tailEnd type="none" w="med" len="med"/>
+                    </a:lnL>
+                    <a:lnR w="9525" cap="flat" cmpd="sng" algn="ctr">
+                      <a:solidFill>
+                        <a:srgbClr val="2A3448"/>
+                      </a:solidFill>
+                      <a:prstDash val="solid"/>
+                      <a:round/>
+                      <a:headEnd type="none" w="med" len="med"/>
+                      <a:tailEnd type="none" w="med" len="med"/>
+                    </a:lnR>
+                    <a:lnT w="9525" cap="flat" cmpd="sng" algn="ctr">
+                      <a:solidFill>
+                        <a:srgbClr val="2A3448"/>
+                      </a:solidFill>
+                      <a:prstDash val="solid"/>
+                      <a:round/>
+                      <a:headEnd type="none" w="med" len="med"/>
+                      <a:tailEnd type="none" w="med" len="med"/>
+                    </a:lnT>
+                    <a:lnB w="9525" cap="flat" cmpd="sng" algn="ctr">
+                      <a:solidFill>
+                        <a:srgbClr val="2A3448"/>
+                      </a:solidFill>
+                      <a:prstDash val="solid"/>
+                      <a:round/>
+                      <a:headEnd type="none" w="med" len="med"/>
+                      <a:tailEnd type="none" w="med" len="med"/>
+                    </a:lnB>
+                    <a:solidFill>
+                      <a:srgbClr val="0F1420"/>
+                    </a:solidFill>
+                  </a:tcPr>
+                </a:tc>
+                <a:tc>
+                  <a:txBody>
+                    <a:bodyPr/>
+                    <a:lstStyle/>
+                    <a:p>
+                      <a:pPr algn="ctr" indent="0" marL="0">
+                        <a:buNone/>
+                      </a:pPr>
+                      <a:r>
+                        <a:rPr lang="en-US" sz="1250" dirty="0">
+                          <a:solidFill>
+                            <a:srgbClr val="F5F7FA"/>
+                          </a:solidFill>
+                          <a:latin typeface="Calibri" pitchFamily="34" charset="0"/>
+                          <a:ea typeface="Calibri" pitchFamily="34" charset="-122"/>
+                          <a:cs typeface="Calibri" pitchFamily="34" charset="-120"/>
+                        </a:rPr>
+                        <a:t>$0.016</a:t>
+                      </a:r>
+                      <a:endParaRPr lang="en-US" sz="1250" dirty="0">
+                        <a:latin typeface="Calibri" charset="0"/>
+                        <a:ea typeface="Calibri" charset="0"/>
+                        <a:cs typeface="Calibri" charset="0"/>
+                      </a:endParaRPr>
+                    </a:p>
+                  </a:txBody>
+                  <a:tcPr marL="91440" marR="91440" marT="45720" marB="45720" anchor="ctr">
+                    <a:lnL w="9525" cap="flat" cmpd="sng" algn="ctr">
+                      <a:solidFill>
+                        <a:srgbClr val="2A3448"/>
+                      </a:solidFill>
+                      <a:prstDash val="solid"/>
+                      <a:round/>
+                      <a:headEnd type="none" w="med" len="med"/>
+                      <a:tailEnd type="none" w="med" len="med"/>
+                    </a:lnL>
+                    <a:lnR w="9525" cap="flat" cmpd="sng" algn="ctr">
+                      <a:solidFill>
+                        <a:srgbClr val="2A3448"/>
+                      </a:solidFill>
+                      <a:prstDash val="solid"/>
+                      <a:round/>
+                      <a:headEnd type="none" w="med" len="med"/>
+                      <a:tailEnd type="none" w="med" len="med"/>
+                    </a:lnR>
+                    <a:lnT w="9525" cap="flat" cmpd="sng" algn="ctr">
+                      <a:solidFill>
+                        <a:srgbClr val="2A3448"/>
+                      </a:solidFill>
+                      <a:prstDash val="solid"/>
+                      <a:round/>
+                      <a:headEnd type="none" w="med" len="med"/>
+                      <a:tailEnd type="none" w="med" len="med"/>
+                    </a:lnT>
+                    <a:lnB w="9525" cap="flat" cmpd="sng" algn="ctr">
+                      <a:solidFill>
+                        <a:srgbClr val="2A3448"/>
+                      </a:solidFill>
+                      <a:prstDash val="solid"/>
+                      <a:round/>
+                      <a:headEnd type="none" w="med" len="med"/>
+                      <a:tailEnd type="none" w="med" len="med"/>
+                    </a:lnB>
+                    <a:solidFill>
+                      <a:srgbClr val="0F1420"/>
+                    </a:solidFill>
+                  </a:tcPr>
+                </a:tc>
+              </a:tr>
+              <a:tr h="338328">
+                <a:tc>
+                  <a:txBody>
+                    <a:bodyPr/>
+                    <a:lstStyle/>
+                    <a:p>
+                      <a:pPr algn="ctr" indent="0" marL="0">
+                        <a:buNone/>
+                      </a:pPr>
+                      <a:r>
+                        <a:rPr lang="en-US" sz="1250" dirty="0">
+                          <a:solidFill>
+                            <a:srgbClr val="F5F7FA"/>
+                          </a:solidFill>
+                          <a:latin typeface="Calibri" pitchFamily="34" charset="0"/>
+                          <a:ea typeface="Calibri" pitchFamily="34" charset="-122"/>
+                          <a:cs typeface="Calibri" pitchFamily="34" charset="-120"/>
+                        </a:rPr>
+                        <a:t>Phi-4-14B</a:t>
+                      </a:r>
+                      <a:endParaRPr lang="en-US" sz="1250" dirty="0">
+                        <a:latin typeface="Calibri" charset="0"/>
+                        <a:ea typeface="Calibri" charset="0"/>
+                        <a:cs typeface="Calibri" charset="0"/>
+                      </a:endParaRPr>
+                    </a:p>
+                  </a:txBody>
+                  <a:tcPr marL="91440" marR="91440" marT="45720" marB="45720" anchor="ctr">
+                    <a:lnL w="9525" cap="flat" cmpd="sng" algn="ctr">
+                      <a:solidFill>
+                        <a:srgbClr val="2A3448"/>
+                      </a:solidFill>
+                      <a:prstDash val="solid"/>
+                      <a:round/>
+                      <a:headEnd type="none" w="med" len="med"/>
+                      <a:tailEnd type="none" w="med" len="med"/>
+                    </a:lnL>
+                    <a:lnR w="9525" cap="flat" cmpd="sng" algn="ctr">
+                      <a:solidFill>
+                        <a:srgbClr val="2A3448"/>
+                      </a:solidFill>
+                      <a:prstDash val="solid"/>
+                      <a:round/>
+                      <a:headEnd type="none" w="med" len="med"/>
+                      <a:tailEnd type="none" w="med" len="med"/>
+                    </a:lnR>
+                    <a:lnT w="9525" cap="flat" cmpd="sng" algn="ctr">
+                      <a:solidFill>
+                        <a:srgbClr val="2A3448"/>
+                      </a:solidFill>
+                      <a:prstDash val="solid"/>
+                      <a:round/>
+                      <a:headEnd type="none" w="med" len="med"/>
+                      <a:tailEnd type="none" w="med" len="med"/>
+                    </a:lnT>
+                    <a:lnB w="9525" cap="flat" cmpd="sng" algn="ctr">
+                      <a:solidFill>
+                        <a:srgbClr val="2A3448"/>
+                      </a:solidFill>
+                      <a:prstDash val="solid"/>
+                      <a:round/>
+                      <a:headEnd type="none" w="med" len="med"/>
+                      <a:tailEnd type="none" w="med" len="med"/>
+                    </a:lnB>
+                    <a:solidFill>
+                      <a:srgbClr val="0F1420"/>
+                    </a:solidFill>
+                  </a:tcPr>
+                </a:tc>
+                <a:tc>
+                  <a:txBody>
+                    <a:bodyPr/>
+                    <a:lstStyle/>
+                    <a:p>
+                      <a:pPr algn="ctr" indent="0" marL="0">
+                        <a:buNone/>
+                      </a:pPr>
+                      <a:r>
+                        <a:rPr lang="en-US" sz="1250" dirty="0">
+                          <a:solidFill>
+                            <a:srgbClr val="F5F7FA"/>
+                          </a:solidFill>
+                          <a:latin typeface="Calibri" pitchFamily="34" charset="0"/>
+                          <a:ea typeface="Calibri" pitchFamily="34" charset="-122"/>
+                          <a:cs typeface="Calibri" pitchFamily="34" charset="-120"/>
+                        </a:rPr>
+                        <a:t>0.727 (0.702-0.749)</a:t>
+                      </a:r>
+                      <a:endParaRPr lang="en-US" sz="1250" dirty="0">
+                        <a:latin typeface="Calibri" charset="0"/>
+                        <a:ea typeface="Calibri" charset="0"/>
+                        <a:cs typeface="Calibri" charset="0"/>
+                      </a:endParaRPr>
+                    </a:p>
+                  </a:txBody>
+                  <a:tcPr marL="91440" marR="91440" marT="45720" marB="45720" anchor="ctr">
+                    <a:lnL w="9525" cap="flat" cmpd="sng" algn="ctr">
+                      <a:solidFill>
+                        <a:srgbClr val="2A3448"/>
+                      </a:solidFill>
+                      <a:prstDash val="solid"/>
+                      <a:round/>
+                      <a:headEnd type="none" w="med" len="med"/>
+                      <a:tailEnd type="none" w="med" len="med"/>
+                    </a:lnL>
+                    <a:lnR w="9525" cap="flat" cmpd="sng" algn="ctr">
+                      <a:solidFill>
+                        <a:srgbClr val="2A3448"/>
+                      </a:solidFill>
+                      <a:prstDash val="solid"/>
+                      <a:round/>
+                      <a:headEnd type="none" w="med" len="med"/>
+                      <a:tailEnd type="none" w="med" len="med"/>
+                    </a:lnR>
+                    <a:lnT w="9525" cap="flat" cmpd="sng" algn="ctr">
+                      <a:solidFill>
+                        <a:srgbClr val="2A3448"/>
+                      </a:solidFill>
+                      <a:prstDash val="solid"/>
+                      <a:round/>
+                      <a:headEnd type="none" w="med" len="med"/>
+                      <a:tailEnd type="none" w="med" len="med"/>
+                    </a:lnT>
+                    <a:lnB w="9525" cap="flat" cmpd="sng" algn="ctr">
+                      <a:solidFill>
+                        <a:srgbClr val="2A3448"/>
+                      </a:solidFill>
+                      <a:prstDash val="solid"/>
+                      <a:round/>
+                      <a:headEnd type="none" w="med" len="med"/>
+                      <a:tailEnd type="none" w="med" len="med"/>
+                    </a:lnB>
+                    <a:solidFill>
+                      <a:srgbClr val="0F1420"/>
+                    </a:solidFill>
+                  </a:tcPr>
+                </a:tc>
+                <a:tc>
+                  <a:txBody>
+                    <a:bodyPr/>
+                    <a:lstStyle/>
+                    <a:p>
+                      <a:pPr algn="ctr" indent="0" marL="0">
+                        <a:buNone/>
+                      </a:pPr>
+                      <a:r>
+                        <a:rPr lang="en-US" sz="1250" dirty="0">
+                          <a:solidFill>
+                            <a:srgbClr val="F5F7FA"/>
+                          </a:solidFill>
+                          <a:latin typeface="Calibri" pitchFamily="34" charset="0"/>
+                          <a:ea typeface="Calibri" pitchFamily="34" charset="-122"/>
+                          <a:cs typeface="Calibri" pitchFamily="34" charset="-120"/>
+                        </a:rPr>
+                        <a:t>0.621</a:t>
+                      </a:r>
+                      <a:endParaRPr lang="en-US" sz="1250" dirty="0">
+                        <a:latin typeface="Calibri" charset="0"/>
+                        <a:ea typeface="Calibri" charset="0"/>
+                        <a:cs typeface="Calibri" charset="0"/>
+                      </a:endParaRPr>
+                    </a:p>
+                  </a:txBody>
+                  <a:tcPr marL="91440" marR="91440" marT="45720" marB="45720" anchor="ctr">
+                    <a:lnL w="9525" cap="flat" cmpd="sng" algn="ctr">
+                      <a:solidFill>
+                        <a:srgbClr val="2A3448"/>
+                      </a:solidFill>
+                      <a:prstDash val="solid"/>
+                      <a:round/>
+                      <a:headEnd type="none" w="med" len="med"/>
+                      <a:tailEnd type="none" w="med" len="med"/>
+                    </a:lnL>
+                    <a:lnR w="9525" cap="flat" cmpd="sng" algn="ctr">
+                      <a:solidFill>
+                        <a:srgbClr val="2A3448"/>
+                      </a:solidFill>
+                      <a:prstDash val="solid"/>
+                      <a:round/>
+                      <a:headEnd type="none" w="med" len="med"/>
+                      <a:tailEnd type="none" w="med" len="med"/>
+                    </a:lnR>
+                    <a:lnT w="9525" cap="flat" cmpd="sng" algn="ctr">
+                      <a:solidFill>
+                        <a:srgbClr val="2A3448"/>
+                      </a:solidFill>
+                      <a:prstDash val="solid"/>
+                      <a:round/>
+                      <a:headEnd type="none" w="med" len="med"/>
+                      <a:tailEnd type="none" w="med" len="med"/>
+                    </a:lnT>
+                    <a:lnB w="9525" cap="flat" cmpd="sng" algn="ctr">
+                      <a:solidFill>
+                        <a:srgbClr val="2A3448"/>
+                      </a:solidFill>
+                      <a:prstDash val="solid"/>
+                      <a:round/>
+                      <a:headEnd type="none" w="med" len="med"/>
+                      <a:tailEnd type="none" w="med" len="med"/>
+                    </a:lnB>
+                    <a:solidFill>
+                      <a:srgbClr val="0F1420"/>
+                    </a:solidFill>
+                  </a:tcPr>
+                </a:tc>
+                <a:tc>
+                  <a:txBody>
+                    <a:bodyPr/>
+                    <a:lstStyle/>
+                    <a:p>
+                      <a:pPr algn="ctr" indent="0" marL="0">
+                        <a:buNone/>
+                      </a:pPr>
+                      <a:r>
+                        <a:rPr lang="en-US" sz="1250" dirty="0">
+                          <a:solidFill>
+                            <a:srgbClr val="F5F7FA"/>
+                          </a:solidFill>
+                          <a:latin typeface="Calibri" pitchFamily="34" charset="0"/>
+                          <a:ea typeface="Calibri" pitchFamily="34" charset="-122"/>
+                          <a:cs typeface="Calibri" pitchFamily="34" charset="-120"/>
+                        </a:rPr>
+                        <a:t>28%</a:t>
+                      </a:r>
+                      <a:endParaRPr lang="en-US" sz="1250" dirty="0">
+                        <a:latin typeface="Calibri" charset="0"/>
+                        <a:ea typeface="Calibri" charset="0"/>
+                        <a:cs typeface="Calibri" charset="0"/>
+                      </a:endParaRPr>
+                    </a:p>
+                  </a:txBody>
+                  <a:tcPr marL="91440" marR="91440" marT="45720" marB="45720" anchor="ctr">
+                    <a:lnL w="9525" cap="flat" cmpd="sng" algn="ctr">
+                      <a:solidFill>
+                        <a:srgbClr val="2A3448"/>
+                      </a:solidFill>
+                      <a:prstDash val="solid"/>
+                      <a:round/>
+                      <a:headEnd type="none" w="med" len="med"/>
+                      <a:tailEnd type="none" w="med" len="med"/>
+                    </a:lnL>
+                    <a:lnR w="9525" cap="flat" cmpd="sng" algn="ctr">
+                      <a:solidFill>
+                        <a:srgbClr val="2A3448"/>
+                      </a:solidFill>
+                      <a:prstDash val="solid"/>
+                      <a:round/>
+                      <a:headEnd type="none" w="med" len="med"/>
+                      <a:tailEnd type="none" w="med" len="med"/>
+                    </a:lnR>
+                    <a:lnT w="9525" cap="flat" cmpd="sng" algn="ctr">
+                      <a:solidFill>
+                        <a:srgbClr val="2A3448"/>
+                      </a:solidFill>
+                      <a:prstDash val="solid"/>
+                      <a:round/>
+                      <a:headEnd type="none" w="med" len="med"/>
+                      <a:tailEnd type="none" w="med" len="med"/>
+                    </a:lnT>
+                    <a:lnB w="9525" cap="flat" cmpd="sng" algn="ctr">
+                      <a:solidFill>
+                        <a:srgbClr val="2A3448"/>
+                      </a:solidFill>
+                      <a:prstDash val="solid"/>
+                      <a:round/>
+                      <a:headEnd type="none" w="med" len="med"/>
+                      <a:tailEnd type="none" w="med" len="med"/>
+                    </a:lnB>
+                    <a:solidFill>
+                      <a:srgbClr val="0F1420"/>
+                    </a:solidFill>
+                  </a:tcPr>
+                </a:tc>
+                <a:tc>
+                  <a:txBody>
+                    <a:bodyPr/>
+                    <a:lstStyle/>
+                    <a:p>
+                      <a:pPr algn="ctr" indent="0" marL="0">
+                        <a:buNone/>
+                      </a:pPr>
+                      <a:r>
+                        <a:rPr lang="en-US" sz="1250" dirty="0">
+                          <a:solidFill>
+                            <a:srgbClr val="F5F7FA"/>
+                          </a:solidFill>
+                          <a:latin typeface="Calibri" pitchFamily="34" charset="0"/>
+                          <a:ea typeface="Calibri" pitchFamily="34" charset="-122"/>
+                          <a:cs typeface="Calibri" pitchFamily="34" charset="-120"/>
+                        </a:rPr>
+                        <a:t>0.759</a:t>
+                      </a:r>
+                      <a:endParaRPr lang="en-US" sz="1250" dirty="0">
+                        <a:latin typeface="Calibri" charset="0"/>
+                        <a:ea typeface="Calibri" charset="0"/>
+                        <a:cs typeface="Calibri" charset="0"/>
+                      </a:endParaRPr>
+                    </a:p>
+                  </a:txBody>
+                  <a:tcPr marL="91440" marR="91440" marT="45720" marB="45720" anchor="ctr">
+                    <a:lnL w="9525" cap="flat" cmpd="sng" algn="ctr">
+                      <a:solidFill>
+                        <a:srgbClr val="2A3448"/>
+                      </a:solidFill>
+                      <a:prstDash val="solid"/>
+                      <a:round/>
+                      <a:headEnd type="none" w="med" len="med"/>
+                      <a:tailEnd type="none" w="med" len="med"/>
+                    </a:lnL>
+                    <a:lnR w="9525" cap="flat" cmpd="sng" algn="ctr">
+                      <a:solidFill>
+                        <a:srgbClr val="2A3448"/>
+                      </a:solidFill>
+                      <a:prstDash val="solid"/>
+                      <a:round/>
+                      <a:headEnd type="none" w="med" len="med"/>
+                      <a:tailEnd type="none" w="med" len="med"/>
+                    </a:lnR>
+                    <a:lnT w="9525" cap="flat" cmpd="sng" algn="ctr">
+                      <a:solidFill>
+                        <a:srgbClr val="2A3448"/>
+                      </a:solidFill>
+                      <a:prstDash val="solid"/>
+                      <a:round/>
+                      <a:headEnd type="none" w="med" len="med"/>
+                      <a:tailEnd type="none" w="med" len="med"/>
+                    </a:lnT>
+                    <a:lnB w="9525" cap="flat" cmpd="sng" algn="ctr">
+                      <a:solidFill>
+                        <a:srgbClr val="2A3448"/>
+                      </a:solidFill>
+                      <a:prstDash val="solid"/>
+                      <a:round/>
+                      <a:headEnd type="none" w="med" len="med"/>
+                      <a:tailEnd type="none" w="med" len="med"/>
+                    </a:lnB>
+                    <a:solidFill>
+                      <a:srgbClr val="0F1420"/>
+                    </a:solidFill>
+                  </a:tcPr>
+                </a:tc>
+                <a:tc>
+                  <a:txBody>
+                    <a:bodyPr/>
+                    <a:lstStyle/>
+                    <a:p>
+                      <a:pPr algn="ctr" indent="0" marL="0">
+                        <a:buNone/>
+                      </a:pPr>
+                      <a:r>
+                        <a:rPr lang="en-US" sz="1250" dirty="0">
+                          <a:solidFill>
+                            <a:srgbClr val="F5F7FA"/>
+                          </a:solidFill>
+                          <a:latin typeface="Calibri" pitchFamily="34" charset="0"/>
+                          <a:ea typeface="Calibri" pitchFamily="34" charset="-122"/>
+                          <a:cs typeface="Calibri" pitchFamily="34" charset="-120"/>
+                        </a:rPr>
+                        <a:t>0.660</a:t>
+                      </a:r>
+                      <a:endParaRPr lang="en-US" sz="1250" dirty="0">
+                        <a:latin typeface="Calibri" charset="0"/>
+                        <a:ea typeface="Calibri" charset="0"/>
+                        <a:cs typeface="Calibri" charset="0"/>
+                      </a:endParaRPr>
+                    </a:p>
+                  </a:txBody>
+                  <a:tcPr marL="91440" marR="91440" marT="45720" marB="45720" anchor="ctr">
+                    <a:lnL w="9525" cap="flat" cmpd="sng" algn="ctr">
+                      <a:solidFill>
+                        <a:srgbClr val="2A3448"/>
+                      </a:solidFill>
+                      <a:prstDash val="solid"/>
+                      <a:round/>
+                      <a:headEnd type="none" w="med" len="med"/>
+                      <a:tailEnd type="none" w="med" len="med"/>
+                    </a:lnL>
+                    <a:lnR w="9525" cap="flat" cmpd="sng" algn="ctr">
+                      <a:solidFill>
+                        <a:srgbClr val="2A3448"/>
+                      </a:solidFill>
+                      <a:prstDash val="solid"/>
+                      <a:round/>
+                      <a:headEnd type="none" w="med" len="med"/>
+                      <a:tailEnd type="none" w="med" len="med"/>
+                    </a:lnR>
+                    <a:lnT w="9525" cap="flat" cmpd="sng" algn="ctr">
+                      <a:solidFill>
+                        <a:srgbClr val="2A3448"/>
+                      </a:solidFill>
+                      <a:prstDash val="solid"/>
+                      <a:round/>
+                      <a:headEnd type="none" w="med" len="med"/>
+                      <a:tailEnd type="none" w="med" len="med"/>
+                    </a:lnT>
+                    <a:lnB w="9525" cap="flat" cmpd="sng" algn="ctr">
+                      <a:solidFill>
+                        <a:srgbClr val="2A3448"/>
+                      </a:solidFill>
+                      <a:prstDash val="solid"/>
+                      <a:round/>
+                      <a:headEnd type="none" w="med" len="med"/>
+                      <a:tailEnd type="none" w="med" len="med"/>
+                    </a:lnB>
+                    <a:solidFill>
+                      <a:srgbClr val="0F1420"/>
+                    </a:solidFill>
+                  </a:tcPr>
+                </a:tc>
+                <a:tc>
+                  <a:txBody>
+                    <a:bodyPr/>
+                    <a:lstStyle/>
+                    <a:p>
+                      <a:pPr algn="ctr" indent="0" marL="0">
+                        <a:buNone/>
+                      </a:pPr>
+                      <a:r>
+                        <a:rPr lang="en-US" sz="1250" dirty="0">
+                          <a:solidFill>
+                            <a:srgbClr val="F5F7FA"/>
+                          </a:solidFill>
+                          <a:latin typeface="Calibri" pitchFamily="34" charset="0"/>
+                          <a:ea typeface="Calibri" pitchFamily="34" charset="-122"/>
+                          <a:cs typeface="Calibri" pitchFamily="34" charset="-120"/>
+                        </a:rPr>
+                        <a:t>$0.021</a:t>
+                      </a:r>
+                      <a:endParaRPr lang="en-US" sz="1250" dirty="0">
+                        <a:latin typeface="Calibri" charset="0"/>
+                        <a:ea typeface="Calibri" charset="0"/>
+                        <a:cs typeface="Calibri" charset="0"/>
+                      </a:endParaRPr>
+                    </a:p>
+                  </a:txBody>
+                  <a:tcPr marL="91440" marR="91440" marT="45720" marB="45720" anchor="ctr">
+                    <a:lnL w="9525" cap="flat" cmpd="sng" algn="ctr">
+                      <a:solidFill>
+                        <a:srgbClr val="2A3448"/>
+                      </a:solidFill>
+                      <a:prstDash val="solid"/>
+                      <a:round/>
+                      <a:headEnd type="none" w="med" len="med"/>
+                      <a:tailEnd type="none" w="med" len="med"/>
+                    </a:lnL>
+                    <a:lnR w="9525" cap="flat" cmpd="sng" algn="ctr">
+                      <a:solidFill>
+                        <a:srgbClr val="2A3448"/>
+                      </a:solidFill>
+                      <a:prstDash val="solid"/>
+                      <a:round/>
+                      <a:headEnd type="none" w="med" len="med"/>
+                      <a:tailEnd type="none" w="med" len="med"/>
+                    </a:lnR>
+                    <a:lnT w="9525" cap="flat" cmpd="sng" algn="ctr">
+                      <a:solidFill>
+                        <a:srgbClr val="2A3448"/>
+                      </a:solidFill>
+                      <a:prstDash val="solid"/>
+                      <a:round/>
+                      <a:headEnd type="none" w="med" len="med"/>
+                      <a:tailEnd type="none" w="med" len="med"/>
+                    </a:lnT>
+                    <a:lnB w="9525" cap="flat" cmpd="sng" algn="ctr">
+                      <a:solidFill>
+                        <a:srgbClr val="2A3448"/>
+                      </a:solidFill>
+                      <a:prstDash val="solid"/>
+                      <a:round/>
+                      <a:headEnd type="none" w="med" len="med"/>
+                      <a:tailEnd type="none" w="med" len="med"/>
+                    </a:lnB>
+                    <a:solidFill>
+                      <a:srgbClr val="0F1420"/>
+                    </a:solidFill>
+                  </a:tcPr>
+                </a:tc>
+              </a:tr>
+              <a:tr h="338328">
+                <a:tc>
+                  <a:txBody>
+                    <a:bodyPr/>
+                    <a:lstStyle/>
+                    <a:p>
+                      <a:pPr algn="ctr" indent="0" marL="0">
+                        <a:buNone/>
+                      </a:pPr>
+                      <a:r>
+                        <a:rPr lang="en-US" sz="1250" dirty="0">
+                          <a:solidFill>
+                            <a:srgbClr val="F5F7FA"/>
+                          </a:solidFill>
+                          <a:latin typeface="Calibri" pitchFamily="34" charset="0"/>
+                          <a:ea typeface="Calibri" pitchFamily="34" charset="-122"/>
+                          <a:cs typeface="Calibri" pitchFamily="34" charset="-120"/>
+                        </a:rPr>
+                        <a:t>Llama-3.2-1B</a:t>
+                      </a:r>
+                      <a:endParaRPr lang="en-US" sz="1250" dirty="0">
+                        <a:latin typeface="Calibri" charset="0"/>
+                        <a:ea typeface="Calibri" charset="0"/>
+                        <a:cs typeface="Calibri" charset="0"/>
+                      </a:endParaRPr>
+                    </a:p>
+                  </a:txBody>
+                  <a:tcPr marL="91440" marR="91440" marT="45720" marB="45720" anchor="ctr">
+                    <a:lnL w="9525" cap="flat" cmpd="sng" algn="ctr">
+                      <a:solidFill>
+                        <a:srgbClr val="2A3448"/>
+                      </a:solidFill>
+                      <a:prstDash val="solid"/>
+                      <a:round/>
+                      <a:headEnd type="none" w="med" len="med"/>
+                      <a:tailEnd type="none" w="med" len="med"/>
+                    </a:lnL>
+                    <a:lnR w="9525" cap="flat" cmpd="sng" algn="ctr">
+                      <a:solidFill>
+                        <a:srgbClr val="2A3448"/>
+                      </a:solidFill>
+                      <a:prstDash val="solid"/>
+                      <a:round/>
+                      <a:headEnd type="none" w="med" len="med"/>
+                      <a:tailEnd type="none" w="med" len="med"/>
+                    </a:lnR>
+                    <a:lnT w="9525" cap="flat" cmpd="sng" algn="ctr">
+                      <a:solidFill>
+                        <a:srgbClr val="2A3448"/>
+                      </a:solidFill>
+                      <a:prstDash val="solid"/>
+                      <a:round/>
+                      <a:headEnd type="none" w="med" len="med"/>
+                      <a:tailEnd type="none" w="med" len="med"/>
+                    </a:lnT>
+                    <a:lnB w="9525" cap="flat" cmpd="sng" algn="ctr">
+                      <a:solidFill>
+                        <a:srgbClr val="2A3448"/>
+                      </a:solidFill>
+                      <a:prstDash val="solid"/>
+                      <a:round/>
+                      <a:headEnd type="none" w="med" len="med"/>
+                      <a:tailEnd type="none" w="med" len="med"/>
+                    </a:lnB>
+                    <a:solidFill>
+                      <a:srgbClr val="0F1420"/>
+                    </a:solidFill>
+                  </a:tcPr>
+                </a:tc>
+                <a:tc>
+                  <a:txBody>
+                    <a:bodyPr/>
+                    <a:lstStyle/>
+                    <a:p>
+                      <a:pPr algn="ctr" indent="0" marL="0">
+                        <a:buNone/>
+                      </a:pPr>
+                      <a:r>
+                        <a:rPr lang="en-US" sz="1250" dirty="0">
+                          <a:solidFill>
+                            <a:srgbClr val="F5F7FA"/>
+                          </a:solidFill>
+                          <a:latin typeface="Calibri" pitchFamily="34" charset="0"/>
+                          <a:ea typeface="Calibri" pitchFamily="34" charset="-122"/>
+                          <a:cs typeface="Calibri" pitchFamily="34" charset="-120"/>
+                        </a:rPr>
+                        <a:t>0.623 (0.597-0.647)</a:t>
+                      </a:r>
+                      <a:endParaRPr lang="en-US" sz="1250" dirty="0">
+                        <a:latin typeface="Calibri" charset="0"/>
+                        <a:ea typeface="Calibri" charset="0"/>
+                        <a:cs typeface="Calibri" charset="0"/>
+                      </a:endParaRPr>
+                    </a:p>
+                  </a:txBody>
+                  <a:tcPr marL="91440" marR="91440" marT="45720" marB="45720" anchor="ctr">
+                    <a:lnL w="9525" cap="flat" cmpd="sng" algn="ctr">
+                      <a:solidFill>
+                        <a:srgbClr val="2A3448"/>
+                      </a:solidFill>
+                      <a:prstDash val="solid"/>
+                      <a:round/>
+                      <a:headEnd type="none" w="med" len="med"/>
+                      <a:tailEnd type="none" w="med" len="med"/>
+                    </a:lnL>
+                    <a:lnR w="9525" cap="flat" cmpd="sng" algn="ctr">
+                      <a:solidFill>
+                        <a:srgbClr val="2A3448"/>
+                      </a:solidFill>
+                      <a:prstDash val="solid"/>
+                      <a:round/>
+                      <a:headEnd type="none" w="med" len="med"/>
+                      <a:tailEnd type="none" w="med" len="med"/>
+                    </a:lnR>
+                    <a:lnT w="9525" cap="flat" cmpd="sng" algn="ctr">
+                      <a:solidFill>
+                        <a:srgbClr val="2A3448"/>
+                      </a:solidFill>
+                      <a:prstDash val="solid"/>
+                      <a:round/>
+                      <a:headEnd type="none" w="med" len="med"/>
+                      <a:tailEnd type="none" w="med" len="med"/>
+                    </a:lnT>
+                    <a:lnB w="9525" cap="flat" cmpd="sng" algn="ctr">
+                      <a:solidFill>
+                        <a:srgbClr val="2A3448"/>
+                      </a:solidFill>
+                      <a:prstDash val="solid"/>
+                      <a:round/>
+                      <a:headEnd type="none" w="med" len="med"/>
+                      <a:tailEnd type="none" w="med" len="med"/>
+                    </a:lnB>
+                    <a:solidFill>
+                      <a:srgbClr val="0F1420"/>
+                    </a:solidFill>
+                  </a:tcPr>
+                </a:tc>
+                <a:tc>
+                  <a:txBody>
+                    <a:bodyPr/>
+                    <a:lstStyle/>
+                    <a:p>
+                      <a:pPr algn="ctr" indent="0" marL="0">
+                        <a:buNone/>
+                      </a:pPr>
+                      <a:r>
+                        <a:rPr lang="en-US" sz="1250" dirty="0">
+                          <a:solidFill>
+                            <a:srgbClr val="F5F7FA"/>
+                          </a:solidFill>
+                          <a:latin typeface="Calibri" pitchFamily="34" charset="0"/>
+                          <a:ea typeface="Calibri" pitchFamily="34" charset="-122"/>
+                          <a:cs typeface="Calibri" pitchFamily="34" charset="-120"/>
+                        </a:rPr>
+                        <a:t>0.359</a:t>
+                      </a:r>
+                      <a:endParaRPr lang="en-US" sz="1250" dirty="0">
+                        <a:latin typeface="Calibri" charset="0"/>
+                        <a:ea typeface="Calibri" charset="0"/>
+                        <a:cs typeface="Calibri" charset="0"/>
+                      </a:endParaRPr>
+                    </a:p>
+                  </a:txBody>
+                  <a:tcPr marL="91440" marR="91440" marT="45720" marB="45720" anchor="ctr">
+                    <a:lnL w="9525" cap="flat" cmpd="sng" algn="ctr">
+                      <a:solidFill>
+                        <a:srgbClr val="2A3448"/>
+                      </a:solidFill>
+                      <a:prstDash val="solid"/>
+                      <a:round/>
+                      <a:headEnd type="none" w="med" len="med"/>
+                      <a:tailEnd type="none" w="med" len="med"/>
+                    </a:lnL>
+                    <a:lnR w="9525" cap="flat" cmpd="sng" algn="ctr">
+                      <a:solidFill>
+                        <a:srgbClr val="2A3448"/>
+                      </a:solidFill>
+                      <a:prstDash val="solid"/>
+                      <a:round/>
+                      <a:headEnd type="none" w="med" len="med"/>
+                      <a:tailEnd type="none" w="med" len="med"/>
+                    </a:lnR>
+                    <a:lnT w="9525" cap="flat" cmpd="sng" algn="ctr">
+                      <a:solidFill>
+                        <a:srgbClr val="2A3448"/>
+                      </a:solidFill>
+                      <a:prstDash val="solid"/>
+                      <a:round/>
+                      <a:headEnd type="none" w="med" len="med"/>
+                      <a:tailEnd type="none" w="med" len="med"/>
+                    </a:lnT>
+                    <a:lnB w="9525" cap="flat" cmpd="sng" algn="ctr">
+                      <a:solidFill>
+                        <a:srgbClr val="2A3448"/>
+                      </a:solidFill>
+                      <a:prstDash val="solid"/>
+                      <a:round/>
+                      <a:headEnd type="none" w="med" len="med"/>
+                      <a:tailEnd type="none" w="med" len="med"/>
+                    </a:lnB>
+                    <a:solidFill>
+                      <a:srgbClr val="0F1420"/>
+                    </a:solidFill>
+                  </a:tcPr>
+                </a:tc>
+                <a:tc>
+                  <a:txBody>
+                    <a:bodyPr/>
+                    <a:lstStyle/>
+                    <a:p>
+                      <a:pPr algn="ctr" indent="0" marL="0">
+                        <a:buNone/>
+                      </a:pPr>
+                      <a:r>
+                        <a:rPr lang="en-US" sz="1250" dirty="0">
+                          <a:solidFill>
+                            <a:srgbClr val="F5F7FA"/>
+                          </a:solidFill>
+                          <a:latin typeface="Calibri" pitchFamily="34" charset="0"/>
+                          <a:ea typeface="Calibri" pitchFamily="34" charset="-122"/>
+                          <a:cs typeface="Calibri" pitchFamily="34" charset="-120"/>
+                        </a:rPr>
+                        <a:t>60%</a:t>
+                      </a:r>
+                      <a:endParaRPr lang="en-US" sz="1250" dirty="0">
+                        <a:latin typeface="Calibri" charset="0"/>
+                        <a:ea typeface="Calibri" charset="0"/>
+                        <a:cs typeface="Calibri" charset="0"/>
+                      </a:endParaRPr>
+                    </a:p>
+                  </a:txBody>
+                  <a:tcPr marL="91440" marR="91440" marT="45720" marB="45720" anchor="ctr">
+                    <a:lnL w="9525" cap="flat" cmpd="sng" algn="ctr">
+                      <a:solidFill>
+                        <a:srgbClr val="2A3448"/>
+                      </a:solidFill>
+                      <a:prstDash val="solid"/>
+                      <a:round/>
+                      <a:headEnd type="none" w="med" len="med"/>
+                      <a:tailEnd type="none" w="med" len="med"/>
+                    </a:lnL>
+                    <a:lnR w="9525" cap="flat" cmpd="sng" algn="ctr">
+                      <a:solidFill>
+                        <a:srgbClr val="2A3448"/>
+                      </a:solidFill>
+                      <a:prstDash val="solid"/>
+                      <a:round/>
+                      <a:headEnd type="none" w="med" len="med"/>
+                      <a:tailEnd type="none" w="med" len="med"/>
+                    </a:lnR>
+                    <a:lnT w="9525" cap="flat" cmpd="sng" algn="ctr">
+                      <a:solidFill>
+                        <a:srgbClr val="2A3448"/>
+                      </a:solidFill>
+                      <a:prstDash val="solid"/>
+                      <a:round/>
+                      <a:headEnd type="none" w="med" len="med"/>
+                      <a:tailEnd type="none" w="med" len="med"/>
+                    </a:lnT>
+                    <a:lnB w="9525" cap="flat" cmpd="sng" algn="ctr">
+                      <a:solidFill>
+                        <a:srgbClr val="2A3448"/>
+                      </a:solidFill>
+                      <a:prstDash val="solid"/>
+                      <a:round/>
+                      <a:headEnd type="none" w="med" len="med"/>
+                      <a:tailEnd type="none" w="med" len="med"/>
+                    </a:lnB>
+                    <a:solidFill>
+                      <a:srgbClr val="0F1420"/>
+                    </a:solidFill>
+                  </a:tcPr>
+                </a:tc>
+                <a:tc>
+                  <a:txBody>
+                    <a:bodyPr/>
+                    <a:lstStyle/>
+                    <a:p>
+                      <a:pPr algn="ctr" indent="0" marL="0">
+                        <a:buNone/>
+                      </a:pPr>
+                      <a:r>
+                        <a:rPr lang="en-US" sz="1250" dirty="0">
+                          <a:solidFill>
+                            <a:srgbClr val="F5F7FA"/>
+                          </a:solidFill>
+                          <a:latin typeface="Calibri" pitchFamily="34" charset="0"/>
+                          <a:ea typeface="Calibri" pitchFamily="34" charset="-122"/>
+                          <a:cs typeface="Calibri" pitchFamily="34" charset="-120"/>
+                        </a:rPr>
+                        <a:t>0.474</a:t>
+                      </a:r>
+                      <a:endParaRPr lang="en-US" sz="1250" dirty="0">
+                        <a:latin typeface="Calibri" charset="0"/>
+                        <a:ea typeface="Calibri" charset="0"/>
+                        <a:cs typeface="Calibri" charset="0"/>
+                      </a:endParaRPr>
+                    </a:p>
+                  </a:txBody>
+                  <a:tcPr marL="91440" marR="91440" marT="45720" marB="45720" anchor="ctr">
+                    <a:lnL w="9525" cap="flat" cmpd="sng" algn="ctr">
+                      <a:solidFill>
+                        <a:srgbClr val="2A3448"/>
+                      </a:solidFill>
+                      <a:prstDash val="solid"/>
+                      <a:round/>
+                      <a:headEnd type="none" w="med" len="med"/>
+                      <a:tailEnd type="none" w="med" len="med"/>
+                    </a:lnL>
+                    <a:lnR w="9525" cap="flat" cmpd="sng" algn="ctr">
+                      <a:solidFill>
+                        <a:srgbClr val="2A3448"/>
+                      </a:solidFill>
+                      <a:prstDash val="solid"/>
+                      <a:round/>
+                      <a:headEnd type="none" w="med" len="med"/>
+                      <a:tailEnd type="none" w="med" len="med"/>
+                    </a:lnR>
+                    <a:lnT w="9525" cap="flat" cmpd="sng" algn="ctr">
+                      <a:solidFill>
+                        <a:srgbClr val="2A3448"/>
+                      </a:solidFill>
+                      <a:prstDash val="solid"/>
+                      <a:round/>
+                      <a:headEnd type="none" w="med" len="med"/>
+                      <a:tailEnd type="none" w="med" len="med"/>
+                    </a:lnT>
+                    <a:lnB w="9525" cap="flat" cmpd="sng" algn="ctr">
+                      <a:solidFill>
+                        <a:srgbClr val="2A3448"/>
+                      </a:solidFill>
+                      <a:prstDash val="solid"/>
+                      <a:round/>
+                      <a:headEnd type="none" w="med" len="med"/>
+                      <a:tailEnd type="none" w="med" len="med"/>
+                    </a:lnB>
+                    <a:solidFill>
+                      <a:srgbClr val="0F1420"/>
+                    </a:solidFill>
+                  </a:tcPr>
+                </a:tc>
+                <a:tc>
+                  <a:txBody>
+                    <a:bodyPr/>
+                    <a:lstStyle/>
+                    <a:p>
+                      <a:pPr algn="ctr" indent="0" marL="0">
+                        <a:buNone/>
+                      </a:pPr>
+                      <a:r>
+                        <a:rPr lang="en-US" sz="1250" dirty="0">
+                          <a:solidFill>
+                            <a:srgbClr val="F5F7FA"/>
+                          </a:solidFill>
+                          <a:latin typeface="Calibri" pitchFamily="34" charset="0"/>
+                          <a:ea typeface="Calibri" pitchFamily="34" charset="-122"/>
+                          <a:cs typeface="Calibri" pitchFamily="34" charset="-120"/>
+                        </a:rPr>
+                        <a:t>0.760</a:t>
+                      </a:r>
+                      <a:endParaRPr lang="en-US" sz="1250" dirty="0">
+                        <a:latin typeface="Calibri" charset="0"/>
+                        <a:ea typeface="Calibri" charset="0"/>
+                        <a:cs typeface="Calibri" charset="0"/>
+                      </a:endParaRPr>
+                    </a:p>
+                  </a:txBody>
+                  <a:tcPr marL="91440" marR="91440" marT="45720" marB="45720" anchor="ctr">
+                    <a:lnL w="9525" cap="flat" cmpd="sng" algn="ctr">
+                      <a:solidFill>
+                        <a:srgbClr val="2A3448"/>
+                      </a:solidFill>
+                      <a:prstDash val="solid"/>
+                      <a:round/>
+                      <a:headEnd type="none" w="med" len="med"/>
+                      <a:tailEnd type="none" w="med" len="med"/>
+                    </a:lnL>
+                    <a:lnR w="9525" cap="flat" cmpd="sng" algn="ctr">
+                      <a:solidFill>
+                        <a:srgbClr val="2A3448"/>
+                      </a:solidFill>
+                      <a:prstDash val="solid"/>
+                      <a:round/>
+                      <a:headEnd type="none" w="med" len="med"/>
+                      <a:tailEnd type="none" w="med" len="med"/>
+                    </a:lnR>
+                    <a:lnT w="9525" cap="flat" cmpd="sng" algn="ctr">
+                      <a:solidFill>
+                        <a:srgbClr val="2A3448"/>
+                      </a:solidFill>
+                      <a:prstDash val="solid"/>
+                      <a:round/>
+                      <a:headEnd type="none" w="med" len="med"/>
+                      <a:tailEnd type="none" w="med" len="med"/>
+                    </a:lnT>
+                    <a:lnB w="9525" cap="flat" cmpd="sng" algn="ctr">
+                      <a:solidFill>
+                        <a:srgbClr val="2A3448"/>
+                      </a:solidFill>
+                      <a:prstDash val="solid"/>
+                      <a:round/>
+                      <a:headEnd type="none" w="med" len="med"/>
+                      <a:tailEnd type="none" w="med" len="med"/>
+                    </a:lnB>
+                    <a:solidFill>
+                      <a:srgbClr val="0F1420"/>
+                    </a:solidFill>
+                  </a:tcPr>
+                </a:tc>
+                <a:tc>
+                  <a:txBody>
+                    <a:bodyPr/>
+                    <a:lstStyle/>
+                    <a:p>
+                      <a:pPr algn="ctr" indent="0" marL="0">
+                        <a:buNone/>
+                      </a:pPr>
+                      <a:r>
+                        <a:rPr lang="en-US" sz="1250" dirty="0">
                           <a:solidFill>
                             <a:srgbClr val="F5F7FA"/>
                           </a:solidFill>
@@ -20264,7 +22311,7 @@
                         </a:rPr>
                         <a:t>$0.009</a:t>
                       </a:r>
-                      <a:endParaRPr lang="en-US" sz="1300" dirty="0">
+                      <a:endParaRPr lang="en-US" sz="1250" dirty="0">
                         <a:latin typeface="Calibri" charset="0"/>
                         <a:ea typeface="Calibri" charset="0"/>
                         <a:cs typeface="Calibri" charset="0"/>
@@ -20351,7 +22398,7 @@
                 <a:ea typeface="Calibri" pitchFamily="34" charset="-122"/>
                 <a:cs typeface="Calibri" pitchFamily="34" charset="-120"/>
               </a:rPr>
-              <a:t>All scores on the same held-out emails. Trained models use decontaminated data. LLMs never saw any of our data.</a:t>
+              <a:t>All scores on the same held-out emails. Trained models use decontaminated data. LLMs never saw any of our data. False alarms = share of legitimate mail flagged.</a:t>
             </a:r>
             <a:endParaRPr lang="en-US" sz="1200" dirty="0"/>
           </a:p>
@@ -20539,7 +22586,7 @@
                 <a:ea typeface="Calibri" pitchFamily="34" charset="-122"/>
                 <a:cs typeface="Calibri" pitchFamily="34" charset="-120"/>
               </a:rPr>
-              <a:t>Cheap, robust detectors exist, but not all small LLMs are</a:t>
+              <a:t>No single winner: pick the trade-off you can live with</a:t>
             </a:r>
             <a:endParaRPr lang="en-US" sz="3200" dirty="0"/>
           </a:p>
@@ -20553,12 +22600,12 @@
         </p:nvSpPr>
         <p:spPr>
           <a:xfrm>
-            <a:off x="548640" y="1554480"/>
-            <a:ext cx="5394960" cy="1371600"/>
+            <a:off x="548640" y="1508760"/>
+            <a:ext cx="5394960" cy="1024128"/>
           </a:xfrm>
           <a:prstGeom prst="roundRect">
             <a:avLst>
-              <a:gd name="adj" fmla="val 5333"/>
+              <a:gd name="adj" fmla="val 7143"/>
             </a:avLst>
           </a:prstGeom>
           <a:solidFill>
@@ -20580,8 +22627,8 @@
         </p:nvSpPr>
         <p:spPr>
           <a:xfrm>
-            <a:off x="685800" y="1645920"/>
-            <a:ext cx="5120640" cy="1188720"/>
+            <a:off x="685800" y="1600200"/>
+            <a:ext cx="5120640" cy="841248"/>
           </a:xfrm>
           <a:prstGeom prst="rect">
             <a:avLst/>
@@ -20608,7 +22655,7 @@
                 <a:ea typeface="Calibri" pitchFamily="34" charset="-122"/>
                 <a:cs typeface="Calibri" pitchFamily="34" charset="-120"/>
               </a:rPr>
-              <a:t>1. A 7B model wins, for cents</a:t>
+              <a:t>1. Best balance: Qwen-2.5-7B zero-shot</a:t>
             </a:r>
             <a:endParaRPr lang="en-US" sz="1500" dirty="0"/>
           </a:p>
@@ -20628,7 +22675,7 @@
                 <a:ea typeface="Calibri" pitchFamily="34" charset="-122"/>
                 <a:cs typeface="Calibri" pitchFamily="34" charset="-120"/>
               </a:rPr>
-              <a:t>Qwen-2.5-7B reaches 0.928 F1 on unseen corpora and 0.819 on AI phishing, at $0.031 per 1,000 emails.</a:t>
+              <a:t>0.928 F1 on unseen corpora, 3% false alarms, 0.819 on AI phishing, $0.031 per 1,000 emails.</a:t>
             </a:r>
             <a:endParaRPr lang="en-US" sz="1500" dirty="0"/>
           </a:p>
@@ -20642,12 +22689,190 @@
         </p:nvSpPr>
         <p:spPr>
           <a:xfrm>
-            <a:off x="548640" y="3063240"/>
-            <a:ext cx="5394960" cy="1371600"/>
+            <a:off x="548640" y="2651760"/>
+            <a:ext cx="5394960" cy="1024128"/>
           </a:xfrm>
           <a:prstGeom prst="roundRect">
             <a:avLst>
-              <a:gd name="adj" fmla="val 5333"/>
+              <a:gd name="adj" fmla="val 7143"/>
+            </a:avLst>
+          </a:prstGeom>
+          <a:solidFill>
+            <a:srgbClr val="1B2335"/>
+          </a:solidFill>
+          <a:ln w="19050">
+            <a:solidFill>
+              <a:srgbClr val="FBBF24"/>
+            </a:solidFill>
+            <a:prstDash val="solid"/>
+          </a:ln>
+        </p:spPr>
+      </p:sp>
+      <p:sp>
+        <p:nvSpPr>
+          <p:cNvPr id="8" name="Text 6"/>
+          <p:cNvSpPr txBox="1"/>
+          <p:nvPr/>
+        </p:nvSpPr>
+        <p:spPr>
+          <a:xfrm>
+            <a:off x="685800" y="2743200"/>
+            <a:ext cx="5120640" cy="841248"/>
+          </a:xfrm>
+          <a:prstGeom prst="rect">
+            <a:avLst/>
+          </a:prstGeom>
+          <a:noFill/>
+          <a:ln/>
+        </p:spPr>
+        <p:txBody>
+          <a:bodyPr wrap="square" lIns="0" tIns="0" rIns="0" bIns="0" rtlCol="0" anchor="t"/>
+          <a:lstStyle/>
+          <a:p>
+            <a:pPr indent="0" marL="0">
+              <a:spcAft>
+                <a:spcPts val="400"/>
+              </a:spcAft>
+              <a:buNone/>
+            </a:pPr>
+            <a:r>
+              <a:rPr lang="en-US" sz="1500" b="1" dirty="0">
+                <a:solidFill>
+                  <a:srgbClr val="FBBF24"/>
+                </a:solidFill>
+                <a:latin typeface="Calibri" pitchFamily="34" charset="0"/>
+                <a:ea typeface="Calibri" pitchFamily="34" charset="-122"/>
+                <a:cs typeface="Calibri" pitchFamily="34" charset="-120"/>
+              </a:rPr>
+              <a:t>2. Gemma-3-12B catches more, flags more</a:t>
+            </a:r>
+            <a:endParaRPr lang="en-US" sz="1500" dirty="0"/>
+          </a:p>
+          <a:p>
+            <a:pPr indent="0" marL="0">
+              <a:spcAft>
+                <a:spcPts val="400"/>
+              </a:spcAft>
+              <a:buNone/>
+            </a:pPr>
+            <a:r>
+              <a:rPr lang="en-US" sz="1200" dirty="0">
+                <a:solidFill>
+                  <a:srgbClr val="94A3B8"/>
+                </a:solidFill>
+                <a:latin typeface="Calibri" pitchFamily="34" charset="0"/>
+                <a:ea typeface="Calibri" pitchFamily="34" charset="-122"/>
+                <a:cs typeface="Calibri" pitchFamily="34" charset="-120"/>
+              </a:rPr>
+              <a:t>0.955 on AI phishing, but 25% of legitimate mail flagged. Good for review queues, not for blocking.</a:t>
+            </a:r>
+            <a:endParaRPr lang="en-US" sz="1500" dirty="0"/>
+          </a:p>
+        </p:txBody>
+      </p:sp>
+      <p:sp>
+        <p:nvSpPr>
+          <p:cNvPr id="9" name="Shape 7"/>
+          <p:cNvSpPr/>
+          <p:nvPr/>
+        </p:nvSpPr>
+        <p:spPr>
+          <a:xfrm>
+            <a:off x="548640" y="3794760"/>
+            <a:ext cx="5394960" cy="1024128"/>
+          </a:xfrm>
+          <a:prstGeom prst="roundRect">
+            <a:avLst>
+              <a:gd name="adj" fmla="val 7143"/>
+            </a:avLst>
+          </a:prstGeom>
+          <a:solidFill>
+            <a:srgbClr val="1B2335"/>
+          </a:solidFill>
+          <a:ln w="19050">
+            <a:solidFill>
+              <a:srgbClr val="FF6B4A"/>
+            </a:solidFill>
+            <a:prstDash val="solid"/>
+          </a:ln>
+        </p:spPr>
+      </p:sp>
+      <p:sp>
+        <p:nvSpPr>
+          <p:cNvPr id="10" name="Text 8"/>
+          <p:cNvSpPr txBox="1"/>
+          <p:nvPr/>
+        </p:nvSpPr>
+        <p:spPr>
+          <a:xfrm>
+            <a:off x="685800" y="3886200"/>
+            <a:ext cx="5120640" cy="841248"/>
+          </a:xfrm>
+          <a:prstGeom prst="rect">
+            <a:avLst/>
+          </a:prstGeom>
+          <a:noFill/>
+          <a:ln/>
+        </p:spPr>
+        <p:txBody>
+          <a:bodyPr wrap="square" lIns="0" tIns="0" rIns="0" bIns="0" rtlCol="0" anchor="t"/>
+          <a:lstStyle/>
+          <a:p>
+            <a:pPr indent="0" marL="0">
+              <a:spcAft>
+                <a:spcPts val="400"/>
+              </a:spcAft>
+              <a:buNone/>
+            </a:pPr>
+            <a:r>
+              <a:rPr lang="en-US" sz="1500" b="1" dirty="0">
+                <a:solidFill>
+                  <a:srgbClr val="FF6B4A"/>
+                </a:solidFill>
+                <a:latin typeface="Calibri" pitchFamily="34" charset="0"/>
+                <a:ea typeface="Calibri" pitchFamily="34" charset="-122"/>
+                <a:cs typeface="Calibri" pitchFamily="34" charset="-120"/>
+              </a:rPr>
+              <a:t>3. Few-shot helps old mail, hurts AI phishing</a:t>
+            </a:r>
+            <a:endParaRPr lang="en-US" sz="1500" dirty="0"/>
+          </a:p>
+          <a:p>
+            <a:pPr indent="0" marL="0">
+              <a:spcAft>
+                <a:spcPts val="400"/>
+              </a:spcAft>
+              <a:buNone/>
+            </a:pPr>
+            <a:r>
+              <a:rPr lang="en-US" sz="1200" dirty="0">
+                <a:solidFill>
+                  <a:srgbClr val="94A3B8"/>
+                </a:solidFill>
+                <a:latin typeface="Calibri" pitchFamily="34" charset="0"/>
+                <a:ea typeface="Calibri" pitchFamily="34" charset="-122"/>
+                <a:cs typeface="Calibri" pitchFamily="34" charset="-120"/>
+              </a:rPr>
+              <a:t>Qwen on AI phishing: 0.819 to 0.598 with 4 old examples. They anchor it to old spam.</a:t>
+            </a:r>
+            <a:endParaRPr lang="en-US" sz="1500" dirty="0"/>
+          </a:p>
+        </p:txBody>
+      </p:sp>
+      <p:sp>
+        <p:nvSpPr>
+          <p:cNvPr id="11" name="Shape 9"/>
+          <p:cNvSpPr/>
+          <p:nvPr/>
+        </p:nvSpPr>
+        <p:spPr>
+          <a:xfrm>
+            <a:off x="548640" y="4937760"/>
+            <a:ext cx="5394960" cy="1024128"/>
+          </a:xfrm>
+          <a:prstGeom prst="roundRect">
+            <a:avLst>
+              <a:gd name="adj" fmla="val 7143"/>
             </a:avLst>
           </a:prstGeom>
           <a:solidFill>
@@ -20663,14 +22888,14 @@
       </p:sp>
       <p:sp>
         <p:nvSpPr>
-          <p:cNvPr id="8" name="Text 6"/>
+          <p:cNvPr id="12" name="Text 10"/>
           <p:cNvSpPr txBox="1"/>
           <p:nvPr/>
         </p:nvSpPr>
         <p:spPr>
           <a:xfrm>
-            <a:off x="685800" y="3154680"/>
-            <a:ext cx="5120640" cy="1188720"/>
+            <a:off x="685800" y="5029200"/>
+            <a:ext cx="5120640" cy="841248"/>
           </a:xfrm>
           <a:prstGeom prst="rect">
             <a:avLst/>
@@ -20697,7 +22922,7 @@
                 <a:ea typeface="Calibri" pitchFamily="34" charset="-122"/>
                 <a:cs typeface="Calibri" pitchFamily="34" charset="-120"/>
               </a:rPr>
-              <a:t>2. TF-IDF is still a strong baseline</a:t>
+              <a:t>4. The usual metric picks the wrong model</a:t>
             </a:r>
             <a:endParaRPr lang="en-US" sz="1500" dirty="0"/>
           </a:p>
@@ -20717,7 +22942,7 @@
                 <a:ea typeface="Calibri" pitchFamily="34" charset="-122"/>
                 <a:cs typeface="Calibri" pitchFamily="34" charset="-120"/>
               </a:rPr>
-              <a:t>0.901 on unseen corpora for free, but only 0.640 on AI-written phishing.</a:t>
+              <a:t>DistilBERT: best in-corpus F1 (0.975), weakest trained model on AI phishing (0.493).</a:t>
             </a:r>
             <a:endParaRPr lang="en-US" sz="1500" dirty="0"/>
           </a:p>
@@ -20725,107 +22950,18 @@
       </p:sp>
       <p:sp>
         <p:nvSpPr>
-          <p:cNvPr id="9" name="Shape 7"/>
+          <p:cNvPr id="13" name="Shape 11"/>
           <p:cNvSpPr/>
           <p:nvPr/>
         </p:nvSpPr>
         <p:spPr>
           <a:xfrm>
-            <a:off x="548640" y="4572000"/>
-            <a:ext cx="5394960" cy="1371600"/>
+            <a:off x="6172200" y="1508760"/>
+            <a:ext cx="5468112" cy="4434840"/>
           </a:xfrm>
           <a:prstGeom prst="roundRect">
             <a:avLst>
-              <a:gd name="adj" fmla="val 5333"/>
-            </a:avLst>
-          </a:prstGeom>
-          <a:solidFill>
-            <a:srgbClr val="1B2335"/>
-          </a:solidFill>
-          <a:ln w="19050">
-            <a:solidFill>
-              <a:srgbClr val="FBBF24"/>
-            </a:solidFill>
-            <a:prstDash val="solid"/>
-          </a:ln>
-        </p:spPr>
-      </p:sp>
-      <p:sp>
-        <p:nvSpPr>
-          <p:cNvPr id="10" name="Text 8"/>
-          <p:cNvSpPr txBox="1"/>
-          <p:nvPr/>
-        </p:nvSpPr>
-        <p:spPr>
-          <a:xfrm>
-            <a:off x="685800" y="4663440"/>
-            <a:ext cx="5120640" cy="1188720"/>
-          </a:xfrm>
-          <a:prstGeom prst="rect">
-            <a:avLst/>
-          </a:prstGeom>
-          <a:noFill/>
-          <a:ln/>
-        </p:spPr>
-        <p:txBody>
-          <a:bodyPr wrap="square" lIns="0" tIns="0" rIns="0" bIns="0" rtlCol="0" anchor="t"/>
-          <a:lstStyle/>
-          <a:p>
-            <a:pPr indent="0" marL="0">
-              <a:spcAft>
-                <a:spcPts val="400"/>
-              </a:spcAft>
-              <a:buNone/>
-            </a:pPr>
-            <a:r>
-              <a:rPr lang="en-US" sz="1500" b="1" dirty="0">
-                <a:solidFill>
-                  <a:srgbClr val="FBBF24"/>
-                </a:solidFill>
-                <a:latin typeface="Calibri" pitchFamily="34" charset="0"/>
-                <a:ea typeface="Calibri" pitchFamily="34" charset="-122"/>
-                <a:cs typeface="Calibri" pitchFamily="34" charset="-120"/>
-              </a:rPr>
-              <a:t>3. Size is not quality</a:t>
-            </a:r>
-            <a:endParaRPr lang="en-US" sz="1500" dirty="0"/>
-          </a:p>
-          <a:p>
-            <a:pPr indent="0" marL="0">
-              <a:spcAft>
-                <a:spcPts val="400"/>
-              </a:spcAft>
-              <a:buNone/>
-            </a:pPr>
-            <a:r>
-              <a:rPr lang="en-US" sz="1200" dirty="0">
-                <a:solidFill>
-                  <a:srgbClr val="94A3B8"/>
-                </a:solidFill>
-                <a:latin typeface="Calibri" pitchFamily="34" charset="0"/>
-                <a:ea typeface="Calibri" pitchFamily="34" charset="-122"/>
-                <a:cs typeface="Calibri" pitchFamily="34" charset="-120"/>
-              </a:rPr>
-              <a:t>Phi-4 (14B) skipped the one-word answer in a third of emails. Following the output format matters as much as reasoning.</a:t>
-            </a:r>
-            <a:endParaRPr lang="en-US" sz="1500" dirty="0"/>
-          </a:p>
-        </p:txBody>
-      </p:sp>
-      <p:sp>
-        <p:nvSpPr>
-          <p:cNvPr id="11" name="Shape 9"/>
-          <p:cNvSpPr/>
-          <p:nvPr/>
-        </p:nvSpPr>
-        <p:spPr>
-          <a:xfrm>
-            <a:off x="6172200" y="1554480"/>
-            <a:ext cx="5468112" cy="4389120"/>
-          </a:xfrm>
-          <a:prstGeom prst="roundRect">
-            <a:avLst>
-              <a:gd name="adj" fmla="val 1667"/>
+              <a:gd name="adj" fmla="val 1649"/>
             </a:avLst>
           </a:prstGeom>
           <a:solidFill>
@@ -20841,7 +22977,7 @@
       </p:sp>
       <p:pic>
         <p:nvPicPr>
-          <p:cNvPr id="12" name="Image 0" descr="/Users/sinha/Downloads/uiu/cn/results/final/figures/f1_vs_cost.png">    </p:cNvPr>
+          <p:cNvPr id="14" name="Image 0" descr="/Users/sinha/Downloads/uiu/cn/results/final/figures/f1_vs_cost.png">    </p:cNvPr>
           <p:cNvPicPr>
             <a:picLocks noChangeAspect="1"/>
           </p:cNvPicPr>
@@ -20854,8 +22990,8 @@
         </p:blipFill>
         <p:spPr>
           <a:xfrm>
-            <a:off x="6263640" y="1645920"/>
-            <a:ext cx="5285232" cy="4206240"/>
+            <a:off x="6263640" y="1600200"/>
+            <a:ext cx="5285232" cy="4251960"/>
           </a:xfrm>
           <a:prstGeom prst="rect">
             <a:avLst/>
@@ -20864,7 +23000,7 @@
       </p:pic>
       <p:sp>
         <p:nvSpPr>
-          <p:cNvPr id="13" name="Text 10"/>
+          <p:cNvPr id="15" name="Text 12"/>
           <p:cNvSpPr txBox="1"/>
           <p:nvPr/>
         </p:nvSpPr>

</xml_diff>

<commit_message>
Presentation: 14 slides at 9:45, balanced across three speakers, bilingual script and a Bangla HTML guide
- deck cut from 16 to 14 slides: explanations merged into the takeaways slide,
  next-two-weeks merged with the source code links, so the talk lands at
  9 minutes 45 instead of 11:20
- speaking split rebalanced: Sinha 1-5 (2:50), Saimon 6-9 (3:20), Faria 10-14 (3:35)
- every section the brief asks for is on its own slide: objectives (3),
  methodology (4), experimental details from the notebook (5), results (6-11),
  limitations (13), two-week scope and the GitHub and Colab links (14)
- speaker_script.md rewritten for the 14 slides, English and Bangla per slide,
  with delivery notes and two audience questions
- GUIDE.html: the whole study explained in plain Bangla with the figures,
  literature statements, a question bank and a glossary
- PPTX and group-18.pdf regenerated from the new deck

Co-Authored-By: Claude Opus 5 (1M context) <noreply@anthropic.com>
</commit_message>
<xml_diff>
--- a/final-slides/final_deck.pptx
+++ b/final-slides/final_deck.pptx
@@ -19,8 +19,6 @@
     <p:sldId id="267" r:id="rId19"/>
     <p:sldId id="268" r:id="rId20"/>
     <p:sldId id="269" r:id="rId21"/>
-    <p:sldId id="270" r:id="rId22"/>
-    <p:sldId id="271" r:id="rId23"/>
   </p:sldIdLst>
   <p:sldSz cx="12191695" cy="6858000" type="screen4x3"/>
   <p:notesSz cx="6858000" cy="9144000"/>
@@ -587,7 +585,7 @@
           <a:lstStyle/>
           <a:p>
             <a:r>
-              <a:t>55 sec. Tell it as a story: we suspected our own good number, ran the obvious test, it said we were right to worry, then the proper paired test said otherwise. Report both.</a:t>
+              <a:t>55 sec. Three rows only: Gemini (best, paid), Qwen (best open), and a published detector (high on our corpora, low on AI mail).</a:t>
             </a:r>
           </a:p>
         </p:txBody>
@@ -657,7 +655,7 @@
           <a:lstStyle/>
           <a:p>
             <a:r>
-              <a:t>55 sec. The point: the ranking changes with the base rate, and combining two cheap models beats either one.</a:t>
+              <a:t>50 sec. The point: the ranking changes with the base rate, and combining two cheap models beats either one.</a:t>
             </a:r>
           </a:p>
         </p:txBody>
@@ -727,7 +725,7 @@
           <a:lstStyle/>
           <a:p>
             <a:r>
-              <a:t>45 sec. Two numbers and the significance line. Do not read the whole box.</a:t>
+              <a:t>40 sec. One sentence per card. Read the explanation box quickly, then the closing line, then go on to limitations.</a:t>
             </a:r>
           </a:p>
         </p:txBody>
@@ -797,7 +795,7 @@
           <a:lstStyle/>
           <a:p>
             <a:r>
-              <a:t>40 sec. One sentence each. Land on the closing line but do not finish yet, limitations come next.</a:t>
+              <a:t>35 sec. Say the first three clearly. Owning these is what makes the rest believable.</a:t>
             </a:r>
           </a:p>
         </p:txBody>
@@ -867,147 +865,7 @@
           <a:lstStyle/>
           <a:p>
             <a:r>
-              <a:t>35 sec. Say the first three clearly. Owning these is what makes the rest believable.</a:t>
-            </a:r>
-          </a:p>
-        </p:txBody>
-      </p:sp>
-      <p:sp>
-        <p:nvSpPr>
-          <p:cNvPr id="4" name="Slide Number Placeholder 3"/>
-          <p:cNvSpPr>
-            <a:spLocks noGrp="1"/>
-          </p:cNvSpPr>
-          <p:nvPr>
-            <p:ph type="sldNum" idx="5" sz="quarter"/>
-          </p:nvPr>
-        </p:nvSpPr>
-        <p:spPr/>
-      </p:sp>
-    </p:spTree>
-  </p:cSld>
-  <p:clrMapOvr>
-    <a:masterClrMapping/>
-  </p:clrMapOvr>
-</p:notes>
-</file>
-
-<file path=ppt/notesSlides/notesSlide15.xml><?xml version="1.0" encoding="utf-8"?>
-<p:notes xmlns:a="http://schemas.openxmlformats.org/drawingml/2006/main" xmlns:p="http://schemas.openxmlformats.org/presentationml/2006/main" xmlns:r="http://schemas.openxmlformats.org/officeDocument/2006/relationships">
-  <p:cSld>
-    <p:spTree>
-      <p:nvGrpSpPr>
-        <p:cNvPr id="1" name=""/>
-        <p:cNvGrpSpPr/>
-        <p:nvPr/>
-      </p:nvGrpSpPr>
-      <p:grpSpPr>
-        <a:xfrm>
-          <a:off x="0" y="0"/>
-          <a:ext cx="0" cy="0"/>
-          <a:chOff x="0" y="0"/>
-          <a:chExt cx="0" cy="0"/>
-        </a:xfrm>
-      </p:grpSpPr>
-      <p:sp>
-        <p:nvSpPr>
-          <p:cNvPr id="2" name="Slide Image Placeholder 1"/>
-          <p:cNvSpPr>
-            <a:spLocks noGrp="1"/>
-          </p:cNvSpPr>
-          <p:nvPr>
-            <p:ph type="sldImg" idx="2"/>
-          </p:nvPr>
-        </p:nvSpPr>
-        <p:spPr/>
-      </p:sp>
-      <p:sp>
-        <p:nvSpPr>
-          <p:cNvPr id="3" name="Notes Placeholder 2"/>
-          <p:cNvSpPr>
-            <a:spLocks noGrp="1"/>
-          </p:cNvSpPr>
-          <p:nvPr>
-            <p:ph type="body" idx="3" sz="quarter"/>
-          </p:nvPr>
-        </p:nvSpPr>
-        <p:spPr/>
-        <p:txBody>
-          <a:bodyPr/>
-          <a:lstStyle/>
-          <a:p>
-            <a:r>
-              <a:t>30 sec. Four blocks. Stress that the first one replaces a model with human labels.</a:t>
-            </a:r>
-          </a:p>
-        </p:txBody>
-      </p:sp>
-      <p:sp>
-        <p:nvSpPr>
-          <p:cNvPr id="4" name="Slide Number Placeholder 3"/>
-          <p:cNvSpPr>
-            <a:spLocks noGrp="1"/>
-          </p:cNvSpPr>
-          <p:nvPr>
-            <p:ph type="sldNum" idx="5" sz="quarter"/>
-          </p:nvPr>
-        </p:nvSpPr>
-        <p:spPr/>
-      </p:sp>
-    </p:spTree>
-  </p:cSld>
-  <p:clrMapOvr>
-    <a:masterClrMapping/>
-  </p:clrMapOvr>
-</p:notes>
-</file>
-
-<file path=ppt/notesSlides/notesSlide16.xml><?xml version="1.0" encoding="utf-8"?>
-<p:notes xmlns:a="http://schemas.openxmlformats.org/drawingml/2006/main" xmlns:p="http://schemas.openxmlformats.org/presentationml/2006/main" xmlns:r="http://schemas.openxmlformats.org/officeDocument/2006/relationships">
-  <p:cSld>
-    <p:spTree>
-      <p:nvGrpSpPr>
-        <p:cNvPr id="1" name=""/>
-        <p:cNvGrpSpPr/>
-        <p:nvPr/>
-      </p:nvGrpSpPr>
-      <p:grpSpPr>
-        <a:xfrm>
-          <a:off x="0" y="0"/>
-          <a:ext cx="0" cy="0"/>
-          <a:chOff x="0" y="0"/>
-          <a:chExt cx="0" cy="0"/>
-        </a:xfrm>
-      </p:grpSpPr>
-      <p:sp>
-        <p:nvSpPr>
-          <p:cNvPr id="2" name="Slide Image Placeholder 1"/>
-          <p:cNvSpPr>
-            <a:spLocks noGrp="1"/>
-          </p:cNvSpPr>
-          <p:nvPr>
-            <p:ph type="sldImg" idx="2"/>
-          </p:nvPr>
-        </p:nvSpPr>
-        <p:spPr/>
-      </p:sp>
-      <p:sp>
-        <p:nvSpPr>
-          <p:cNvPr id="3" name="Notes Placeholder 2"/>
-          <p:cNvSpPr>
-            <a:spLocks noGrp="1"/>
-          </p:cNvSpPr>
-          <p:nvPr>
-            <p:ph type="body" idx="3" sz="quarter"/>
-          </p:nvPr>
-        </p:nvSpPr>
-        <p:spPr/>
-        <p:txBody>
-          <a:bodyPr/>
-          <a:lstStyle/>
-          <a:p>
-            <a:r>
-              <a:t>20 sec. Read the links, then the three numbers, then stop.</a:t>
+              <a:t>35 sec. Two blocks of plan, then the links, then the three numbers. Stop after "thank you".</a:t>
             </a:r>
           </a:p>
         </p:txBody>
@@ -1077,7 +935,7 @@
           <a:lstStyle/>
           <a:p>
             <a:r>
-              <a:t>45 sec. Timeline in one breath, then the three corrections. Be open that we are not the first to test across corpora.</a:t>
+              <a:t>35 sec. Timeline in one breath, then the three corrections. Be open that we are not the first to test across corpora.</a:t>
             </a:r>
           </a:p>
         </p:txBody>
@@ -1147,7 +1005,7 @@
           <a:lstStyle/>
           <a:p>
             <a:r>
-              <a:t>30 sec. All six done. Point at the last row: review made the project bigger, not smaller.</a:t>
+              <a:t>35 sec. All six done. Point at the last row: review made the project bigger, not smaller.</a:t>
             </a:r>
           </a:p>
         </p:txBody>
@@ -1217,7 +1075,7 @@
           <a:lstStyle/>
           <a:p>
             <a:r>
-              <a:t>45 sec. Spend the time on the control box. That is the answer to the first question any examiner asks.</a:t>
+              <a:t>40 sec. Spend the time on the control box. That is the answer to the first question any examiner asks.</a:t>
             </a:r>
           </a:p>
         </p:txBody>
@@ -1567,7 +1425,7 @@
           <a:lstStyle/>
           <a:p>
             <a:r>
-              <a:t>60 sec. Three rows only: Gemini (best, paid), Qwen (best open), and a published detector (high on our corpora, low on AI mail).</a:t>
+              <a:t>40 sec. Tell it as a story: we suspected our own good number, ran the obvious test, it said we were right to worry, then the proper paired test said otherwise. Report both.</a:t>
             </a:r>
           </a:p>
         </p:txBody>
@@ -4786,90 +4644,6 @@
       <p:pic>
         <p:nvPicPr>
           <p:cNvPr id="2" name="Picture 1" descr="slide_14.png"/>
-          <p:cNvPicPr>
-            <a:picLocks noChangeAspect="1"/>
-          </p:cNvPicPr>
-          <p:nvPr/>
-        </p:nvPicPr>
-        <p:blipFill>
-          <a:blip r:embed="rId2"/>
-          <a:stretch>
-            <a:fillRect/>
-          </a:stretch>
-        </p:blipFill>
-        <p:spPr>
-          <a:xfrm>
-            <a:off x="0" y="0"/>
-            <a:ext cx="12191695" cy="6858000"/>
-          </a:xfrm>
-          <a:prstGeom prst="rect">
-            <a:avLst/>
-          </a:prstGeom>
-        </p:spPr>
-      </p:pic>
-    </p:spTree>
-  </p:cSld>
-  <p:clrMapOvr>
-    <a:masterClrMapping/>
-  </p:clrMapOvr>
-</p:sld>
-</file>
-
-<file path=ppt/slides/slide15.xml><?xml version="1.0" encoding="utf-8"?>
-<p:sld xmlns:a="http://schemas.openxmlformats.org/drawingml/2006/main" xmlns:p="http://schemas.openxmlformats.org/presentationml/2006/main" xmlns:r="http://schemas.openxmlformats.org/officeDocument/2006/relationships">
-  <p:cSld>
-    <p:spTree>
-      <p:nvGrpSpPr>
-        <p:cNvPr id="1" name=""/>
-        <p:cNvGrpSpPr/>
-        <p:nvPr/>
-      </p:nvGrpSpPr>
-      <p:grpSpPr/>
-      <p:pic>
-        <p:nvPicPr>
-          <p:cNvPr id="2" name="Picture 1" descr="slide_15.png"/>
-          <p:cNvPicPr>
-            <a:picLocks noChangeAspect="1"/>
-          </p:cNvPicPr>
-          <p:nvPr/>
-        </p:nvPicPr>
-        <p:blipFill>
-          <a:blip r:embed="rId2"/>
-          <a:stretch>
-            <a:fillRect/>
-          </a:stretch>
-        </p:blipFill>
-        <p:spPr>
-          <a:xfrm>
-            <a:off x="0" y="0"/>
-            <a:ext cx="12191695" cy="6858000"/>
-          </a:xfrm>
-          <a:prstGeom prst="rect">
-            <a:avLst/>
-          </a:prstGeom>
-        </p:spPr>
-      </p:pic>
-    </p:spTree>
-  </p:cSld>
-  <p:clrMapOvr>
-    <a:masterClrMapping/>
-  </p:clrMapOvr>
-</p:sld>
-</file>
-
-<file path=ppt/slides/slide16.xml><?xml version="1.0" encoding="utf-8"?>
-<p:sld xmlns:a="http://schemas.openxmlformats.org/drawingml/2006/main" xmlns:p="http://schemas.openxmlformats.org/presentationml/2006/main" xmlns:r="http://schemas.openxmlformats.org/officeDocument/2006/relationships">
-  <p:cSld>
-    <p:spTree>
-      <p:nvGrpSpPr>
-        <p:cNvPr id="1" name=""/>
-        <p:cNvGrpSpPr/>
-        <p:nvPr/>
-      </p:nvGrpSpPr>
-      <p:grpSpPr/>
-      <p:pic>
-        <p:nvPicPr>
-          <p:cNvPr id="2" name="Picture 1" descr="slide_16.png"/>
           <p:cNvPicPr>
             <a:picLocks noChangeAspect="1"/>
           </p:cNvPicPr>

</xml_diff>